<commit_message>
Refresh slides with final SVG figures
</commit_message>
<xml_diff>
--- a/slides/FA24-BED-046.pptx
+++ b/slides/FA24-BED-046.pptx
@@ -193,7 +193,7 @@
             </a:lvl1pPr>
           </a:lstStyle>
           <a:p>
-            <a:fld id="{151E1F6D-14CB-4BC7-BD8A-7120A2078051}" type="datetimeFigureOut">
+            <a:fld id="{EFED064A-707A-4B4D-9314-C21163F5059B}" type="datetimeFigureOut">
               <a:rPr lang="en-PK" smtClean="0"/>
               <a:t>26/10/2026</a:t>
             </a:fld>
@@ -352,7 +352,7 @@
             </a:lvl1pPr>
           </a:lstStyle>
           <a:p>
-            <a:fld id="{84102BCB-10B9-44E1-A29D-B25289613390}" type="slidenum">
+            <a:fld id="{5217D443-F693-413D-B0FD-0B0A9BFF7ADA}" type="slidenum">
               <a:rPr lang="en-PK" smtClean="0"/>
               <a:t>‹#›</a:t>
             </a:fld>
@@ -363,7 +363,7 @@
     </p:spTree>
     <p:extLst>
       <p:ext uri="{BB962C8B-B14F-4D97-AF65-F5344CB8AC3E}">
-        <p14:creationId xmlns:p14="http://schemas.microsoft.com/office/powerpoint/2010/main" val="590962040"/>
+        <p14:creationId xmlns:p14="http://schemas.microsoft.com/office/powerpoint/2010/main" val="375702677"/>
       </p:ext>
     </p:extLst>
   </p:cSld>
@@ -530,7 +530,7 @@
           <a:bodyPr/>
           <a:lstStyle/>
           <a:p>
-            <a:fld id="{84102BCB-10B9-44E1-A29D-B25289613390}" type="slidenum">
+            <a:fld id="{5217D443-F693-413D-B0FD-0B0A9BFF7ADA}" type="slidenum">
               <a:rPr lang="en-PK" smtClean="0"/>
               <a:t>1</a:t>
             </a:fld>
@@ -541,7 +541,7 @@
     </p:spTree>
     <p:extLst>
       <p:ext uri="{BB962C8B-B14F-4D97-AF65-F5344CB8AC3E}">
-        <p14:creationId xmlns:p14="http://schemas.microsoft.com/office/powerpoint/2010/main" val="2800418420"/>
+        <p14:creationId xmlns:p14="http://schemas.microsoft.com/office/powerpoint/2010/main" val="3631444108"/>
       </p:ext>
     </p:extLst>
   </p:cSld>
@@ -618,7 +618,7 @@
           <a:bodyPr/>
           <a:lstStyle/>
           <a:p>
-            <a:fld id="{84102BCB-10B9-44E1-A29D-B25289613390}" type="slidenum">
+            <a:fld id="{5217D443-F693-413D-B0FD-0B0A9BFF7ADA}" type="slidenum">
               <a:rPr lang="en-PK" smtClean="0"/>
               <a:t>2</a:t>
             </a:fld>
@@ -629,7 +629,7 @@
     </p:spTree>
     <p:extLst>
       <p:ext uri="{BB962C8B-B14F-4D97-AF65-F5344CB8AC3E}">
-        <p14:creationId xmlns:p14="http://schemas.microsoft.com/office/powerpoint/2010/main" val="642829063"/>
+        <p14:creationId xmlns:p14="http://schemas.microsoft.com/office/powerpoint/2010/main" val="2067871549"/>
       </p:ext>
     </p:extLst>
   </p:cSld>
@@ -706,7 +706,7 @@
           <a:bodyPr/>
           <a:lstStyle/>
           <a:p>
-            <a:fld id="{84102BCB-10B9-44E1-A29D-B25289613390}" type="slidenum">
+            <a:fld id="{5217D443-F693-413D-B0FD-0B0A9BFF7ADA}" type="slidenum">
               <a:rPr lang="en-PK" smtClean="0"/>
               <a:t>3</a:t>
             </a:fld>
@@ -717,7 +717,7 @@
     </p:spTree>
     <p:extLst>
       <p:ext uri="{BB962C8B-B14F-4D97-AF65-F5344CB8AC3E}">
-        <p14:creationId xmlns:p14="http://schemas.microsoft.com/office/powerpoint/2010/main" val="802298954"/>
+        <p14:creationId xmlns:p14="http://schemas.microsoft.com/office/powerpoint/2010/main" val="1195439284"/>
       </p:ext>
     </p:extLst>
   </p:cSld>
@@ -794,7 +794,7 @@
           <a:bodyPr/>
           <a:lstStyle/>
           <a:p>
-            <a:fld id="{84102BCB-10B9-44E1-A29D-B25289613390}" type="slidenum">
+            <a:fld id="{5217D443-F693-413D-B0FD-0B0A9BFF7ADA}" type="slidenum">
               <a:rPr lang="en-PK" smtClean="0"/>
               <a:t>4</a:t>
             </a:fld>
@@ -805,7 +805,7 @@
     </p:spTree>
     <p:extLst>
       <p:ext uri="{BB962C8B-B14F-4D97-AF65-F5344CB8AC3E}">
-        <p14:creationId xmlns:p14="http://schemas.microsoft.com/office/powerpoint/2010/main" val="2861223638"/>
+        <p14:creationId xmlns:p14="http://schemas.microsoft.com/office/powerpoint/2010/main" val="1364855781"/>
       </p:ext>
     </p:extLst>
   </p:cSld>
@@ -837,7 +837,7 @@
           <p:cNvPr id="2" name="Title 1">
             <a:extLst>
               <a:ext uri="{FF2B5EF4-FFF2-40B4-BE49-F238E27FC236}">
-                <a16:creationId xmlns:a16="http://schemas.microsoft.com/office/drawing/2014/main" id="{01CD546F-61A3-BEDC-B100-AD519C4A65E8}"/>
+                <a16:creationId xmlns:a16="http://schemas.microsoft.com/office/drawing/2014/main" id="{161DA185-B5F9-17AF-92BF-DFE990611A25}"/>
               </a:ext>
             </a:extLst>
           </p:cNvPr>
@@ -875,7 +875,7 @@
           <p:cNvPr id="3" name="Subtitle 2">
             <a:extLst>
               <a:ext uri="{FF2B5EF4-FFF2-40B4-BE49-F238E27FC236}">
-                <a16:creationId xmlns:a16="http://schemas.microsoft.com/office/drawing/2014/main" id="{91906930-69CD-FE42-6C3A-DD8AA0F43986}"/>
+                <a16:creationId xmlns:a16="http://schemas.microsoft.com/office/drawing/2014/main" id="{C59A4C2D-FEBC-04F6-9924-AF5DBDFC11B7}"/>
               </a:ext>
             </a:extLst>
           </p:cNvPr>
@@ -946,7 +946,7 @@
           <p:cNvPr id="4" name="Date Placeholder 3">
             <a:extLst>
               <a:ext uri="{FF2B5EF4-FFF2-40B4-BE49-F238E27FC236}">
-                <a16:creationId xmlns:a16="http://schemas.microsoft.com/office/drawing/2014/main" id="{17D2ACB1-4A7A-0AAD-A7F8-354B7CA13050}"/>
+                <a16:creationId xmlns:a16="http://schemas.microsoft.com/office/drawing/2014/main" id="{437CC80B-39C9-38BE-97C1-255A70B4FB6C}"/>
               </a:ext>
             </a:extLst>
           </p:cNvPr>
@@ -962,7 +962,7 @@
           <a:bodyPr/>
           <a:lstStyle/>
           <a:p>
-            <a:fld id="{59F4FADE-CEBA-41DE-9B86-AE9226ABBE5E}" type="datetimeFigureOut">
+            <a:fld id="{187C6756-6102-4259-B40B-0718AF07DF35}" type="datetimeFigureOut">
               <a:rPr lang="en-PK" smtClean="0"/>
               <a:t>26/10/2026</a:t>
             </a:fld>
@@ -975,7 +975,7 @@
           <p:cNvPr id="5" name="Footer Placeholder 4">
             <a:extLst>
               <a:ext uri="{FF2B5EF4-FFF2-40B4-BE49-F238E27FC236}">
-                <a16:creationId xmlns:a16="http://schemas.microsoft.com/office/drawing/2014/main" id="{45566B6B-EEDC-4737-C78D-6DD532F6EF4A}"/>
+                <a16:creationId xmlns:a16="http://schemas.microsoft.com/office/drawing/2014/main" id="{9AEE888A-667F-B38E-9944-198E81A1B132}"/>
               </a:ext>
             </a:extLst>
           </p:cNvPr>
@@ -1000,7 +1000,7 @@
           <p:cNvPr id="6" name="Slide Number Placeholder 5">
             <a:extLst>
               <a:ext uri="{FF2B5EF4-FFF2-40B4-BE49-F238E27FC236}">
-                <a16:creationId xmlns:a16="http://schemas.microsoft.com/office/drawing/2014/main" id="{04013B45-5A95-37A5-E9EE-BFC6587C0E9C}"/>
+                <a16:creationId xmlns:a16="http://schemas.microsoft.com/office/drawing/2014/main" id="{13C6D513-EE62-04BF-0B44-6B0BECCF9326}"/>
               </a:ext>
             </a:extLst>
           </p:cNvPr>
@@ -1016,7 +1016,7 @@
           <a:bodyPr/>
           <a:lstStyle/>
           <a:p>
-            <a:fld id="{2B531DE8-2E3C-47B4-BCFD-D7BB0CA398CD}" type="slidenum">
+            <a:fld id="{64F069EE-6B3C-43A6-BA10-5D41419D3069}" type="slidenum">
               <a:rPr lang="en-PK" smtClean="0"/>
               <a:t>‹#›</a:t>
             </a:fld>
@@ -1027,7 +1027,7 @@
     </p:spTree>
     <p:extLst>
       <p:ext uri="{BB962C8B-B14F-4D97-AF65-F5344CB8AC3E}">
-        <p14:creationId xmlns:p14="http://schemas.microsoft.com/office/powerpoint/2010/main" val="145883705"/>
+        <p14:creationId xmlns:p14="http://schemas.microsoft.com/office/powerpoint/2010/main" val="623159226"/>
       </p:ext>
     </p:extLst>
   </p:cSld>
@@ -1059,7 +1059,7 @@
           <p:cNvPr id="2" name="Title 1">
             <a:extLst>
               <a:ext uri="{FF2B5EF4-FFF2-40B4-BE49-F238E27FC236}">
-                <a16:creationId xmlns:a16="http://schemas.microsoft.com/office/drawing/2014/main" id="{E73812D9-A543-0471-824F-6A6B4D057643}"/>
+                <a16:creationId xmlns:a16="http://schemas.microsoft.com/office/drawing/2014/main" id="{A8D7121A-7B85-FAD4-9FC7-7EE9CFFBB92F}"/>
               </a:ext>
             </a:extLst>
           </p:cNvPr>
@@ -1088,7 +1088,7 @@
           <p:cNvPr id="3" name="Vertical Text Placeholder 2">
             <a:extLst>
               <a:ext uri="{FF2B5EF4-FFF2-40B4-BE49-F238E27FC236}">
-                <a16:creationId xmlns:a16="http://schemas.microsoft.com/office/drawing/2014/main" id="{9281CB11-F6FC-E8BB-5F38-84D685E0AA96}"/>
+                <a16:creationId xmlns:a16="http://schemas.microsoft.com/office/drawing/2014/main" id="{89A08888-EBD9-56CC-D88C-555A12457BB0}"/>
               </a:ext>
             </a:extLst>
           </p:cNvPr>
@@ -1146,7 +1146,7 @@
           <p:cNvPr id="4" name="Date Placeholder 3">
             <a:extLst>
               <a:ext uri="{FF2B5EF4-FFF2-40B4-BE49-F238E27FC236}">
-                <a16:creationId xmlns:a16="http://schemas.microsoft.com/office/drawing/2014/main" id="{45661EF5-2A2D-B5EB-4AC8-A915C4485A2D}"/>
+                <a16:creationId xmlns:a16="http://schemas.microsoft.com/office/drawing/2014/main" id="{54356BE8-F4D9-D317-2305-E8118736E013}"/>
               </a:ext>
             </a:extLst>
           </p:cNvPr>
@@ -1162,7 +1162,7 @@
           <a:bodyPr/>
           <a:lstStyle/>
           <a:p>
-            <a:fld id="{59F4FADE-CEBA-41DE-9B86-AE9226ABBE5E}" type="datetimeFigureOut">
+            <a:fld id="{187C6756-6102-4259-B40B-0718AF07DF35}" type="datetimeFigureOut">
               <a:rPr lang="en-PK" smtClean="0"/>
               <a:t>26/10/2026</a:t>
             </a:fld>
@@ -1175,7 +1175,7 @@
           <p:cNvPr id="5" name="Footer Placeholder 4">
             <a:extLst>
               <a:ext uri="{FF2B5EF4-FFF2-40B4-BE49-F238E27FC236}">
-                <a16:creationId xmlns:a16="http://schemas.microsoft.com/office/drawing/2014/main" id="{21D1C7FA-CC0F-DDB0-857B-CC656CEDBECE}"/>
+                <a16:creationId xmlns:a16="http://schemas.microsoft.com/office/drawing/2014/main" id="{2BFE0954-35DD-15AC-4C53-1EE9152FAB24}"/>
               </a:ext>
             </a:extLst>
           </p:cNvPr>
@@ -1200,7 +1200,7 @@
           <p:cNvPr id="6" name="Slide Number Placeholder 5">
             <a:extLst>
               <a:ext uri="{FF2B5EF4-FFF2-40B4-BE49-F238E27FC236}">
-                <a16:creationId xmlns:a16="http://schemas.microsoft.com/office/drawing/2014/main" id="{FC6CF7D3-DD0C-85D1-455C-3A441C7A68F2}"/>
+                <a16:creationId xmlns:a16="http://schemas.microsoft.com/office/drawing/2014/main" id="{449F0FA2-CB36-5033-F957-D5C61F1B1DAC}"/>
               </a:ext>
             </a:extLst>
           </p:cNvPr>
@@ -1216,7 +1216,7 @@
           <a:bodyPr/>
           <a:lstStyle/>
           <a:p>
-            <a:fld id="{2B531DE8-2E3C-47B4-BCFD-D7BB0CA398CD}" type="slidenum">
+            <a:fld id="{64F069EE-6B3C-43A6-BA10-5D41419D3069}" type="slidenum">
               <a:rPr lang="en-PK" smtClean="0"/>
               <a:t>‹#›</a:t>
             </a:fld>
@@ -1227,7 +1227,7 @@
     </p:spTree>
     <p:extLst>
       <p:ext uri="{BB962C8B-B14F-4D97-AF65-F5344CB8AC3E}">
-        <p14:creationId xmlns:p14="http://schemas.microsoft.com/office/powerpoint/2010/main" val="3333688064"/>
+        <p14:creationId xmlns:p14="http://schemas.microsoft.com/office/powerpoint/2010/main" val="717069895"/>
       </p:ext>
     </p:extLst>
   </p:cSld>
@@ -1259,7 +1259,7 @@
           <p:cNvPr id="2" name="Vertical Title 1">
             <a:extLst>
               <a:ext uri="{FF2B5EF4-FFF2-40B4-BE49-F238E27FC236}">
-                <a16:creationId xmlns:a16="http://schemas.microsoft.com/office/drawing/2014/main" id="{B2C23FF3-29DD-4DCC-69C8-C772369513A1}"/>
+                <a16:creationId xmlns:a16="http://schemas.microsoft.com/office/drawing/2014/main" id="{5D1A27AD-9645-8072-C9BA-891B7BA5BB47}"/>
               </a:ext>
             </a:extLst>
           </p:cNvPr>
@@ -1293,7 +1293,7 @@
           <p:cNvPr id="3" name="Vertical Text Placeholder 2">
             <a:extLst>
               <a:ext uri="{FF2B5EF4-FFF2-40B4-BE49-F238E27FC236}">
-                <a16:creationId xmlns:a16="http://schemas.microsoft.com/office/drawing/2014/main" id="{4D47C7FE-13C0-A1F9-910E-57925AC6159F}"/>
+                <a16:creationId xmlns:a16="http://schemas.microsoft.com/office/drawing/2014/main" id="{86E36AB0-8575-3D1E-A554-E3DE7998EE56}"/>
               </a:ext>
             </a:extLst>
           </p:cNvPr>
@@ -1356,7 +1356,7 @@
           <p:cNvPr id="4" name="Date Placeholder 3">
             <a:extLst>
               <a:ext uri="{FF2B5EF4-FFF2-40B4-BE49-F238E27FC236}">
-                <a16:creationId xmlns:a16="http://schemas.microsoft.com/office/drawing/2014/main" id="{79B9509D-45AD-EEA7-8C66-6765C2DA7C68}"/>
+                <a16:creationId xmlns:a16="http://schemas.microsoft.com/office/drawing/2014/main" id="{6CF958C1-1D4C-A6CF-9599-615150B10A1B}"/>
               </a:ext>
             </a:extLst>
           </p:cNvPr>
@@ -1372,7 +1372,7 @@
           <a:bodyPr/>
           <a:lstStyle/>
           <a:p>
-            <a:fld id="{59F4FADE-CEBA-41DE-9B86-AE9226ABBE5E}" type="datetimeFigureOut">
+            <a:fld id="{187C6756-6102-4259-B40B-0718AF07DF35}" type="datetimeFigureOut">
               <a:rPr lang="en-PK" smtClean="0"/>
               <a:t>26/10/2026</a:t>
             </a:fld>
@@ -1385,7 +1385,7 @@
           <p:cNvPr id="5" name="Footer Placeholder 4">
             <a:extLst>
               <a:ext uri="{FF2B5EF4-FFF2-40B4-BE49-F238E27FC236}">
-                <a16:creationId xmlns:a16="http://schemas.microsoft.com/office/drawing/2014/main" id="{26093DBE-784C-B281-8F06-D0E8AA510533}"/>
+                <a16:creationId xmlns:a16="http://schemas.microsoft.com/office/drawing/2014/main" id="{8CBF69DF-2FF5-ACD9-D330-4D9781DAFB0C}"/>
               </a:ext>
             </a:extLst>
           </p:cNvPr>
@@ -1410,7 +1410,7 @@
           <p:cNvPr id="6" name="Slide Number Placeholder 5">
             <a:extLst>
               <a:ext uri="{FF2B5EF4-FFF2-40B4-BE49-F238E27FC236}">
-                <a16:creationId xmlns:a16="http://schemas.microsoft.com/office/drawing/2014/main" id="{34FA391E-F23A-5865-4100-A571729A0C04}"/>
+                <a16:creationId xmlns:a16="http://schemas.microsoft.com/office/drawing/2014/main" id="{081E7884-49C2-592C-8B18-BB748EFCE0C1}"/>
               </a:ext>
             </a:extLst>
           </p:cNvPr>
@@ -1426,7 +1426,7 @@
           <a:bodyPr/>
           <a:lstStyle/>
           <a:p>
-            <a:fld id="{2B531DE8-2E3C-47B4-BCFD-D7BB0CA398CD}" type="slidenum">
+            <a:fld id="{64F069EE-6B3C-43A6-BA10-5D41419D3069}" type="slidenum">
               <a:rPr lang="en-PK" smtClean="0"/>
               <a:t>‹#›</a:t>
             </a:fld>
@@ -1437,7 +1437,7 @@
     </p:spTree>
     <p:extLst>
       <p:ext uri="{BB962C8B-B14F-4D97-AF65-F5344CB8AC3E}">
-        <p14:creationId xmlns:p14="http://schemas.microsoft.com/office/powerpoint/2010/main" val="3343327698"/>
+        <p14:creationId xmlns:p14="http://schemas.microsoft.com/office/powerpoint/2010/main" val="2755399582"/>
       </p:ext>
     </p:extLst>
   </p:cSld>
@@ -1469,7 +1469,7 @@
           <p:cNvPr id="2" name="Title 1">
             <a:extLst>
               <a:ext uri="{FF2B5EF4-FFF2-40B4-BE49-F238E27FC236}">
-                <a16:creationId xmlns:a16="http://schemas.microsoft.com/office/drawing/2014/main" id="{F0988B06-2588-328A-B08E-240D27E5A123}"/>
+                <a16:creationId xmlns:a16="http://schemas.microsoft.com/office/drawing/2014/main" id="{D2212DD9-CBD0-A137-F1AD-EFDA738EA241}"/>
               </a:ext>
             </a:extLst>
           </p:cNvPr>
@@ -1498,7 +1498,7 @@
           <p:cNvPr id="3" name="Content Placeholder 2">
             <a:extLst>
               <a:ext uri="{FF2B5EF4-FFF2-40B4-BE49-F238E27FC236}">
-                <a16:creationId xmlns:a16="http://schemas.microsoft.com/office/drawing/2014/main" id="{F0596B74-F8F6-7647-F546-33D3046AAE13}"/>
+                <a16:creationId xmlns:a16="http://schemas.microsoft.com/office/drawing/2014/main" id="{2E847E44-C3A9-3B2A-592F-E2EE27273A34}"/>
               </a:ext>
             </a:extLst>
           </p:cNvPr>
@@ -1556,7 +1556,7 @@
           <p:cNvPr id="4" name="Date Placeholder 3">
             <a:extLst>
               <a:ext uri="{FF2B5EF4-FFF2-40B4-BE49-F238E27FC236}">
-                <a16:creationId xmlns:a16="http://schemas.microsoft.com/office/drawing/2014/main" id="{CD91A821-A471-BEAA-A3F7-CABD773CC115}"/>
+                <a16:creationId xmlns:a16="http://schemas.microsoft.com/office/drawing/2014/main" id="{337EA09E-4BF7-9138-A9FF-6793AB733103}"/>
               </a:ext>
             </a:extLst>
           </p:cNvPr>
@@ -1572,7 +1572,7 @@
           <a:bodyPr/>
           <a:lstStyle/>
           <a:p>
-            <a:fld id="{59F4FADE-CEBA-41DE-9B86-AE9226ABBE5E}" type="datetimeFigureOut">
+            <a:fld id="{187C6756-6102-4259-B40B-0718AF07DF35}" type="datetimeFigureOut">
               <a:rPr lang="en-PK" smtClean="0"/>
               <a:t>26/10/2026</a:t>
             </a:fld>
@@ -1585,7 +1585,7 @@
           <p:cNvPr id="5" name="Footer Placeholder 4">
             <a:extLst>
               <a:ext uri="{FF2B5EF4-FFF2-40B4-BE49-F238E27FC236}">
-                <a16:creationId xmlns:a16="http://schemas.microsoft.com/office/drawing/2014/main" id="{B6383AD3-2AD7-7D3F-CB45-21C539413B33}"/>
+                <a16:creationId xmlns:a16="http://schemas.microsoft.com/office/drawing/2014/main" id="{288DE42F-F6F4-5B62-76D2-A714224BE366}"/>
               </a:ext>
             </a:extLst>
           </p:cNvPr>
@@ -1610,7 +1610,7 @@
           <p:cNvPr id="6" name="Slide Number Placeholder 5">
             <a:extLst>
               <a:ext uri="{FF2B5EF4-FFF2-40B4-BE49-F238E27FC236}">
-                <a16:creationId xmlns:a16="http://schemas.microsoft.com/office/drawing/2014/main" id="{D1456727-7AED-E7DF-2221-D9B5307E1029}"/>
+                <a16:creationId xmlns:a16="http://schemas.microsoft.com/office/drawing/2014/main" id="{BDE42766-1D78-5DA5-C461-006502278CCA}"/>
               </a:ext>
             </a:extLst>
           </p:cNvPr>
@@ -1626,7 +1626,7 @@
           <a:bodyPr/>
           <a:lstStyle/>
           <a:p>
-            <a:fld id="{2B531DE8-2E3C-47B4-BCFD-D7BB0CA398CD}" type="slidenum">
+            <a:fld id="{64F069EE-6B3C-43A6-BA10-5D41419D3069}" type="slidenum">
               <a:rPr lang="en-PK" smtClean="0"/>
               <a:t>‹#›</a:t>
             </a:fld>
@@ -1637,7 +1637,7 @@
     </p:spTree>
     <p:extLst>
       <p:ext uri="{BB962C8B-B14F-4D97-AF65-F5344CB8AC3E}">
-        <p14:creationId xmlns:p14="http://schemas.microsoft.com/office/powerpoint/2010/main" val="2198560695"/>
+        <p14:creationId xmlns:p14="http://schemas.microsoft.com/office/powerpoint/2010/main" val="900979404"/>
       </p:ext>
     </p:extLst>
   </p:cSld>
@@ -1669,7 +1669,7 @@
           <p:cNvPr id="2" name="Title 1">
             <a:extLst>
               <a:ext uri="{FF2B5EF4-FFF2-40B4-BE49-F238E27FC236}">
-                <a16:creationId xmlns:a16="http://schemas.microsoft.com/office/drawing/2014/main" id="{DB4E7FA8-95C9-8AC6-2E1A-694A5553695F}"/>
+                <a16:creationId xmlns:a16="http://schemas.microsoft.com/office/drawing/2014/main" id="{869F54E2-F7B6-005C-FA6A-97C25F5E315D}"/>
               </a:ext>
             </a:extLst>
           </p:cNvPr>
@@ -1707,7 +1707,7 @@
           <p:cNvPr id="3" name="Text Placeholder 2">
             <a:extLst>
               <a:ext uri="{FF2B5EF4-FFF2-40B4-BE49-F238E27FC236}">
-                <a16:creationId xmlns:a16="http://schemas.microsoft.com/office/drawing/2014/main" id="{BD13D5F1-AAA3-E7C7-E5CE-EBBB82984B05}"/>
+                <a16:creationId xmlns:a16="http://schemas.microsoft.com/office/drawing/2014/main" id="{1242E04D-68FA-D5C0-56CC-803560AC2957}"/>
               </a:ext>
             </a:extLst>
           </p:cNvPr>
@@ -1832,7 +1832,7 @@
           <p:cNvPr id="4" name="Date Placeholder 3">
             <a:extLst>
               <a:ext uri="{FF2B5EF4-FFF2-40B4-BE49-F238E27FC236}">
-                <a16:creationId xmlns:a16="http://schemas.microsoft.com/office/drawing/2014/main" id="{20C16CB8-47BA-4F22-A96F-62B87EE091D4}"/>
+                <a16:creationId xmlns:a16="http://schemas.microsoft.com/office/drawing/2014/main" id="{576FE50A-B86D-575A-DE19-7863FBEBF0D1}"/>
               </a:ext>
             </a:extLst>
           </p:cNvPr>
@@ -1848,7 +1848,7 @@
           <a:bodyPr/>
           <a:lstStyle/>
           <a:p>
-            <a:fld id="{59F4FADE-CEBA-41DE-9B86-AE9226ABBE5E}" type="datetimeFigureOut">
+            <a:fld id="{187C6756-6102-4259-B40B-0718AF07DF35}" type="datetimeFigureOut">
               <a:rPr lang="en-PK" smtClean="0"/>
               <a:t>26/10/2026</a:t>
             </a:fld>
@@ -1861,7 +1861,7 @@
           <p:cNvPr id="5" name="Footer Placeholder 4">
             <a:extLst>
               <a:ext uri="{FF2B5EF4-FFF2-40B4-BE49-F238E27FC236}">
-                <a16:creationId xmlns:a16="http://schemas.microsoft.com/office/drawing/2014/main" id="{72D6BEA2-9B81-1409-B2B5-C3B44091862B}"/>
+                <a16:creationId xmlns:a16="http://schemas.microsoft.com/office/drawing/2014/main" id="{0AA2670E-D1FD-E09D-A5F4-95CE1E1C91AF}"/>
               </a:ext>
             </a:extLst>
           </p:cNvPr>
@@ -1886,7 +1886,7 @@
           <p:cNvPr id="6" name="Slide Number Placeholder 5">
             <a:extLst>
               <a:ext uri="{FF2B5EF4-FFF2-40B4-BE49-F238E27FC236}">
-                <a16:creationId xmlns:a16="http://schemas.microsoft.com/office/drawing/2014/main" id="{192DA5B1-40C2-EE8C-A90C-24B72C213DF6}"/>
+                <a16:creationId xmlns:a16="http://schemas.microsoft.com/office/drawing/2014/main" id="{2112146A-53E6-DEBE-4E9A-F52402CE3234}"/>
               </a:ext>
             </a:extLst>
           </p:cNvPr>
@@ -1902,7 +1902,7 @@
           <a:bodyPr/>
           <a:lstStyle/>
           <a:p>
-            <a:fld id="{2B531DE8-2E3C-47B4-BCFD-D7BB0CA398CD}" type="slidenum">
+            <a:fld id="{64F069EE-6B3C-43A6-BA10-5D41419D3069}" type="slidenum">
               <a:rPr lang="en-PK" smtClean="0"/>
               <a:t>‹#›</a:t>
             </a:fld>
@@ -1913,7 +1913,7 @@
     </p:spTree>
     <p:extLst>
       <p:ext uri="{BB962C8B-B14F-4D97-AF65-F5344CB8AC3E}">
-        <p14:creationId xmlns:p14="http://schemas.microsoft.com/office/powerpoint/2010/main" val="3411687362"/>
+        <p14:creationId xmlns:p14="http://schemas.microsoft.com/office/powerpoint/2010/main" val="311571372"/>
       </p:ext>
     </p:extLst>
   </p:cSld>
@@ -1945,7 +1945,7 @@
           <p:cNvPr id="2" name="Title 1">
             <a:extLst>
               <a:ext uri="{FF2B5EF4-FFF2-40B4-BE49-F238E27FC236}">
-                <a16:creationId xmlns:a16="http://schemas.microsoft.com/office/drawing/2014/main" id="{223D3C7B-7E9A-6361-D54D-F17F7357BF46}"/>
+                <a16:creationId xmlns:a16="http://schemas.microsoft.com/office/drawing/2014/main" id="{A70D58D9-65B2-51F2-A4C8-47ADC6FF34B7}"/>
               </a:ext>
             </a:extLst>
           </p:cNvPr>
@@ -1974,7 +1974,7 @@
           <p:cNvPr id="3" name="Content Placeholder 2">
             <a:extLst>
               <a:ext uri="{FF2B5EF4-FFF2-40B4-BE49-F238E27FC236}">
-                <a16:creationId xmlns:a16="http://schemas.microsoft.com/office/drawing/2014/main" id="{637143C3-293F-6DD1-1D07-DB369547067B}"/>
+                <a16:creationId xmlns:a16="http://schemas.microsoft.com/office/drawing/2014/main" id="{2AE24E67-560A-A8B9-ECA5-EB089A2E3AB9}"/>
               </a:ext>
             </a:extLst>
           </p:cNvPr>
@@ -2037,7 +2037,7 @@
           <p:cNvPr id="4" name="Content Placeholder 3">
             <a:extLst>
               <a:ext uri="{FF2B5EF4-FFF2-40B4-BE49-F238E27FC236}">
-                <a16:creationId xmlns:a16="http://schemas.microsoft.com/office/drawing/2014/main" id="{23F0FF1C-F709-16A7-47A2-A3591FD7C484}"/>
+                <a16:creationId xmlns:a16="http://schemas.microsoft.com/office/drawing/2014/main" id="{15077557-2EB0-0AEB-55B0-11FC1CF0CE6B}"/>
               </a:ext>
             </a:extLst>
           </p:cNvPr>
@@ -2100,7 +2100,7 @@
           <p:cNvPr id="5" name="Date Placeholder 4">
             <a:extLst>
               <a:ext uri="{FF2B5EF4-FFF2-40B4-BE49-F238E27FC236}">
-                <a16:creationId xmlns:a16="http://schemas.microsoft.com/office/drawing/2014/main" id="{FDAC01C2-F53E-53F9-635C-30F940DFC0BD}"/>
+                <a16:creationId xmlns:a16="http://schemas.microsoft.com/office/drawing/2014/main" id="{DA2F1DA9-B99A-A1AA-DE36-B95B9C5AA9B7}"/>
               </a:ext>
             </a:extLst>
           </p:cNvPr>
@@ -2116,7 +2116,7 @@
           <a:bodyPr/>
           <a:lstStyle/>
           <a:p>
-            <a:fld id="{59F4FADE-CEBA-41DE-9B86-AE9226ABBE5E}" type="datetimeFigureOut">
+            <a:fld id="{187C6756-6102-4259-B40B-0718AF07DF35}" type="datetimeFigureOut">
               <a:rPr lang="en-PK" smtClean="0"/>
               <a:t>26/10/2026</a:t>
             </a:fld>
@@ -2129,7 +2129,7 @@
           <p:cNvPr id="6" name="Footer Placeholder 5">
             <a:extLst>
               <a:ext uri="{FF2B5EF4-FFF2-40B4-BE49-F238E27FC236}">
-                <a16:creationId xmlns:a16="http://schemas.microsoft.com/office/drawing/2014/main" id="{7CF6BCD7-8C18-1CCA-1085-4B86D4A29A14}"/>
+                <a16:creationId xmlns:a16="http://schemas.microsoft.com/office/drawing/2014/main" id="{6D12DDD4-22E9-A086-FB8B-713ACD877320}"/>
               </a:ext>
             </a:extLst>
           </p:cNvPr>
@@ -2154,7 +2154,7 @@
           <p:cNvPr id="7" name="Slide Number Placeholder 6">
             <a:extLst>
               <a:ext uri="{FF2B5EF4-FFF2-40B4-BE49-F238E27FC236}">
-                <a16:creationId xmlns:a16="http://schemas.microsoft.com/office/drawing/2014/main" id="{47DA659D-E23B-7418-D076-CDD39DF47C8C}"/>
+                <a16:creationId xmlns:a16="http://schemas.microsoft.com/office/drawing/2014/main" id="{BF1DD6FE-A843-FE04-6F41-208D727C8D3D}"/>
               </a:ext>
             </a:extLst>
           </p:cNvPr>
@@ -2170,7 +2170,7 @@
           <a:bodyPr/>
           <a:lstStyle/>
           <a:p>
-            <a:fld id="{2B531DE8-2E3C-47B4-BCFD-D7BB0CA398CD}" type="slidenum">
+            <a:fld id="{64F069EE-6B3C-43A6-BA10-5D41419D3069}" type="slidenum">
               <a:rPr lang="en-PK" smtClean="0"/>
               <a:t>‹#›</a:t>
             </a:fld>
@@ -2181,7 +2181,7 @@
     </p:spTree>
     <p:extLst>
       <p:ext uri="{BB962C8B-B14F-4D97-AF65-F5344CB8AC3E}">
-        <p14:creationId xmlns:p14="http://schemas.microsoft.com/office/powerpoint/2010/main" val="4275051081"/>
+        <p14:creationId xmlns:p14="http://schemas.microsoft.com/office/powerpoint/2010/main" val="846223103"/>
       </p:ext>
     </p:extLst>
   </p:cSld>
@@ -2213,7 +2213,7 @@
           <p:cNvPr id="2" name="Title 1">
             <a:extLst>
               <a:ext uri="{FF2B5EF4-FFF2-40B4-BE49-F238E27FC236}">
-                <a16:creationId xmlns:a16="http://schemas.microsoft.com/office/drawing/2014/main" id="{4996F96C-C477-1481-4486-883EFF9AA1B9}"/>
+                <a16:creationId xmlns:a16="http://schemas.microsoft.com/office/drawing/2014/main" id="{6502574D-9A8B-3528-BA02-B1F0D830E832}"/>
               </a:ext>
             </a:extLst>
           </p:cNvPr>
@@ -2247,7 +2247,7 @@
           <p:cNvPr id="3" name="Text Placeholder 2">
             <a:extLst>
               <a:ext uri="{FF2B5EF4-FFF2-40B4-BE49-F238E27FC236}">
-                <a16:creationId xmlns:a16="http://schemas.microsoft.com/office/drawing/2014/main" id="{4AF269D6-0AB8-1ACC-5D54-335F79798019}"/>
+                <a16:creationId xmlns:a16="http://schemas.microsoft.com/office/drawing/2014/main" id="{5D328A40-7BFD-FB69-372F-A8AB39C9800B}"/>
               </a:ext>
             </a:extLst>
           </p:cNvPr>
@@ -2318,7 +2318,7 @@
           <p:cNvPr id="4" name="Content Placeholder 3">
             <a:extLst>
               <a:ext uri="{FF2B5EF4-FFF2-40B4-BE49-F238E27FC236}">
-                <a16:creationId xmlns:a16="http://schemas.microsoft.com/office/drawing/2014/main" id="{F74819A6-FBC8-DA29-5F3F-E36D832252E8}"/>
+                <a16:creationId xmlns:a16="http://schemas.microsoft.com/office/drawing/2014/main" id="{3D0983DA-2616-EA03-1770-B164E0382814}"/>
               </a:ext>
             </a:extLst>
           </p:cNvPr>
@@ -2381,7 +2381,7 @@
           <p:cNvPr id="5" name="Text Placeholder 4">
             <a:extLst>
               <a:ext uri="{FF2B5EF4-FFF2-40B4-BE49-F238E27FC236}">
-                <a16:creationId xmlns:a16="http://schemas.microsoft.com/office/drawing/2014/main" id="{85040B92-E3F1-2272-AE70-38B80BB278E5}"/>
+                <a16:creationId xmlns:a16="http://schemas.microsoft.com/office/drawing/2014/main" id="{2E218483-74AC-3806-60D3-E18F15261868}"/>
               </a:ext>
             </a:extLst>
           </p:cNvPr>
@@ -2452,7 +2452,7 @@
           <p:cNvPr id="6" name="Content Placeholder 5">
             <a:extLst>
               <a:ext uri="{FF2B5EF4-FFF2-40B4-BE49-F238E27FC236}">
-                <a16:creationId xmlns:a16="http://schemas.microsoft.com/office/drawing/2014/main" id="{A5E1F80F-958F-A2C5-8B6E-BF27B421F74F}"/>
+                <a16:creationId xmlns:a16="http://schemas.microsoft.com/office/drawing/2014/main" id="{E33BB180-9CF5-8DFC-06C1-01E98DC5D39B}"/>
               </a:ext>
             </a:extLst>
           </p:cNvPr>
@@ -2515,7 +2515,7 @@
           <p:cNvPr id="7" name="Date Placeholder 6">
             <a:extLst>
               <a:ext uri="{FF2B5EF4-FFF2-40B4-BE49-F238E27FC236}">
-                <a16:creationId xmlns:a16="http://schemas.microsoft.com/office/drawing/2014/main" id="{DF244045-B6F6-0D10-896E-6AF7453E8E7C}"/>
+                <a16:creationId xmlns:a16="http://schemas.microsoft.com/office/drawing/2014/main" id="{2CEC0C2F-431B-C2B2-5C8D-3BA0674839E4}"/>
               </a:ext>
             </a:extLst>
           </p:cNvPr>
@@ -2531,7 +2531,7 @@
           <a:bodyPr/>
           <a:lstStyle/>
           <a:p>
-            <a:fld id="{59F4FADE-CEBA-41DE-9B86-AE9226ABBE5E}" type="datetimeFigureOut">
+            <a:fld id="{187C6756-6102-4259-B40B-0718AF07DF35}" type="datetimeFigureOut">
               <a:rPr lang="en-PK" smtClean="0"/>
               <a:t>26/10/2026</a:t>
             </a:fld>
@@ -2544,7 +2544,7 @@
           <p:cNvPr id="8" name="Footer Placeholder 7">
             <a:extLst>
               <a:ext uri="{FF2B5EF4-FFF2-40B4-BE49-F238E27FC236}">
-                <a16:creationId xmlns:a16="http://schemas.microsoft.com/office/drawing/2014/main" id="{17C5D149-3006-E999-B442-07E41B8465EC}"/>
+                <a16:creationId xmlns:a16="http://schemas.microsoft.com/office/drawing/2014/main" id="{1DADDB03-5491-9E0D-87BB-FC750BC2384B}"/>
               </a:ext>
             </a:extLst>
           </p:cNvPr>
@@ -2569,7 +2569,7 @@
           <p:cNvPr id="9" name="Slide Number Placeholder 8">
             <a:extLst>
               <a:ext uri="{FF2B5EF4-FFF2-40B4-BE49-F238E27FC236}">
-                <a16:creationId xmlns:a16="http://schemas.microsoft.com/office/drawing/2014/main" id="{433F795D-E1A8-7DC1-98B3-3C1818B75A9C}"/>
+                <a16:creationId xmlns:a16="http://schemas.microsoft.com/office/drawing/2014/main" id="{28C2EAB3-46AC-8676-B45E-CC8EFE848C17}"/>
               </a:ext>
             </a:extLst>
           </p:cNvPr>
@@ -2585,7 +2585,7 @@
           <a:bodyPr/>
           <a:lstStyle/>
           <a:p>
-            <a:fld id="{2B531DE8-2E3C-47B4-BCFD-D7BB0CA398CD}" type="slidenum">
+            <a:fld id="{64F069EE-6B3C-43A6-BA10-5D41419D3069}" type="slidenum">
               <a:rPr lang="en-PK" smtClean="0"/>
               <a:t>‹#›</a:t>
             </a:fld>
@@ -2596,7 +2596,7 @@
     </p:spTree>
     <p:extLst>
       <p:ext uri="{BB962C8B-B14F-4D97-AF65-F5344CB8AC3E}">
-        <p14:creationId xmlns:p14="http://schemas.microsoft.com/office/powerpoint/2010/main" val="1013095383"/>
+        <p14:creationId xmlns:p14="http://schemas.microsoft.com/office/powerpoint/2010/main" val="1895751438"/>
       </p:ext>
     </p:extLst>
   </p:cSld>
@@ -2628,7 +2628,7 @@
           <p:cNvPr id="2" name="Title 1">
             <a:extLst>
               <a:ext uri="{FF2B5EF4-FFF2-40B4-BE49-F238E27FC236}">
-                <a16:creationId xmlns:a16="http://schemas.microsoft.com/office/drawing/2014/main" id="{3B78D064-819B-B3CB-C0D9-D3E6EE3C9073}"/>
+                <a16:creationId xmlns:a16="http://schemas.microsoft.com/office/drawing/2014/main" id="{AE2CCDAC-6B23-FE18-4405-0A5B424A6CFA}"/>
               </a:ext>
             </a:extLst>
           </p:cNvPr>
@@ -2657,7 +2657,7 @@
           <p:cNvPr id="3" name="Date Placeholder 2">
             <a:extLst>
               <a:ext uri="{FF2B5EF4-FFF2-40B4-BE49-F238E27FC236}">
-                <a16:creationId xmlns:a16="http://schemas.microsoft.com/office/drawing/2014/main" id="{A68951BF-B0A0-9660-49CD-F498C64655ED}"/>
+                <a16:creationId xmlns:a16="http://schemas.microsoft.com/office/drawing/2014/main" id="{6B1B4541-FCB5-B062-E8C8-8365EC976465}"/>
               </a:ext>
             </a:extLst>
           </p:cNvPr>
@@ -2673,7 +2673,7 @@
           <a:bodyPr/>
           <a:lstStyle/>
           <a:p>
-            <a:fld id="{59F4FADE-CEBA-41DE-9B86-AE9226ABBE5E}" type="datetimeFigureOut">
+            <a:fld id="{187C6756-6102-4259-B40B-0718AF07DF35}" type="datetimeFigureOut">
               <a:rPr lang="en-PK" smtClean="0"/>
               <a:t>26/10/2026</a:t>
             </a:fld>
@@ -2686,7 +2686,7 @@
           <p:cNvPr id="4" name="Footer Placeholder 3">
             <a:extLst>
               <a:ext uri="{FF2B5EF4-FFF2-40B4-BE49-F238E27FC236}">
-                <a16:creationId xmlns:a16="http://schemas.microsoft.com/office/drawing/2014/main" id="{57864AF3-BAC4-ACDD-F1FB-5A44C79360C4}"/>
+                <a16:creationId xmlns:a16="http://schemas.microsoft.com/office/drawing/2014/main" id="{B8F74ECD-769E-B9FC-9D8B-FF8DC3A61FEC}"/>
               </a:ext>
             </a:extLst>
           </p:cNvPr>
@@ -2711,7 +2711,7 @@
           <p:cNvPr id="5" name="Slide Number Placeholder 4">
             <a:extLst>
               <a:ext uri="{FF2B5EF4-FFF2-40B4-BE49-F238E27FC236}">
-                <a16:creationId xmlns:a16="http://schemas.microsoft.com/office/drawing/2014/main" id="{286EBAB0-3085-1E63-CC64-400043F0A689}"/>
+                <a16:creationId xmlns:a16="http://schemas.microsoft.com/office/drawing/2014/main" id="{2F82BAE1-C0FD-BC6B-8DD3-9E962070CD7F}"/>
               </a:ext>
             </a:extLst>
           </p:cNvPr>
@@ -2727,7 +2727,7 @@
           <a:bodyPr/>
           <a:lstStyle/>
           <a:p>
-            <a:fld id="{2B531DE8-2E3C-47B4-BCFD-D7BB0CA398CD}" type="slidenum">
+            <a:fld id="{64F069EE-6B3C-43A6-BA10-5D41419D3069}" type="slidenum">
               <a:rPr lang="en-PK" smtClean="0"/>
               <a:t>‹#›</a:t>
             </a:fld>
@@ -2738,7 +2738,7 @@
     </p:spTree>
     <p:extLst>
       <p:ext uri="{BB962C8B-B14F-4D97-AF65-F5344CB8AC3E}">
-        <p14:creationId xmlns:p14="http://schemas.microsoft.com/office/powerpoint/2010/main" val="1528058628"/>
+        <p14:creationId xmlns:p14="http://schemas.microsoft.com/office/powerpoint/2010/main" val="2655407442"/>
       </p:ext>
     </p:extLst>
   </p:cSld>
@@ -2770,7 +2770,7 @@
           <p:cNvPr id="2" name="Date Placeholder 1">
             <a:extLst>
               <a:ext uri="{FF2B5EF4-FFF2-40B4-BE49-F238E27FC236}">
-                <a16:creationId xmlns:a16="http://schemas.microsoft.com/office/drawing/2014/main" id="{A776CB47-1F3F-0AFB-C6D3-C11C51D523A6}"/>
+                <a16:creationId xmlns:a16="http://schemas.microsoft.com/office/drawing/2014/main" id="{88DBA29D-AE53-2467-EB82-DC4212B168F2}"/>
               </a:ext>
             </a:extLst>
           </p:cNvPr>
@@ -2786,7 +2786,7 @@
           <a:bodyPr/>
           <a:lstStyle/>
           <a:p>
-            <a:fld id="{59F4FADE-CEBA-41DE-9B86-AE9226ABBE5E}" type="datetimeFigureOut">
+            <a:fld id="{187C6756-6102-4259-B40B-0718AF07DF35}" type="datetimeFigureOut">
               <a:rPr lang="en-PK" smtClean="0"/>
               <a:t>26/10/2026</a:t>
             </a:fld>
@@ -2799,7 +2799,7 @@
           <p:cNvPr id="3" name="Footer Placeholder 2">
             <a:extLst>
               <a:ext uri="{FF2B5EF4-FFF2-40B4-BE49-F238E27FC236}">
-                <a16:creationId xmlns:a16="http://schemas.microsoft.com/office/drawing/2014/main" id="{27AA645A-4E12-DD01-37A7-5F48045EB8E2}"/>
+                <a16:creationId xmlns:a16="http://schemas.microsoft.com/office/drawing/2014/main" id="{FB9872CC-910B-150A-1431-B0E9F3EDAE17}"/>
               </a:ext>
             </a:extLst>
           </p:cNvPr>
@@ -2824,7 +2824,7 @@
           <p:cNvPr id="4" name="Slide Number Placeholder 3">
             <a:extLst>
               <a:ext uri="{FF2B5EF4-FFF2-40B4-BE49-F238E27FC236}">
-                <a16:creationId xmlns:a16="http://schemas.microsoft.com/office/drawing/2014/main" id="{72A499F9-CB70-1540-A6F8-9FB061055EE1}"/>
+                <a16:creationId xmlns:a16="http://schemas.microsoft.com/office/drawing/2014/main" id="{BD47DC09-410A-52B6-DDDB-36AD849733F9}"/>
               </a:ext>
             </a:extLst>
           </p:cNvPr>
@@ -2840,7 +2840,7 @@
           <a:bodyPr/>
           <a:lstStyle/>
           <a:p>
-            <a:fld id="{2B531DE8-2E3C-47B4-BCFD-D7BB0CA398CD}" type="slidenum">
+            <a:fld id="{64F069EE-6B3C-43A6-BA10-5D41419D3069}" type="slidenum">
               <a:rPr lang="en-PK" smtClean="0"/>
               <a:t>‹#›</a:t>
             </a:fld>
@@ -2851,7 +2851,7 @@
     </p:spTree>
     <p:extLst>
       <p:ext uri="{BB962C8B-B14F-4D97-AF65-F5344CB8AC3E}">
-        <p14:creationId xmlns:p14="http://schemas.microsoft.com/office/powerpoint/2010/main" val="737376330"/>
+        <p14:creationId xmlns:p14="http://schemas.microsoft.com/office/powerpoint/2010/main" val="3633138965"/>
       </p:ext>
     </p:extLst>
   </p:cSld>
@@ -2883,7 +2883,7 @@
           <p:cNvPr id="2" name="Title 1">
             <a:extLst>
               <a:ext uri="{FF2B5EF4-FFF2-40B4-BE49-F238E27FC236}">
-                <a16:creationId xmlns:a16="http://schemas.microsoft.com/office/drawing/2014/main" id="{79167CEB-D05B-CAF7-A66C-E733D22DC526}"/>
+                <a16:creationId xmlns:a16="http://schemas.microsoft.com/office/drawing/2014/main" id="{2493D002-5F3F-8D55-1B57-7D593A2567EB}"/>
               </a:ext>
             </a:extLst>
           </p:cNvPr>
@@ -2921,7 +2921,7 @@
           <p:cNvPr id="3" name="Content Placeholder 2">
             <a:extLst>
               <a:ext uri="{FF2B5EF4-FFF2-40B4-BE49-F238E27FC236}">
-                <a16:creationId xmlns:a16="http://schemas.microsoft.com/office/drawing/2014/main" id="{3D84E18C-32F3-6A01-EDB9-E863552381B4}"/>
+                <a16:creationId xmlns:a16="http://schemas.microsoft.com/office/drawing/2014/main" id="{9C1C1BB2-63D6-5400-0487-042DF0E6386B}"/>
               </a:ext>
             </a:extLst>
           </p:cNvPr>
@@ -3012,7 +3012,7 @@
           <p:cNvPr id="4" name="Text Placeholder 3">
             <a:extLst>
               <a:ext uri="{FF2B5EF4-FFF2-40B4-BE49-F238E27FC236}">
-                <a16:creationId xmlns:a16="http://schemas.microsoft.com/office/drawing/2014/main" id="{2E6B4D66-1146-88E3-0140-11F0CC873F4F}"/>
+                <a16:creationId xmlns:a16="http://schemas.microsoft.com/office/drawing/2014/main" id="{CCB437F4-C0E8-79A0-6FAE-53B5A6364446}"/>
               </a:ext>
             </a:extLst>
           </p:cNvPr>
@@ -3083,7 +3083,7 @@
           <p:cNvPr id="5" name="Date Placeholder 4">
             <a:extLst>
               <a:ext uri="{FF2B5EF4-FFF2-40B4-BE49-F238E27FC236}">
-                <a16:creationId xmlns:a16="http://schemas.microsoft.com/office/drawing/2014/main" id="{C08B1E63-BA9B-C1EE-CA8C-75B9DFA9BF7D}"/>
+                <a16:creationId xmlns:a16="http://schemas.microsoft.com/office/drawing/2014/main" id="{FF2D700B-8B3F-78ED-1055-06CEB8D43899}"/>
               </a:ext>
             </a:extLst>
           </p:cNvPr>
@@ -3099,7 +3099,7 @@
           <a:bodyPr/>
           <a:lstStyle/>
           <a:p>
-            <a:fld id="{59F4FADE-CEBA-41DE-9B86-AE9226ABBE5E}" type="datetimeFigureOut">
+            <a:fld id="{187C6756-6102-4259-B40B-0718AF07DF35}" type="datetimeFigureOut">
               <a:rPr lang="en-PK" smtClean="0"/>
               <a:t>26/10/2026</a:t>
             </a:fld>
@@ -3112,7 +3112,7 @@
           <p:cNvPr id="6" name="Footer Placeholder 5">
             <a:extLst>
               <a:ext uri="{FF2B5EF4-FFF2-40B4-BE49-F238E27FC236}">
-                <a16:creationId xmlns:a16="http://schemas.microsoft.com/office/drawing/2014/main" id="{46F3D61A-4CFB-DCA1-DCD5-BD48D89DF6C7}"/>
+                <a16:creationId xmlns:a16="http://schemas.microsoft.com/office/drawing/2014/main" id="{53AE768C-6181-44F9-88B4-DE71D002E678}"/>
               </a:ext>
             </a:extLst>
           </p:cNvPr>
@@ -3137,7 +3137,7 @@
           <p:cNvPr id="7" name="Slide Number Placeholder 6">
             <a:extLst>
               <a:ext uri="{FF2B5EF4-FFF2-40B4-BE49-F238E27FC236}">
-                <a16:creationId xmlns:a16="http://schemas.microsoft.com/office/drawing/2014/main" id="{50E04F1F-DCF3-49BF-3EAB-454A52CD99FF}"/>
+                <a16:creationId xmlns:a16="http://schemas.microsoft.com/office/drawing/2014/main" id="{7F3E4306-8DD9-D577-1D8C-1B5445940E05}"/>
               </a:ext>
             </a:extLst>
           </p:cNvPr>
@@ -3153,7 +3153,7 @@
           <a:bodyPr/>
           <a:lstStyle/>
           <a:p>
-            <a:fld id="{2B531DE8-2E3C-47B4-BCFD-D7BB0CA398CD}" type="slidenum">
+            <a:fld id="{64F069EE-6B3C-43A6-BA10-5D41419D3069}" type="slidenum">
               <a:rPr lang="en-PK" smtClean="0"/>
               <a:t>‹#›</a:t>
             </a:fld>
@@ -3164,7 +3164,7 @@
     </p:spTree>
     <p:extLst>
       <p:ext uri="{BB962C8B-B14F-4D97-AF65-F5344CB8AC3E}">
-        <p14:creationId xmlns:p14="http://schemas.microsoft.com/office/powerpoint/2010/main" val="2980614030"/>
+        <p14:creationId xmlns:p14="http://schemas.microsoft.com/office/powerpoint/2010/main" val="1403830558"/>
       </p:ext>
     </p:extLst>
   </p:cSld>
@@ -3196,7 +3196,7 @@
           <p:cNvPr id="2" name="Title 1">
             <a:extLst>
               <a:ext uri="{FF2B5EF4-FFF2-40B4-BE49-F238E27FC236}">
-                <a16:creationId xmlns:a16="http://schemas.microsoft.com/office/drawing/2014/main" id="{3A19D269-D5D0-5AB0-CE22-778459DD360B}"/>
+                <a16:creationId xmlns:a16="http://schemas.microsoft.com/office/drawing/2014/main" id="{5420947D-4031-F893-8413-ADDC1AB1241B}"/>
               </a:ext>
             </a:extLst>
           </p:cNvPr>
@@ -3234,7 +3234,7 @@
           <p:cNvPr id="3" name="Picture Placeholder 2">
             <a:extLst>
               <a:ext uri="{FF2B5EF4-FFF2-40B4-BE49-F238E27FC236}">
-                <a16:creationId xmlns:a16="http://schemas.microsoft.com/office/drawing/2014/main" id="{7F14BEC4-311F-5072-0F0F-5F006DDD5BB0}"/>
+                <a16:creationId xmlns:a16="http://schemas.microsoft.com/office/drawing/2014/main" id="{9E9B936C-8B91-9C71-765F-D232E70D6E74}"/>
               </a:ext>
             </a:extLst>
           </p:cNvPr>
@@ -3301,7 +3301,7 @@
           <p:cNvPr id="4" name="Text Placeholder 3">
             <a:extLst>
               <a:ext uri="{FF2B5EF4-FFF2-40B4-BE49-F238E27FC236}">
-                <a16:creationId xmlns:a16="http://schemas.microsoft.com/office/drawing/2014/main" id="{32ED63FA-8B26-A95D-C18A-98FCA494421A}"/>
+                <a16:creationId xmlns:a16="http://schemas.microsoft.com/office/drawing/2014/main" id="{4A3487B3-CB62-14F9-4317-9DB4295A12AE}"/>
               </a:ext>
             </a:extLst>
           </p:cNvPr>
@@ -3372,7 +3372,7 @@
           <p:cNvPr id="5" name="Date Placeholder 4">
             <a:extLst>
               <a:ext uri="{FF2B5EF4-FFF2-40B4-BE49-F238E27FC236}">
-                <a16:creationId xmlns:a16="http://schemas.microsoft.com/office/drawing/2014/main" id="{4238E55B-6D00-067C-4748-59444BF30B5F}"/>
+                <a16:creationId xmlns:a16="http://schemas.microsoft.com/office/drawing/2014/main" id="{21599EF9-4975-7E41-98B8-17B3373571AF}"/>
               </a:ext>
             </a:extLst>
           </p:cNvPr>
@@ -3388,7 +3388,7 @@
           <a:bodyPr/>
           <a:lstStyle/>
           <a:p>
-            <a:fld id="{59F4FADE-CEBA-41DE-9B86-AE9226ABBE5E}" type="datetimeFigureOut">
+            <a:fld id="{187C6756-6102-4259-B40B-0718AF07DF35}" type="datetimeFigureOut">
               <a:rPr lang="en-PK" smtClean="0"/>
               <a:t>26/10/2026</a:t>
             </a:fld>
@@ -3401,7 +3401,7 @@
           <p:cNvPr id="6" name="Footer Placeholder 5">
             <a:extLst>
               <a:ext uri="{FF2B5EF4-FFF2-40B4-BE49-F238E27FC236}">
-                <a16:creationId xmlns:a16="http://schemas.microsoft.com/office/drawing/2014/main" id="{92A836F4-863E-B58B-59DE-027E33727618}"/>
+                <a16:creationId xmlns:a16="http://schemas.microsoft.com/office/drawing/2014/main" id="{6B8ADB9D-2276-DFF1-B742-504362F0F08F}"/>
               </a:ext>
             </a:extLst>
           </p:cNvPr>
@@ -3426,7 +3426,7 @@
           <p:cNvPr id="7" name="Slide Number Placeholder 6">
             <a:extLst>
               <a:ext uri="{FF2B5EF4-FFF2-40B4-BE49-F238E27FC236}">
-                <a16:creationId xmlns:a16="http://schemas.microsoft.com/office/drawing/2014/main" id="{F1C2EDC7-3D71-D7DA-E360-83F802DC25C4}"/>
+                <a16:creationId xmlns:a16="http://schemas.microsoft.com/office/drawing/2014/main" id="{B306629A-A1E7-5393-8E31-BB9857B2A747}"/>
               </a:ext>
             </a:extLst>
           </p:cNvPr>
@@ -3442,7 +3442,7 @@
           <a:bodyPr/>
           <a:lstStyle/>
           <a:p>
-            <a:fld id="{2B531DE8-2E3C-47B4-BCFD-D7BB0CA398CD}" type="slidenum">
+            <a:fld id="{64F069EE-6B3C-43A6-BA10-5D41419D3069}" type="slidenum">
               <a:rPr lang="en-PK" smtClean="0"/>
               <a:t>‹#›</a:t>
             </a:fld>
@@ -3453,7 +3453,7 @@
     </p:spTree>
     <p:extLst>
       <p:ext uri="{BB962C8B-B14F-4D97-AF65-F5344CB8AC3E}">
-        <p14:creationId xmlns:p14="http://schemas.microsoft.com/office/powerpoint/2010/main" val="2778180406"/>
+        <p14:creationId xmlns:p14="http://schemas.microsoft.com/office/powerpoint/2010/main" val="565682324"/>
       </p:ext>
     </p:extLst>
   </p:cSld>
@@ -3490,7 +3490,7 @@
           <p:cNvPr id="2" name="Title Placeholder 1">
             <a:extLst>
               <a:ext uri="{FF2B5EF4-FFF2-40B4-BE49-F238E27FC236}">
-                <a16:creationId xmlns:a16="http://schemas.microsoft.com/office/drawing/2014/main" id="{1A18E92F-DFD7-A8A8-0251-28CAFD7BA550}"/>
+                <a16:creationId xmlns:a16="http://schemas.microsoft.com/office/drawing/2014/main" id="{43772B63-647A-3646-D6B6-79B94CC1ED9F}"/>
               </a:ext>
             </a:extLst>
           </p:cNvPr>
@@ -3529,7 +3529,7 @@
           <p:cNvPr id="3" name="Text Placeholder 2">
             <a:extLst>
               <a:ext uri="{FF2B5EF4-FFF2-40B4-BE49-F238E27FC236}">
-                <a16:creationId xmlns:a16="http://schemas.microsoft.com/office/drawing/2014/main" id="{315FFD48-E699-EB2F-E77C-9018657306F6}"/>
+                <a16:creationId xmlns:a16="http://schemas.microsoft.com/office/drawing/2014/main" id="{5E6F27DA-B05C-F72C-0920-2AF1F71D6502}"/>
               </a:ext>
             </a:extLst>
           </p:cNvPr>
@@ -3597,7 +3597,7 @@
           <p:cNvPr id="4" name="Date Placeholder 3">
             <a:extLst>
               <a:ext uri="{FF2B5EF4-FFF2-40B4-BE49-F238E27FC236}">
-                <a16:creationId xmlns:a16="http://schemas.microsoft.com/office/drawing/2014/main" id="{F0698EEA-0E89-A98E-DF34-539ED56B35DE}"/>
+                <a16:creationId xmlns:a16="http://schemas.microsoft.com/office/drawing/2014/main" id="{5B42407A-C0B4-5E7F-4EFA-814256772DD3}"/>
               </a:ext>
             </a:extLst>
           </p:cNvPr>
@@ -3631,7 +3631,7 @@
             </a:lvl1pPr>
           </a:lstStyle>
           <a:p>
-            <a:fld id="{59F4FADE-CEBA-41DE-9B86-AE9226ABBE5E}" type="datetimeFigureOut">
+            <a:fld id="{187C6756-6102-4259-B40B-0718AF07DF35}" type="datetimeFigureOut">
               <a:rPr lang="en-PK" smtClean="0"/>
               <a:t>26/10/2026</a:t>
             </a:fld>
@@ -3644,7 +3644,7 @@
           <p:cNvPr id="5" name="Footer Placeholder 4">
             <a:extLst>
               <a:ext uri="{FF2B5EF4-FFF2-40B4-BE49-F238E27FC236}">
-                <a16:creationId xmlns:a16="http://schemas.microsoft.com/office/drawing/2014/main" id="{87626DFA-7567-B859-C50C-873421BC8BA3}"/>
+                <a16:creationId xmlns:a16="http://schemas.microsoft.com/office/drawing/2014/main" id="{04B9DD2C-5017-A929-71DD-61D50B0FD433}"/>
               </a:ext>
             </a:extLst>
           </p:cNvPr>
@@ -3687,7 +3687,7 @@
           <p:cNvPr id="6" name="Slide Number Placeholder 5">
             <a:extLst>
               <a:ext uri="{FF2B5EF4-FFF2-40B4-BE49-F238E27FC236}">
-                <a16:creationId xmlns:a16="http://schemas.microsoft.com/office/drawing/2014/main" id="{F07AA04C-5507-6F6C-121F-68CB2E0062EF}"/>
+                <a16:creationId xmlns:a16="http://schemas.microsoft.com/office/drawing/2014/main" id="{7C8A2362-916A-4B26-8FB2-C22BF32A82FE}"/>
               </a:ext>
             </a:extLst>
           </p:cNvPr>
@@ -3721,7 +3721,7 @@
             </a:lvl1pPr>
           </a:lstStyle>
           <a:p>
-            <a:fld id="{2B531DE8-2E3C-47B4-BCFD-D7BB0CA398CD}" type="slidenum">
+            <a:fld id="{64F069EE-6B3C-43A6-BA10-5D41419D3069}" type="slidenum">
               <a:rPr lang="en-PK" smtClean="0"/>
               <a:t>‹#›</a:t>
             </a:fld>
@@ -3732,7 +3732,7 @@
     </p:spTree>
     <p:extLst>
       <p:ext uri="{BB962C8B-B14F-4D97-AF65-F5344CB8AC3E}">
-        <p14:creationId xmlns:p14="http://schemas.microsoft.com/office/powerpoint/2010/main" val="3378672403"/>
+        <p14:creationId xmlns:p14="http://schemas.microsoft.com/office/powerpoint/2010/main" val="4030157828"/>
       </p:ext>
     </p:extLst>
   </p:cSld>
@@ -4055,7 +4055,7 @@
           <p:cNvPr id="2" name="Rectangle 1">
             <a:extLst>
               <a:ext uri="{FF2B5EF4-FFF2-40B4-BE49-F238E27FC236}">
-                <a16:creationId xmlns:a16="http://schemas.microsoft.com/office/drawing/2014/main" id="{78DFFB37-A769-DEEA-7351-76884CFDDECD}"/>
+                <a16:creationId xmlns:a16="http://schemas.microsoft.com/office/drawing/2014/main" id="{DD7A9A1B-EEB7-51F3-1E02-9EC924CF647B}"/>
               </a:ext>
             </a:extLst>
           </p:cNvPr>
@@ -4123,7 +4123,7 @@
           <p:cNvPr id="3" name="Rectangle 2">
             <a:extLst>
               <a:ext uri="{FF2B5EF4-FFF2-40B4-BE49-F238E27FC236}">
-                <a16:creationId xmlns:a16="http://schemas.microsoft.com/office/drawing/2014/main" id="{F6B71584-7BBA-D09F-A122-E23412551D08}"/>
+                <a16:creationId xmlns:a16="http://schemas.microsoft.com/office/drawing/2014/main" id="{A768D4A2-FC05-7BD5-C53B-A768BAEA5C00}"/>
               </a:ext>
             </a:extLst>
           </p:cNvPr>
@@ -4191,7 +4191,7 @@
           <p:cNvPr id="4" name="TextBox 3">
             <a:extLst>
               <a:ext uri="{FF2B5EF4-FFF2-40B4-BE49-F238E27FC236}">
-                <a16:creationId xmlns:a16="http://schemas.microsoft.com/office/drawing/2014/main" id="{E02921EA-2FA5-F6DC-0C8D-86F01A85D408}"/>
+                <a16:creationId xmlns:a16="http://schemas.microsoft.com/office/drawing/2014/main" id="{81E6394D-1C33-B545-94AA-67431AC7071C}"/>
               </a:ext>
             </a:extLst>
           </p:cNvPr>
@@ -4237,7 +4237,7 @@
           <p:cNvPr id="5" name="TextBox 4">
             <a:extLst>
               <a:ext uri="{FF2B5EF4-FFF2-40B4-BE49-F238E27FC236}">
-                <a16:creationId xmlns:a16="http://schemas.microsoft.com/office/drawing/2014/main" id="{D7FF1B93-C1D5-3522-4432-3DC767E0FE20}"/>
+                <a16:creationId xmlns:a16="http://schemas.microsoft.com/office/drawing/2014/main" id="{F94DB5EF-D71E-2E8A-B163-ADBC0FE0025A}"/>
               </a:ext>
             </a:extLst>
           </p:cNvPr>
@@ -4283,7 +4283,7 @@
           <p:cNvPr id="6" name="TextBox 5">
             <a:extLst>
               <a:ext uri="{FF2B5EF4-FFF2-40B4-BE49-F238E27FC236}">
-                <a16:creationId xmlns:a16="http://schemas.microsoft.com/office/drawing/2014/main" id="{45B10E4E-FC1B-0A84-8625-9F5495D090EF}"/>
+                <a16:creationId xmlns:a16="http://schemas.microsoft.com/office/drawing/2014/main" id="{58529EBF-3CBE-2E1A-4D6C-6A67DE8FA80C}"/>
               </a:ext>
             </a:extLst>
           </p:cNvPr>
@@ -4329,7 +4329,7 @@
           <p:cNvPr id="7" name="Rectangle 6">
             <a:extLst>
               <a:ext uri="{FF2B5EF4-FFF2-40B4-BE49-F238E27FC236}">
-                <a16:creationId xmlns:a16="http://schemas.microsoft.com/office/drawing/2014/main" id="{8B6D822F-91E8-B1ED-2A25-C8FCEF407100}"/>
+                <a16:creationId xmlns:a16="http://schemas.microsoft.com/office/drawing/2014/main" id="{DCE550B5-E52A-86B5-5B36-4AA09DE4AF35}"/>
               </a:ext>
             </a:extLst>
           </p:cNvPr>
@@ -4397,7 +4397,7 @@
           <p:cNvPr id="8" name="TextBox 7">
             <a:extLst>
               <a:ext uri="{FF2B5EF4-FFF2-40B4-BE49-F238E27FC236}">
-                <a16:creationId xmlns:a16="http://schemas.microsoft.com/office/drawing/2014/main" id="{E6CC6F3C-165D-E52D-D26A-A54800E93CAC}"/>
+                <a16:creationId xmlns:a16="http://schemas.microsoft.com/office/drawing/2014/main" id="{F29348E8-698D-350D-EFD5-997ACBD4F56F}"/>
               </a:ext>
             </a:extLst>
           </p:cNvPr>
@@ -4443,7 +4443,7 @@
           <p:cNvPr id="9" name="TextBox 8">
             <a:extLst>
               <a:ext uri="{FF2B5EF4-FFF2-40B4-BE49-F238E27FC236}">
-                <a16:creationId xmlns:a16="http://schemas.microsoft.com/office/drawing/2014/main" id="{A2AD896E-5709-FA39-31B7-D31BBE2E9B78}"/>
+                <a16:creationId xmlns:a16="http://schemas.microsoft.com/office/drawing/2014/main" id="{81D56092-D330-A9AE-4839-7C92FA57BD86}"/>
               </a:ext>
             </a:extLst>
           </p:cNvPr>
@@ -4489,7 +4489,7 @@
           <p:cNvPr id="10" name="TextBox 9">
             <a:extLst>
               <a:ext uri="{FF2B5EF4-FFF2-40B4-BE49-F238E27FC236}">
-                <a16:creationId xmlns:a16="http://schemas.microsoft.com/office/drawing/2014/main" id="{1B5FE0C8-4C91-FA7C-0E48-4A6BEB32B6BA}"/>
+                <a16:creationId xmlns:a16="http://schemas.microsoft.com/office/drawing/2014/main" id="{A0E4A7FE-7F06-AB83-3C76-9FCC08EC9DB9}"/>
               </a:ext>
             </a:extLst>
           </p:cNvPr>
@@ -4535,7 +4535,7 @@
           <p:cNvPr id="11" name="TextBox 10">
             <a:extLst>
               <a:ext uri="{FF2B5EF4-FFF2-40B4-BE49-F238E27FC236}">
-                <a16:creationId xmlns:a16="http://schemas.microsoft.com/office/drawing/2014/main" id="{07D0291C-C43A-1FA4-2984-A19D0ADF2F3C}"/>
+                <a16:creationId xmlns:a16="http://schemas.microsoft.com/office/drawing/2014/main" id="{35EFEEA2-70C0-DEB6-8369-45C37327177E}"/>
               </a:ext>
             </a:extLst>
           </p:cNvPr>
@@ -4581,7 +4581,7 @@
           <p:cNvPr id="12" name="TextBox 11">
             <a:extLst>
               <a:ext uri="{FF2B5EF4-FFF2-40B4-BE49-F238E27FC236}">
-                <a16:creationId xmlns:a16="http://schemas.microsoft.com/office/drawing/2014/main" id="{8CF471CE-AB33-1E24-10CF-D3FC9A8E9843}"/>
+                <a16:creationId xmlns:a16="http://schemas.microsoft.com/office/drawing/2014/main" id="{8DE53876-E121-F2F8-016F-762B80F3E4C9}"/>
               </a:ext>
             </a:extLst>
           </p:cNvPr>
@@ -4628,7 +4628,7 @@
           <p:cNvPr id="13" name="TextBox 12">
             <a:extLst>
               <a:ext uri="{FF2B5EF4-FFF2-40B4-BE49-F238E27FC236}">
-                <a16:creationId xmlns:a16="http://schemas.microsoft.com/office/drawing/2014/main" id="{0AD535DC-1B7C-410A-0CC5-7DE5B81E6816}"/>
+                <a16:creationId xmlns:a16="http://schemas.microsoft.com/office/drawing/2014/main" id="{ABA8A252-1C60-F653-BA25-C3BAACA9B092}"/>
               </a:ext>
             </a:extLst>
           </p:cNvPr>
@@ -4672,7 +4672,7 @@
     </p:spTree>
     <p:extLst>
       <p:ext uri="{BB962C8B-B14F-4D97-AF65-F5344CB8AC3E}">
-        <p14:creationId xmlns:p14="http://schemas.microsoft.com/office/powerpoint/2010/main" val="227600784"/>
+        <p14:creationId xmlns:p14="http://schemas.microsoft.com/office/powerpoint/2010/main" val="3381361864"/>
       </p:ext>
     </p:extLst>
   </p:cSld>
@@ -4704,7 +4704,7 @@
           <p:cNvPr id="12" name="Rectangle 11">
             <a:extLst>
               <a:ext uri="{FF2B5EF4-FFF2-40B4-BE49-F238E27FC236}">
-                <a16:creationId xmlns:a16="http://schemas.microsoft.com/office/drawing/2014/main" id="{7CE5B9BA-4247-EE4D-B1FA-13804C0F0AE7}"/>
+                <a16:creationId xmlns:a16="http://schemas.microsoft.com/office/drawing/2014/main" id="{67976025-CEED-EC83-91FB-C01FEB170D18}"/>
               </a:ext>
             </a:extLst>
           </p:cNvPr>
@@ -4758,7 +4758,7 @@
           <p:cNvPr id="9" name="Rectangle 8">
             <a:extLst>
               <a:ext uri="{FF2B5EF4-FFF2-40B4-BE49-F238E27FC236}">
-                <a16:creationId xmlns:a16="http://schemas.microsoft.com/office/drawing/2014/main" id="{1E8361A6-7589-0F7F-2AFA-00283444D525}"/>
+                <a16:creationId xmlns:a16="http://schemas.microsoft.com/office/drawing/2014/main" id="{B3C0F8A1-96AC-9E63-AB9D-0888052D49FC}"/>
               </a:ext>
             </a:extLst>
           </p:cNvPr>
@@ -4812,7 +4812,7 @@
           <p:cNvPr id="2" name="Rectangle 1">
             <a:extLst>
               <a:ext uri="{FF2B5EF4-FFF2-40B4-BE49-F238E27FC236}">
-                <a16:creationId xmlns:a16="http://schemas.microsoft.com/office/drawing/2014/main" id="{A5D0DE42-035F-3AE7-391B-2CECA3340DA7}"/>
+                <a16:creationId xmlns:a16="http://schemas.microsoft.com/office/drawing/2014/main" id="{E459D89A-2693-C128-2240-92F416A31C25}"/>
               </a:ext>
             </a:extLst>
           </p:cNvPr>
@@ -4880,7 +4880,7 @@
           <p:cNvPr id="3" name="TextBox 2">
             <a:extLst>
               <a:ext uri="{FF2B5EF4-FFF2-40B4-BE49-F238E27FC236}">
-                <a16:creationId xmlns:a16="http://schemas.microsoft.com/office/drawing/2014/main" id="{E65FEAC8-5C62-D559-6BFD-BFE6947B4EC9}"/>
+                <a16:creationId xmlns:a16="http://schemas.microsoft.com/office/drawing/2014/main" id="{DAC356B6-F3CF-BF5F-93FA-4138E358321B}"/>
               </a:ext>
             </a:extLst>
           </p:cNvPr>
@@ -4926,7 +4926,7 @@
           <p:cNvPr id="4" name="TextBox 3">
             <a:extLst>
               <a:ext uri="{FF2B5EF4-FFF2-40B4-BE49-F238E27FC236}">
-                <a16:creationId xmlns:a16="http://schemas.microsoft.com/office/drawing/2014/main" id="{FBD10EC0-8358-2E6B-79D3-8560EC081FD0}"/>
+                <a16:creationId xmlns:a16="http://schemas.microsoft.com/office/drawing/2014/main" id="{B3D722FE-EAB3-874A-D109-E300A0DBC125}"/>
               </a:ext>
             </a:extLst>
           </p:cNvPr>
@@ -4972,7 +4972,7 @@
           <p:cNvPr id="5" name="TextBox 4">
             <a:extLst>
               <a:ext uri="{FF2B5EF4-FFF2-40B4-BE49-F238E27FC236}">
-                <a16:creationId xmlns:a16="http://schemas.microsoft.com/office/drawing/2014/main" id="{475D964E-A775-7FB5-0EBF-9420C99DE86F}"/>
+                <a16:creationId xmlns:a16="http://schemas.microsoft.com/office/drawing/2014/main" id="{9A2F8AE8-0EA3-4534-095C-7735A6D3CA81}"/>
               </a:ext>
             </a:extLst>
           </p:cNvPr>
@@ -5018,7 +5018,7 @@
           <p:cNvPr id="6" name="TextBox 5">
             <a:extLst>
               <a:ext uri="{FF2B5EF4-FFF2-40B4-BE49-F238E27FC236}">
-                <a16:creationId xmlns:a16="http://schemas.microsoft.com/office/drawing/2014/main" id="{61B2C97C-976C-B298-69FC-F41FBA2B4FD7}"/>
+                <a16:creationId xmlns:a16="http://schemas.microsoft.com/office/drawing/2014/main" id="{AD94264A-F866-E703-5611-08593A464110}"/>
               </a:ext>
             </a:extLst>
           </p:cNvPr>
@@ -5064,7 +5064,7 @@
           <p:cNvPr id="8" name="Graphic 7">
             <a:extLst>
               <a:ext uri="{FF2B5EF4-FFF2-40B4-BE49-F238E27FC236}">
-                <a16:creationId xmlns:a16="http://schemas.microsoft.com/office/drawing/2014/main" id="{EB309B29-B8A3-BCCC-7862-B6E961950BCD}"/>
+                <a16:creationId xmlns:a16="http://schemas.microsoft.com/office/drawing/2014/main" id="{434BD162-19B5-C080-ACD8-E11552A9613B}"/>
               </a:ext>
             </a:extLst>
           </p:cNvPr>
@@ -5100,7 +5100,7 @@
           <p:cNvPr id="11" name="Graphic 10">
             <a:extLst>
               <a:ext uri="{FF2B5EF4-FFF2-40B4-BE49-F238E27FC236}">
-                <a16:creationId xmlns:a16="http://schemas.microsoft.com/office/drawing/2014/main" id="{D8013998-D1D2-5CB2-6FCC-CA8A5C6ABC35}"/>
+                <a16:creationId xmlns:a16="http://schemas.microsoft.com/office/drawing/2014/main" id="{29C9E9C5-8CEC-3CA4-6714-A5271C9516D6}"/>
               </a:ext>
             </a:extLst>
           </p:cNvPr>
@@ -5136,7 +5136,7 @@
           <p:cNvPr id="13" name="TextBox 12">
             <a:extLst>
               <a:ext uri="{FF2B5EF4-FFF2-40B4-BE49-F238E27FC236}">
-                <a16:creationId xmlns:a16="http://schemas.microsoft.com/office/drawing/2014/main" id="{D746A681-685D-FEF6-3D74-F3BAA32BF82D}"/>
+                <a16:creationId xmlns:a16="http://schemas.microsoft.com/office/drawing/2014/main" id="{555E0752-176D-AA3B-D2B6-FC26B3F43069}"/>
               </a:ext>
             </a:extLst>
           </p:cNvPr>
@@ -5182,7 +5182,7 @@
           <p:cNvPr id="14" name="TextBox 13">
             <a:extLst>
               <a:ext uri="{FF2B5EF4-FFF2-40B4-BE49-F238E27FC236}">
-                <a16:creationId xmlns:a16="http://schemas.microsoft.com/office/drawing/2014/main" id="{7744C070-A28C-522C-60D3-9C09B46F96B4}"/>
+                <a16:creationId xmlns:a16="http://schemas.microsoft.com/office/drawing/2014/main" id="{8DF99D11-76B1-4A8B-0FC6-E9F17C2E0309}"/>
               </a:ext>
             </a:extLst>
           </p:cNvPr>
@@ -5228,7 +5228,7 @@
           <p:cNvPr id="15" name="TextBox 14">
             <a:extLst>
               <a:ext uri="{FF2B5EF4-FFF2-40B4-BE49-F238E27FC236}">
-                <a16:creationId xmlns:a16="http://schemas.microsoft.com/office/drawing/2014/main" id="{B4BE08F1-81F6-8108-1AFF-1E4B13110000}"/>
+                <a16:creationId xmlns:a16="http://schemas.microsoft.com/office/drawing/2014/main" id="{F9A55C29-8DA0-4EA1-2867-BF74DE92ED2F}"/>
               </a:ext>
             </a:extLst>
           </p:cNvPr>
@@ -5274,7 +5274,7 @@
           <p:cNvPr id="16" name="TextBox 15">
             <a:extLst>
               <a:ext uri="{FF2B5EF4-FFF2-40B4-BE49-F238E27FC236}">
-                <a16:creationId xmlns:a16="http://schemas.microsoft.com/office/drawing/2014/main" id="{44758271-AB38-BF2B-9E5B-B9AB3DB086E3}"/>
+                <a16:creationId xmlns:a16="http://schemas.microsoft.com/office/drawing/2014/main" id="{16E9BAA2-CEEA-1F6C-EABA-792A9522AF19}"/>
               </a:ext>
             </a:extLst>
           </p:cNvPr>
@@ -5320,7 +5320,7 @@
           <p:cNvPr id="17" name="TextBox 16">
             <a:extLst>
               <a:ext uri="{FF2B5EF4-FFF2-40B4-BE49-F238E27FC236}">
-                <a16:creationId xmlns:a16="http://schemas.microsoft.com/office/drawing/2014/main" id="{36C71CA8-8D91-0640-978F-31B805D7A882}"/>
+                <a16:creationId xmlns:a16="http://schemas.microsoft.com/office/drawing/2014/main" id="{DBC18145-28DA-950C-7943-D74010F5D401}"/>
               </a:ext>
             </a:extLst>
           </p:cNvPr>
@@ -5359,7 +5359,7 @@
     </p:spTree>
     <p:extLst>
       <p:ext uri="{BB962C8B-B14F-4D97-AF65-F5344CB8AC3E}">
-        <p14:creationId xmlns:p14="http://schemas.microsoft.com/office/powerpoint/2010/main" val="1510000533"/>
+        <p14:creationId xmlns:p14="http://schemas.microsoft.com/office/powerpoint/2010/main" val="3276020778"/>
       </p:ext>
     </p:extLst>
   </p:cSld>
@@ -5391,7 +5391,7 @@
           <p:cNvPr id="13" name="Rectangle 12">
             <a:extLst>
               <a:ext uri="{FF2B5EF4-FFF2-40B4-BE49-F238E27FC236}">
-                <a16:creationId xmlns:a16="http://schemas.microsoft.com/office/drawing/2014/main" id="{63290763-1AA4-5CCD-054A-BC9F27FE1883}"/>
+                <a16:creationId xmlns:a16="http://schemas.microsoft.com/office/drawing/2014/main" id="{AA5BFFF3-91D8-211C-2CA8-C2E6EB6957E4}"/>
               </a:ext>
             </a:extLst>
           </p:cNvPr>
@@ -5445,7 +5445,7 @@
           <p:cNvPr id="2" name="Rectangle 1">
             <a:extLst>
               <a:ext uri="{FF2B5EF4-FFF2-40B4-BE49-F238E27FC236}">
-                <a16:creationId xmlns:a16="http://schemas.microsoft.com/office/drawing/2014/main" id="{1949AF98-7733-8DAC-A3FB-EAE50DC11316}"/>
+                <a16:creationId xmlns:a16="http://schemas.microsoft.com/office/drawing/2014/main" id="{285338D0-5D3E-AD12-5C07-E9B8F5339FEF}"/>
               </a:ext>
             </a:extLst>
           </p:cNvPr>
@@ -5513,7 +5513,7 @@
           <p:cNvPr id="3" name="TextBox 2">
             <a:extLst>
               <a:ext uri="{FF2B5EF4-FFF2-40B4-BE49-F238E27FC236}">
-                <a16:creationId xmlns:a16="http://schemas.microsoft.com/office/drawing/2014/main" id="{A1FB5633-DDDA-A419-863F-5E7D23C15EE6}"/>
+                <a16:creationId xmlns:a16="http://schemas.microsoft.com/office/drawing/2014/main" id="{50475EC4-92B3-E108-1464-854D4EF22A6A}"/>
               </a:ext>
             </a:extLst>
           </p:cNvPr>
@@ -5559,7 +5559,7 @@
           <p:cNvPr id="4" name="TextBox 3">
             <a:extLst>
               <a:ext uri="{FF2B5EF4-FFF2-40B4-BE49-F238E27FC236}">
-                <a16:creationId xmlns:a16="http://schemas.microsoft.com/office/drawing/2014/main" id="{51167EC9-CF62-FABC-50E8-6EA2B81C50A6}"/>
+                <a16:creationId xmlns:a16="http://schemas.microsoft.com/office/drawing/2014/main" id="{53FE02DC-5B05-C07A-60BE-8D344DB76D5E}"/>
               </a:ext>
             </a:extLst>
           </p:cNvPr>
@@ -5605,7 +5605,7 @@
           <p:cNvPr id="5" name="TextBox 4">
             <a:extLst>
               <a:ext uri="{FF2B5EF4-FFF2-40B4-BE49-F238E27FC236}">
-                <a16:creationId xmlns:a16="http://schemas.microsoft.com/office/drawing/2014/main" id="{B8491E66-C9CF-A0DE-C969-11A41CAAD3AB}"/>
+                <a16:creationId xmlns:a16="http://schemas.microsoft.com/office/drawing/2014/main" id="{2BE61D69-3B60-65CD-9614-7AEE96FB1AFF}"/>
               </a:ext>
             </a:extLst>
           </p:cNvPr>
@@ -5645,7 +5645,7 @@
           <p:cNvPr id="6" name="TextBox 5">
             <a:extLst>
               <a:ext uri="{FF2B5EF4-FFF2-40B4-BE49-F238E27FC236}">
-                <a16:creationId xmlns:a16="http://schemas.microsoft.com/office/drawing/2014/main" id="{E03A1293-3F7E-42AD-AA7E-DCACED222371}"/>
+                <a16:creationId xmlns:a16="http://schemas.microsoft.com/office/drawing/2014/main" id="{497AFEB7-96A3-87C4-87E3-AA82CB5992FF}"/>
               </a:ext>
             </a:extLst>
           </p:cNvPr>
@@ -5691,7 +5691,7 @@
           <p:cNvPr id="7" name="TextBox 6">
             <a:extLst>
               <a:ext uri="{FF2B5EF4-FFF2-40B4-BE49-F238E27FC236}">
-                <a16:creationId xmlns:a16="http://schemas.microsoft.com/office/drawing/2014/main" id="{CD3D1243-A4F9-3D15-FBAF-BE46A61B45B3}"/>
+                <a16:creationId xmlns:a16="http://schemas.microsoft.com/office/drawing/2014/main" id="{B662DAA1-15DB-163C-0187-FE655BB59F33}"/>
               </a:ext>
             </a:extLst>
           </p:cNvPr>
@@ -5737,7 +5737,7 @@
           <p:cNvPr id="8" name="Rectangle 7">
             <a:extLst>
               <a:ext uri="{FF2B5EF4-FFF2-40B4-BE49-F238E27FC236}">
-                <a16:creationId xmlns:a16="http://schemas.microsoft.com/office/drawing/2014/main" id="{C598C6E6-7DFC-1E20-E69F-D980C61CF618}"/>
+                <a16:creationId xmlns:a16="http://schemas.microsoft.com/office/drawing/2014/main" id="{B35E1C3F-3009-7B21-DDBD-CBBC2D14CA8D}"/>
               </a:ext>
             </a:extLst>
           </p:cNvPr>
@@ -5805,7 +5805,7 @@
           <p:cNvPr id="9" name="TextBox 8">
             <a:extLst>
               <a:ext uri="{FF2B5EF4-FFF2-40B4-BE49-F238E27FC236}">
-                <a16:creationId xmlns:a16="http://schemas.microsoft.com/office/drawing/2014/main" id="{121F68AE-6FFA-F962-5B04-E8036A151B03}"/>
+                <a16:creationId xmlns:a16="http://schemas.microsoft.com/office/drawing/2014/main" id="{04512DD9-96AD-6451-CE2E-30D963A28D42}"/>
               </a:ext>
             </a:extLst>
           </p:cNvPr>
@@ -5883,7 +5883,7 @@
           <p:cNvPr id="10" name="TextBox 9">
             <a:extLst>
               <a:ext uri="{FF2B5EF4-FFF2-40B4-BE49-F238E27FC236}">
-                <a16:creationId xmlns:a16="http://schemas.microsoft.com/office/drawing/2014/main" id="{7333E385-14BC-4477-D668-8B9E94E3866B}"/>
+                <a16:creationId xmlns:a16="http://schemas.microsoft.com/office/drawing/2014/main" id="{B3373285-B050-4681-E4FB-186BACFB4429}"/>
               </a:ext>
             </a:extLst>
           </p:cNvPr>
@@ -5929,7 +5929,7 @@
           <p:cNvPr id="12" name="Graphic 11">
             <a:extLst>
               <a:ext uri="{FF2B5EF4-FFF2-40B4-BE49-F238E27FC236}">
-                <a16:creationId xmlns:a16="http://schemas.microsoft.com/office/drawing/2014/main" id="{239D6B77-F3C8-42FA-DFF4-F329A905F754}"/>
+                <a16:creationId xmlns:a16="http://schemas.microsoft.com/office/drawing/2014/main" id="{89BA7991-A706-C918-5F9F-2DA68D6E1CC9}"/>
               </a:ext>
             </a:extLst>
           </p:cNvPr>
@@ -5965,7 +5965,7 @@
           <p:cNvPr id="14" name="TextBox 13">
             <a:extLst>
               <a:ext uri="{FF2B5EF4-FFF2-40B4-BE49-F238E27FC236}">
-                <a16:creationId xmlns:a16="http://schemas.microsoft.com/office/drawing/2014/main" id="{E6D7F4D0-CBC6-AFCF-FC03-37704E5FB266}"/>
+                <a16:creationId xmlns:a16="http://schemas.microsoft.com/office/drawing/2014/main" id="{16036C71-A5F5-9C02-A7EB-1B4180DA2F4A}"/>
               </a:ext>
             </a:extLst>
           </p:cNvPr>
@@ -6011,7 +6011,7 @@
           <p:cNvPr id="15" name="TextBox 14">
             <a:extLst>
               <a:ext uri="{FF2B5EF4-FFF2-40B4-BE49-F238E27FC236}">
-                <a16:creationId xmlns:a16="http://schemas.microsoft.com/office/drawing/2014/main" id="{F51D3D26-8AE2-C89E-FE17-2C451F0A8141}"/>
+                <a16:creationId xmlns:a16="http://schemas.microsoft.com/office/drawing/2014/main" id="{BF39CADC-4A1B-FF54-17F1-BE301FC37B8D}"/>
               </a:ext>
             </a:extLst>
           </p:cNvPr>
@@ -6050,7 +6050,7 @@
     </p:spTree>
     <p:extLst>
       <p:ext uri="{BB962C8B-B14F-4D97-AF65-F5344CB8AC3E}">
-        <p14:creationId xmlns:p14="http://schemas.microsoft.com/office/powerpoint/2010/main" val="1104259216"/>
+        <p14:creationId xmlns:p14="http://schemas.microsoft.com/office/powerpoint/2010/main" val="3542139465"/>
       </p:ext>
     </p:extLst>
   </p:cSld>
@@ -6082,7 +6082,7 @@
           <p:cNvPr id="7" name="Rectangle 6">
             <a:extLst>
               <a:ext uri="{FF2B5EF4-FFF2-40B4-BE49-F238E27FC236}">
-                <a16:creationId xmlns:a16="http://schemas.microsoft.com/office/drawing/2014/main" id="{C5A230C2-9D34-F269-2394-5B1C5D980241}"/>
+                <a16:creationId xmlns:a16="http://schemas.microsoft.com/office/drawing/2014/main" id="{CDF5B806-76B1-BA3E-DDA8-005D2A7B3799}"/>
               </a:ext>
             </a:extLst>
           </p:cNvPr>
@@ -6136,7 +6136,7 @@
           <p:cNvPr id="2" name="Rectangle 1">
             <a:extLst>
               <a:ext uri="{FF2B5EF4-FFF2-40B4-BE49-F238E27FC236}">
-                <a16:creationId xmlns:a16="http://schemas.microsoft.com/office/drawing/2014/main" id="{1FE884CF-9FCE-39F4-D93E-DAD9376E65F4}"/>
+                <a16:creationId xmlns:a16="http://schemas.microsoft.com/office/drawing/2014/main" id="{C24B8312-F3E5-DB55-5F68-BAF2DFBEC58B}"/>
               </a:ext>
             </a:extLst>
           </p:cNvPr>
@@ -6204,7 +6204,7 @@
           <p:cNvPr id="3" name="TextBox 2">
             <a:extLst>
               <a:ext uri="{FF2B5EF4-FFF2-40B4-BE49-F238E27FC236}">
-                <a16:creationId xmlns:a16="http://schemas.microsoft.com/office/drawing/2014/main" id="{B18459E0-CCFA-3986-1D90-BDBEBCC831B5}"/>
+                <a16:creationId xmlns:a16="http://schemas.microsoft.com/office/drawing/2014/main" id="{E8A7FEE7-47B2-8A1F-B6A0-3BEA245176E5}"/>
               </a:ext>
             </a:extLst>
           </p:cNvPr>
@@ -6250,7 +6250,7 @@
           <p:cNvPr id="4" name="TextBox 3">
             <a:extLst>
               <a:ext uri="{FF2B5EF4-FFF2-40B4-BE49-F238E27FC236}">
-                <a16:creationId xmlns:a16="http://schemas.microsoft.com/office/drawing/2014/main" id="{027E4504-24AB-E6D6-90BE-8CA347DD7DA6}"/>
+                <a16:creationId xmlns:a16="http://schemas.microsoft.com/office/drawing/2014/main" id="{28D95F0E-9CF1-C0DD-B24A-2CD776AF93D3}"/>
               </a:ext>
             </a:extLst>
           </p:cNvPr>
@@ -6296,7 +6296,7 @@
           <p:cNvPr id="6" name="Graphic 5">
             <a:extLst>
               <a:ext uri="{FF2B5EF4-FFF2-40B4-BE49-F238E27FC236}">
-                <a16:creationId xmlns:a16="http://schemas.microsoft.com/office/drawing/2014/main" id="{BA625832-D7D5-0C92-2387-C6E8BC2DFCCE}"/>
+                <a16:creationId xmlns:a16="http://schemas.microsoft.com/office/drawing/2014/main" id="{88A877E6-E60C-1991-4706-44CCCB1C0DCA}"/>
               </a:ext>
             </a:extLst>
           </p:cNvPr>
@@ -6332,7 +6332,7 @@
           <p:cNvPr id="8" name="TextBox 7">
             <a:extLst>
               <a:ext uri="{FF2B5EF4-FFF2-40B4-BE49-F238E27FC236}">
-                <a16:creationId xmlns:a16="http://schemas.microsoft.com/office/drawing/2014/main" id="{3CC705E5-F4AA-AFC2-FF3C-A461F96A7B21}"/>
+                <a16:creationId xmlns:a16="http://schemas.microsoft.com/office/drawing/2014/main" id="{6FDDB1E0-04B4-2674-9E24-58811351500A}"/>
               </a:ext>
             </a:extLst>
           </p:cNvPr>
@@ -6378,7 +6378,7 @@
           <p:cNvPr id="9" name="TextBox 8">
             <a:extLst>
               <a:ext uri="{FF2B5EF4-FFF2-40B4-BE49-F238E27FC236}">
-                <a16:creationId xmlns:a16="http://schemas.microsoft.com/office/drawing/2014/main" id="{D677A1D5-4ADA-75E1-A3D0-F0AFB4F35AD3}"/>
+                <a16:creationId xmlns:a16="http://schemas.microsoft.com/office/drawing/2014/main" id="{5F80F15B-F15A-3D2C-F09C-EF3F8085DFE7}"/>
               </a:ext>
             </a:extLst>
           </p:cNvPr>
@@ -6424,7 +6424,7 @@
           <p:cNvPr id="10" name="TextBox 9">
             <a:extLst>
               <a:ext uri="{FF2B5EF4-FFF2-40B4-BE49-F238E27FC236}">
-                <a16:creationId xmlns:a16="http://schemas.microsoft.com/office/drawing/2014/main" id="{01C27F88-BDEC-5F5A-FF71-D80F07B775C3}"/>
+                <a16:creationId xmlns:a16="http://schemas.microsoft.com/office/drawing/2014/main" id="{CB2E48E0-611E-35A2-E4EF-8CE3CB42D676}"/>
               </a:ext>
             </a:extLst>
           </p:cNvPr>
@@ -6464,7 +6464,7 @@
           <p:cNvPr id="11" name="TextBox 10">
             <a:extLst>
               <a:ext uri="{FF2B5EF4-FFF2-40B4-BE49-F238E27FC236}">
-                <a16:creationId xmlns:a16="http://schemas.microsoft.com/office/drawing/2014/main" id="{A02F4389-9164-6329-7F91-A6D34D483CF5}"/>
+                <a16:creationId xmlns:a16="http://schemas.microsoft.com/office/drawing/2014/main" id="{B8C5BB1F-5B07-50CB-0328-DFDFD1BA8A4C}"/>
               </a:ext>
             </a:extLst>
           </p:cNvPr>
@@ -6510,7 +6510,7 @@
           <p:cNvPr id="12" name="TextBox 11">
             <a:extLst>
               <a:ext uri="{FF2B5EF4-FFF2-40B4-BE49-F238E27FC236}">
-                <a16:creationId xmlns:a16="http://schemas.microsoft.com/office/drawing/2014/main" id="{76B66CD7-11C1-B517-7CC9-74A287CFF600}"/>
+                <a16:creationId xmlns:a16="http://schemas.microsoft.com/office/drawing/2014/main" id="{0748E9FE-D3C2-B1F0-2574-6222953F42C0}"/>
               </a:ext>
             </a:extLst>
           </p:cNvPr>
@@ -6556,7 +6556,7 @@
           <p:cNvPr id="13" name="Rectangle 12">
             <a:extLst>
               <a:ext uri="{FF2B5EF4-FFF2-40B4-BE49-F238E27FC236}">
-                <a16:creationId xmlns:a16="http://schemas.microsoft.com/office/drawing/2014/main" id="{31A88EFD-DDA3-0C03-E316-591E840F5A30}"/>
+                <a16:creationId xmlns:a16="http://schemas.microsoft.com/office/drawing/2014/main" id="{1AB0EE42-99AC-1B48-AF49-E2DBD97A1006}"/>
               </a:ext>
             </a:extLst>
           </p:cNvPr>
@@ -6624,7 +6624,7 @@
           <p:cNvPr id="14" name="TextBox 13">
             <a:extLst>
               <a:ext uri="{FF2B5EF4-FFF2-40B4-BE49-F238E27FC236}">
-                <a16:creationId xmlns:a16="http://schemas.microsoft.com/office/drawing/2014/main" id="{DB824293-05BD-78CA-92DA-23B610195BEA}"/>
+                <a16:creationId xmlns:a16="http://schemas.microsoft.com/office/drawing/2014/main" id="{8D14BFA3-67DB-584F-7370-2E1E04BA619F}"/>
               </a:ext>
             </a:extLst>
           </p:cNvPr>
@@ -6670,7 +6670,7 @@
           <p:cNvPr id="15" name="TextBox 14">
             <a:extLst>
               <a:ext uri="{FF2B5EF4-FFF2-40B4-BE49-F238E27FC236}">
-                <a16:creationId xmlns:a16="http://schemas.microsoft.com/office/drawing/2014/main" id="{11034327-699E-99B1-C033-DE9F19825E5E}"/>
+                <a16:creationId xmlns:a16="http://schemas.microsoft.com/office/drawing/2014/main" id="{5C4D4ADC-73B9-C892-868E-C761514F0F70}"/>
               </a:ext>
             </a:extLst>
           </p:cNvPr>
@@ -6716,7 +6716,7 @@
           <p:cNvPr id="16" name="TextBox 15">
             <a:extLst>
               <a:ext uri="{FF2B5EF4-FFF2-40B4-BE49-F238E27FC236}">
-                <a16:creationId xmlns:a16="http://schemas.microsoft.com/office/drawing/2014/main" id="{03A664BE-8385-CEA2-2BA1-EE0C45470D9A}"/>
+                <a16:creationId xmlns:a16="http://schemas.microsoft.com/office/drawing/2014/main" id="{CB7C9051-2DAB-0B87-264F-EEC476338184}"/>
               </a:ext>
             </a:extLst>
           </p:cNvPr>
@@ -6762,7 +6762,7 @@
           <p:cNvPr id="17" name="TextBox 16">
             <a:extLst>
               <a:ext uri="{FF2B5EF4-FFF2-40B4-BE49-F238E27FC236}">
-                <a16:creationId xmlns:a16="http://schemas.microsoft.com/office/drawing/2014/main" id="{EE85D087-CE7F-30BC-B509-8D4BB4370795}"/>
+                <a16:creationId xmlns:a16="http://schemas.microsoft.com/office/drawing/2014/main" id="{2AB56694-479B-2744-C634-849787BFB19B}"/>
               </a:ext>
             </a:extLst>
           </p:cNvPr>
@@ -6808,7 +6808,7 @@
           <p:cNvPr id="18" name="TextBox 17">
             <a:extLst>
               <a:ext uri="{FF2B5EF4-FFF2-40B4-BE49-F238E27FC236}">
-                <a16:creationId xmlns:a16="http://schemas.microsoft.com/office/drawing/2014/main" id="{B79A49EF-BE71-CB5C-5076-17F44F12F610}"/>
+                <a16:creationId xmlns:a16="http://schemas.microsoft.com/office/drawing/2014/main" id="{52AEE2E3-48AC-120E-95B0-9E6DAE3E6547}"/>
               </a:ext>
             </a:extLst>
           </p:cNvPr>
@@ -6854,7 +6854,7 @@
           <p:cNvPr id="19" name="TextBox 18">
             <a:extLst>
               <a:ext uri="{FF2B5EF4-FFF2-40B4-BE49-F238E27FC236}">
-                <a16:creationId xmlns:a16="http://schemas.microsoft.com/office/drawing/2014/main" id="{9B06D1F3-F123-A6AB-F0C5-D251ADF1C516}"/>
+                <a16:creationId xmlns:a16="http://schemas.microsoft.com/office/drawing/2014/main" id="{06F2DB36-FE68-D488-186B-DC0756F05DF3}"/>
               </a:ext>
             </a:extLst>
           </p:cNvPr>
@@ -6900,7 +6900,7 @@
           <p:cNvPr id="20" name="TextBox 19">
             <a:extLst>
               <a:ext uri="{FF2B5EF4-FFF2-40B4-BE49-F238E27FC236}">
-                <a16:creationId xmlns:a16="http://schemas.microsoft.com/office/drawing/2014/main" id="{2A52B7AC-8B96-1723-600F-21BF8FDF4D23}"/>
+                <a16:creationId xmlns:a16="http://schemas.microsoft.com/office/drawing/2014/main" id="{440FB0B1-488D-790B-E51F-2DDBA1432F2B}"/>
               </a:ext>
             </a:extLst>
           </p:cNvPr>
@@ -6946,7 +6946,7 @@
           <p:cNvPr id="21" name="TextBox 20">
             <a:extLst>
               <a:ext uri="{FF2B5EF4-FFF2-40B4-BE49-F238E27FC236}">
-                <a16:creationId xmlns:a16="http://schemas.microsoft.com/office/drawing/2014/main" id="{87422324-85C0-21F7-33DA-3F188D87EED2}"/>
+                <a16:creationId xmlns:a16="http://schemas.microsoft.com/office/drawing/2014/main" id="{F0308EEC-A508-DE6F-0B1E-2EF831C31C17}"/>
               </a:ext>
             </a:extLst>
           </p:cNvPr>
@@ -6985,7 +6985,7 @@
     </p:spTree>
     <p:extLst>
       <p:ext uri="{BB962C8B-B14F-4D97-AF65-F5344CB8AC3E}">
-        <p14:creationId xmlns:p14="http://schemas.microsoft.com/office/powerpoint/2010/main" val="1135116770"/>
+        <p14:creationId xmlns:p14="http://schemas.microsoft.com/office/powerpoint/2010/main" val="3347263254"/>
       </p:ext>
     </p:extLst>
   </p:cSld>

</xml_diff>

<commit_message>
Clarify speaker notes on reproducibility
</commit_message>
<xml_diff>
--- a/slides/FA24-BED-046.pptx
+++ b/slides/FA24-BED-046.pptx
@@ -193,7 +193,7 @@
             </a:lvl1pPr>
           </a:lstStyle>
           <a:p>
-            <a:fld id="{EFED064A-707A-4B4D-9314-C21163F5059B}" type="datetimeFigureOut">
+            <a:fld id="{8879FFDE-A688-4E73-B6CD-C2CF5B476F3C}" type="datetimeFigureOut">
               <a:rPr lang="en-PK" smtClean="0"/>
               <a:t>26/10/2026</a:t>
             </a:fld>
@@ -352,7 +352,7 @@
             </a:lvl1pPr>
           </a:lstStyle>
           <a:p>
-            <a:fld id="{5217D443-F693-413D-B0FD-0B0A9BFF7ADA}" type="slidenum">
+            <a:fld id="{B3CBD612-EE2E-4062-A379-1D9ECCFD5960}" type="slidenum">
               <a:rPr lang="en-PK" smtClean="0"/>
               <a:t>‹#›</a:t>
             </a:fld>
@@ -363,7 +363,7 @@
     </p:spTree>
     <p:extLst>
       <p:ext uri="{BB962C8B-B14F-4D97-AF65-F5344CB8AC3E}">
-        <p14:creationId xmlns:p14="http://schemas.microsoft.com/office/powerpoint/2010/main" val="375702677"/>
+        <p14:creationId xmlns:p14="http://schemas.microsoft.com/office/powerpoint/2010/main" val="987007836"/>
       </p:ext>
     </p:extLst>
   </p:cSld>
@@ -509,7 +509,7 @@
           <a:p>
             <a:r>
               <a:rPr lang="en-US"/>
-              <a:t>I am FA24-BED-046, Section B. My variant is 6: Balochistan rural, which means prov_code 4 and urban_rural 1. The sample is 8,463 persons in 1,505 households. The literacy sample is 5,677 persons aged 10 to 64, and the education-spending sample is 1,464 students. Every estimate is weighted by hhweight. The repository contains the data, the scripts, the SVG figures, the band table, and this deck; run_all.R rebuilds everything offline.</a:t>
+              <a:t>I am FA24-BED-046, Section B. My variant is 6: Balochistan rural, which means prov_code 4 and urban_rural 1. The sample is 8,463 persons in 1,505 households. The literacy sample is 5,677 persons aged 10 to 64, and the education-spending sample is 1,464 students. Every estimate is weighted by hhweight. The repository contains the data, the scripts, the SVG figures, the band table, and this deck; run_all.R rebuilds every figure and table offline.</a:t>
             </a:r>
             <a:endParaRPr lang="en-PK"/>
           </a:p>
@@ -530,7 +530,7 @@
           <a:bodyPr/>
           <a:lstStyle/>
           <a:p>
-            <a:fld id="{5217D443-F693-413D-B0FD-0B0A9BFF7ADA}" type="slidenum">
+            <a:fld id="{B3CBD612-EE2E-4062-A379-1D9ECCFD5960}" type="slidenum">
               <a:rPr lang="en-PK" smtClean="0"/>
               <a:t>1</a:t>
             </a:fld>
@@ -541,7 +541,7 @@
     </p:spTree>
     <p:extLst>
       <p:ext uri="{BB962C8B-B14F-4D97-AF65-F5344CB8AC3E}">
-        <p14:creationId xmlns:p14="http://schemas.microsoft.com/office/powerpoint/2010/main" val="3631444108"/>
+        <p14:creationId xmlns:p14="http://schemas.microsoft.com/office/powerpoint/2010/main" val="193689493"/>
       </p:ext>
     </p:extLst>
   </p:cSld>
@@ -618,7 +618,7 @@
           <a:bodyPr/>
           <a:lstStyle/>
           <a:p>
-            <a:fld id="{5217D443-F693-413D-B0FD-0B0A9BFF7ADA}" type="slidenum">
+            <a:fld id="{B3CBD612-EE2E-4062-A379-1D9ECCFD5960}" type="slidenum">
               <a:rPr lang="en-PK" smtClean="0"/>
               <a:t>2</a:t>
             </a:fld>
@@ -629,7 +629,7 @@
     </p:spTree>
     <p:extLst>
       <p:ext uri="{BB962C8B-B14F-4D97-AF65-F5344CB8AC3E}">
-        <p14:creationId xmlns:p14="http://schemas.microsoft.com/office/powerpoint/2010/main" val="2067871549"/>
+        <p14:creationId xmlns:p14="http://schemas.microsoft.com/office/powerpoint/2010/main" val="3333561611"/>
       </p:ext>
     </p:extLst>
   </p:cSld>
@@ -706,7 +706,7 @@
           <a:bodyPr/>
           <a:lstStyle/>
           <a:p>
-            <a:fld id="{5217D443-F693-413D-B0FD-0B0A9BFF7ADA}" type="slidenum">
+            <a:fld id="{B3CBD612-EE2E-4062-A379-1D9ECCFD5960}" type="slidenum">
               <a:rPr lang="en-PK" smtClean="0"/>
               <a:t>3</a:t>
             </a:fld>
@@ -717,7 +717,7 @@
     </p:spTree>
     <p:extLst>
       <p:ext uri="{BB962C8B-B14F-4D97-AF65-F5344CB8AC3E}">
-        <p14:creationId xmlns:p14="http://schemas.microsoft.com/office/powerpoint/2010/main" val="1195439284"/>
+        <p14:creationId xmlns:p14="http://schemas.microsoft.com/office/powerpoint/2010/main" val="1482580189"/>
       </p:ext>
     </p:extLst>
   </p:cSld>
@@ -773,7 +773,7 @@
           <a:p>
             <a:r>
               <a:rPr lang="en-US"/>
-              <a:t>For the second language I used Python. It reads the same local CSVs, applies the same variant filter and age bands, and computes the same weighted means. The band tables agree to one decimal, and the maximum absolute difference before rounding is zero. The main default I had to override was the vertical axis: matplotlib autoscaled to the data, so I fixed it at 0 to 100 to match R. The whole repository rebuilds with Rscript scripts/run_all.R, with no internet. The spending figure gives the other headline: the weighted median is Rs 3,500 and the 90th percentile is 31 times the 10th.</a:t>
+              <a:t>For the second language I used Python. It reads the same local CSVs, applies the same variant filter and age bands, and computes the same weighted means. The band tables agree to one decimal, and the maximum absolute difference before rounding is zero. The main default I had to override was the vertical axis: matplotlib autoscaled to the data, so I fixed it at 0 to 100 to match R. Every figure and table rebuilds with Rscript scripts/run_all.R, with no internet. The spending figure gives the other headline: the weighted median is Rs 3,500 and the 90th percentile is 31 times the 10th.</a:t>
             </a:r>
             <a:endParaRPr lang="en-PK"/>
           </a:p>
@@ -794,7 +794,7 @@
           <a:bodyPr/>
           <a:lstStyle/>
           <a:p>
-            <a:fld id="{5217D443-F693-413D-B0FD-0B0A9BFF7ADA}" type="slidenum">
+            <a:fld id="{B3CBD612-EE2E-4062-A379-1D9ECCFD5960}" type="slidenum">
               <a:rPr lang="en-PK" smtClean="0"/>
               <a:t>4</a:t>
             </a:fld>
@@ -805,7 +805,7 @@
     </p:spTree>
     <p:extLst>
       <p:ext uri="{BB962C8B-B14F-4D97-AF65-F5344CB8AC3E}">
-        <p14:creationId xmlns:p14="http://schemas.microsoft.com/office/powerpoint/2010/main" val="1364855781"/>
+        <p14:creationId xmlns:p14="http://schemas.microsoft.com/office/powerpoint/2010/main" val="1105296978"/>
       </p:ext>
     </p:extLst>
   </p:cSld>
@@ -837,7 +837,7 @@
           <p:cNvPr id="2" name="Title 1">
             <a:extLst>
               <a:ext uri="{FF2B5EF4-FFF2-40B4-BE49-F238E27FC236}">
-                <a16:creationId xmlns:a16="http://schemas.microsoft.com/office/drawing/2014/main" id="{161DA185-B5F9-17AF-92BF-DFE990611A25}"/>
+                <a16:creationId xmlns:a16="http://schemas.microsoft.com/office/drawing/2014/main" id="{FD45B79D-2408-A2B6-BAEA-F095D468FFE2}"/>
               </a:ext>
             </a:extLst>
           </p:cNvPr>
@@ -875,7 +875,7 @@
           <p:cNvPr id="3" name="Subtitle 2">
             <a:extLst>
               <a:ext uri="{FF2B5EF4-FFF2-40B4-BE49-F238E27FC236}">
-                <a16:creationId xmlns:a16="http://schemas.microsoft.com/office/drawing/2014/main" id="{C59A4C2D-FEBC-04F6-9924-AF5DBDFC11B7}"/>
+                <a16:creationId xmlns:a16="http://schemas.microsoft.com/office/drawing/2014/main" id="{F3972CE2-59A6-D384-55DE-E871D3B896E2}"/>
               </a:ext>
             </a:extLst>
           </p:cNvPr>
@@ -946,7 +946,7 @@
           <p:cNvPr id="4" name="Date Placeholder 3">
             <a:extLst>
               <a:ext uri="{FF2B5EF4-FFF2-40B4-BE49-F238E27FC236}">
-                <a16:creationId xmlns:a16="http://schemas.microsoft.com/office/drawing/2014/main" id="{437CC80B-39C9-38BE-97C1-255A70B4FB6C}"/>
+                <a16:creationId xmlns:a16="http://schemas.microsoft.com/office/drawing/2014/main" id="{2C64AD35-A327-61D9-0E2D-5C0D3FEDC2D2}"/>
               </a:ext>
             </a:extLst>
           </p:cNvPr>
@@ -962,7 +962,7 @@
           <a:bodyPr/>
           <a:lstStyle/>
           <a:p>
-            <a:fld id="{187C6756-6102-4259-B40B-0718AF07DF35}" type="datetimeFigureOut">
+            <a:fld id="{3E13F701-25CE-4D2B-8B3E-C45F0907FFE9}" type="datetimeFigureOut">
               <a:rPr lang="en-PK" smtClean="0"/>
               <a:t>26/10/2026</a:t>
             </a:fld>
@@ -975,7 +975,7 @@
           <p:cNvPr id="5" name="Footer Placeholder 4">
             <a:extLst>
               <a:ext uri="{FF2B5EF4-FFF2-40B4-BE49-F238E27FC236}">
-                <a16:creationId xmlns:a16="http://schemas.microsoft.com/office/drawing/2014/main" id="{9AEE888A-667F-B38E-9944-198E81A1B132}"/>
+                <a16:creationId xmlns:a16="http://schemas.microsoft.com/office/drawing/2014/main" id="{EED93113-BC3F-EBB6-4022-CD08257608DE}"/>
               </a:ext>
             </a:extLst>
           </p:cNvPr>
@@ -1000,7 +1000,7 @@
           <p:cNvPr id="6" name="Slide Number Placeholder 5">
             <a:extLst>
               <a:ext uri="{FF2B5EF4-FFF2-40B4-BE49-F238E27FC236}">
-                <a16:creationId xmlns:a16="http://schemas.microsoft.com/office/drawing/2014/main" id="{13C6D513-EE62-04BF-0B44-6B0BECCF9326}"/>
+                <a16:creationId xmlns:a16="http://schemas.microsoft.com/office/drawing/2014/main" id="{DC5C17CF-6210-DE4B-0CEA-533BFDF52897}"/>
               </a:ext>
             </a:extLst>
           </p:cNvPr>
@@ -1016,7 +1016,7 @@
           <a:bodyPr/>
           <a:lstStyle/>
           <a:p>
-            <a:fld id="{64F069EE-6B3C-43A6-BA10-5D41419D3069}" type="slidenum">
+            <a:fld id="{FB258019-6AB0-4EA7-82CF-AD3D5CBF336E}" type="slidenum">
               <a:rPr lang="en-PK" smtClean="0"/>
               <a:t>‹#›</a:t>
             </a:fld>
@@ -1027,7 +1027,7 @@
     </p:spTree>
     <p:extLst>
       <p:ext uri="{BB962C8B-B14F-4D97-AF65-F5344CB8AC3E}">
-        <p14:creationId xmlns:p14="http://schemas.microsoft.com/office/powerpoint/2010/main" val="623159226"/>
+        <p14:creationId xmlns:p14="http://schemas.microsoft.com/office/powerpoint/2010/main" val="1440186520"/>
       </p:ext>
     </p:extLst>
   </p:cSld>
@@ -1059,7 +1059,7 @@
           <p:cNvPr id="2" name="Title 1">
             <a:extLst>
               <a:ext uri="{FF2B5EF4-FFF2-40B4-BE49-F238E27FC236}">
-                <a16:creationId xmlns:a16="http://schemas.microsoft.com/office/drawing/2014/main" id="{A8D7121A-7B85-FAD4-9FC7-7EE9CFFBB92F}"/>
+                <a16:creationId xmlns:a16="http://schemas.microsoft.com/office/drawing/2014/main" id="{B91F48F6-0F7B-9A76-7847-CB86E2E9083C}"/>
               </a:ext>
             </a:extLst>
           </p:cNvPr>
@@ -1088,7 +1088,7 @@
           <p:cNvPr id="3" name="Vertical Text Placeholder 2">
             <a:extLst>
               <a:ext uri="{FF2B5EF4-FFF2-40B4-BE49-F238E27FC236}">
-                <a16:creationId xmlns:a16="http://schemas.microsoft.com/office/drawing/2014/main" id="{89A08888-EBD9-56CC-D88C-555A12457BB0}"/>
+                <a16:creationId xmlns:a16="http://schemas.microsoft.com/office/drawing/2014/main" id="{A1C96010-D0A3-722E-1BE1-3CAB5E8B4799}"/>
               </a:ext>
             </a:extLst>
           </p:cNvPr>
@@ -1146,7 +1146,7 @@
           <p:cNvPr id="4" name="Date Placeholder 3">
             <a:extLst>
               <a:ext uri="{FF2B5EF4-FFF2-40B4-BE49-F238E27FC236}">
-                <a16:creationId xmlns:a16="http://schemas.microsoft.com/office/drawing/2014/main" id="{54356BE8-F4D9-D317-2305-E8118736E013}"/>
+                <a16:creationId xmlns:a16="http://schemas.microsoft.com/office/drawing/2014/main" id="{8880622C-55F0-405C-9726-D4CA7329708E}"/>
               </a:ext>
             </a:extLst>
           </p:cNvPr>
@@ -1162,7 +1162,7 @@
           <a:bodyPr/>
           <a:lstStyle/>
           <a:p>
-            <a:fld id="{187C6756-6102-4259-B40B-0718AF07DF35}" type="datetimeFigureOut">
+            <a:fld id="{3E13F701-25CE-4D2B-8B3E-C45F0907FFE9}" type="datetimeFigureOut">
               <a:rPr lang="en-PK" smtClean="0"/>
               <a:t>26/10/2026</a:t>
             </a:fld>
@@ -1175,7 +1175,7 @@
           <p:cNvPr id="5" name="Footer Placeholder 4">
             <a:extLst>
               <a:ext uri="{FF2B5EF4-FFF2-40B4-BE49-F238E27FC236}">
-                <a16:creationId xmlns:a16="http://schemas.microsoft.com/office/drawing/2014/main" id="{2BFE0954-35DD-15AC-4C53-1EE9152FAB24}"/>
+                <a16:creationId xmlns:a16="http://schemas.microsoft.com/office/drawing/2014/main" id="{A121E430-F49B-764A-6F21-0CC8DA427E82}"/>
               </a:ext>
             </a:extLst>
           </p:cNvPr>
@@ -1200,7 +1200,7 @@
           <p:cNvPr id="6" name="Slide Number Placeholder 5">
             <a:extLst>
               <a:ext uri="{FF2B5EF4-FFF2-40B4-BE49-F238E27FC236}">
-                <a16:creationId xmlns:a16="http://schemas.microsoft.com/office/drawing/2014/main" id="{449F0FA2-CB36-5033-F957-D5C61F1B1DAC}"/>
+                <a16:creationId xmlns:a16="http://schemas.microsoft.com/office/drawing/2014/main" id="{CE906233-3B3C-0FED-0C24-852A3BCB6758}"/>
               </a:ext>
             </a:extLst>
           </p:cNvPr>
@@ -1216,7 +1216,7 @@
           <a:bodyPr/>
           <a:lstStyle/>
           <a:p>
-            <a:fld id="{64F069EE-6B3C-43A6-BA10-5D41419D3069}" type="slidenum">
+            <a:fld id="{FB258019-6AB0-4EA7-82CF-AD3D5CBF336E}" type="slidenum">
               <a:rPr lang="en-PK" smtClean="0"/>
               <a:t>‹#›</a:t>
             </a:fld>
@@ -1227,7 +1227,7 @@
     </p:spTree>
     <p:extLst>
       <p:ext uri="{BB962C8B-B14F-4D97-AF65-F5344CB8AC3E}">
-        <p14:creationId xmlns:p14="http://schemas.microsoft.com/office/powerpoint/2010/main" val="717069895"/>
+        <p14:creationId xmlns:p14="http://schemas.microsoft.com/office/powerpoint/2010/main" val="964899931"/>
       </p:ext>
     </p:extLst>
   </p:cSld>
@@ -1259,7 +1259,7 @@
           <p:cNvPr id="2" name="Vertical Title 1">
             <a:extLst>
               <a:ext uri="{FF2B5EF4-FFF2-40B4-BE49-F238E27FC236}">
-                <a16:creationId xmlns:a16="http://schemas.microsoft.com/office/drawing/2014/main" id="{5D1A27AD-9645-8072-C9BA-891B7BA5BB47}"/>
+                <a16:creationId xmlns:a16="http://schemas.microsoft.com/office/drawing/2014/main" id="{F94725D4-B84F-B9D0-863C-3F08C247B2BD}"/>
               </a:ext>
             </a:extLst>
           </p:cNvPr>
@@ -1293,7 +1293,7 @@
           <p:cNvPr id="3" name="Vertical Text Placeholder 2">
             <a:extLst>
               <a:ext uri="{FF2B5EF4-FFF2-40B4-BE49-F238E27FC236}">
-                <a16:creationId xmlns:a16="http://schemas.microsoft.com/office/drawing/2014/main" id="{86E36AB0-8575-3D1E-A554-E3DE7998EE56}"/>
+                <a16:creationId xmlns:a16="http://schemas.microsoft.com/office/drawing/2014/main" id="{3FB34C7F-6DD6-067C-225C-E43113476228}"/>
               </a:ext>
             </a:extLst>
           </p:cNvPr>
@@ -1356,7 +1356,7 @@
           <p:cNvPr id="4" name="Date Placeholder 3">
             <a:extLst>
               <a:ext uri="{FF2B5EF4-FFF2-40B4-BE49-F238E27FC236}">
-                <a16:creationId xmlns:a16="http://schemas.microsoft.com/office/drawing/2014/main" id="{6CF958C1-1D4C-A6CF-9599-615150B10A1B}"/>
+                <a16:creationId xmlns:a16="http://schemas.microsoft.com/office/drawing/2014/main" id="{35E4D1E6-721D-04D8-6927-6338833456AC}"/>
               </a:ext>
             </a:extLst>
           </p:cNvPr>
@@ -1372,7 +1372,7 @@
           <a:bodyPr/>
           <a:lstStyle/>
           <a:p>
-            <a:fld id="{187C6756-6102-4259-B40B-0718AF07DF35}" type="datetimeFigureOut">
+            <a:fld id="{3E13F701-25CE-4D2B-8B3E-C45F0907FFE9}" type="datetimeFigureOut">
               <a:rPr lang="en-PK" smtClean="0"/>
               <a:t>26/10/2026</a:t>
             </a:fld>
@@ -1385,7 +1385,7 @@
           <p:cNvPr id="5" name="Footer Placeholder 4">
             <a:extLst>
               <a:ext uri="{FF2B5EF4-FFF2-40B4-BE49-F238E27FC236}">
-                <a16:creationId xmlns:a16="http://schemas.microsoft.com/office/drawing/2014/main" id="{8CBF69DF-2FF5-ACD9-D330-4D9781DAFB0C}"/>
+                <a16:creationId xmlns:a16="http://schemas.microsoft.com/office/drawing/2014/main" id="{5377AE2E-AD4E-717D-55C5-00C66F2630DA}"/>
               </a:ext>
             </a:extLst>
           </p:cNvPr>
@@ -1410,7 +1410,7 @@
           <p:cNvPr id="6" name="Slide Number Placeholder 5">
             <a:extLst>
               <a:ext uri="{FF2B5EF4-FFF2-40B4-BE49-F238E27FC236}">
-                <a16:creationId xmlns:a16="http://schemas.microsoft.com/office/drawing/2014/main" id="{081E7884-49C2-592C-8B18-BB748EFCE0C1}"/>
+                <a16:creationId xmlns:a16="http://schemas.microsoft.com/office/drawing/2014/main" id="{8F76512C-1172-10D4-273F-4C238C7A0B80}"/>
               </a:ext>
             </a:extLst>
           </p:cNvPr>
@@ -1426,7 +1426,7 @@
           <a:bodyPr/>
           <a:lstStyle/>
           <a:p>
-            <a:fld id="{64F069EE-6B3C-43A6-BA10-5D41419D3069}" type="slidenum">
+            <a:fld id="{FB258019-6AB0-4EA7-82CF-AD3D5CBF336E}" type="slidenum">
               <a:rPr lang="en-PK" smtClean="0"/>
               <a:t>‹#›</a:t>
             </a:fld>
@@ -1437,7 +1437,7 @@
     </p:spTree>
     <p:extLst>
       <p:ext uri="{BB962C8B-B14F-4D97-AF65-F5344CB8AC3E}">
-        <p14:creationId xmlns:p14="http://schemas.microsoft.com/office/powerpoint/2010/main" val="2755399582"/>
+        <p14:creationId xmlns:p14="http://schemas.microsoft.com/office/powerpoint/2010/main" val="474650145"/>
       </p:ext>
     </p:extLst>
   </p:cSld>
@@ -1469,7 +1469,7 @@
           <p:cNvPr id="2" name="Title 1">
             <a:extLst>
               <a:ext uri="{FF2B5EF4-FFF2-40B4-BE49-F238E27FC236}">
-                <a16:creationId xmlns:a16="http://schemas.microsoft.com/office/drawing/2014/main" id="{D2212DD9-CBD0-A137-F1AD-EFDA738EA241}"/>
+                <a16:creationId xmlns:a16="http://schemas.microsoft.com/office/drawing/2014/main" id="{A2027441-F22C-57A8-79AE-04F5F876675C}"/>
               </a:ext>
             </a:extLst>
           </p:cNvPr>
@@ -1498,7 +1498,7 @@
           <p:cNvPr id="3" name="Content Placeholder 2">
             <a:extLst>
               <a:ext uri="{FF2B5EF4-FFF2-40B4-BE49-F238E27FC236}">
-                <a16:creationId xmlns:a16="http://schemas.microsoft.com/office/drawing/2014/main" id="{2E847E44-C3A9-3B2A-592F-E2EE27273A34}"/>
+                <a16:creationId xmlns:a16="http://schemas.microsoft.com/office/drawing/2014/main" id="{68A7DB99-38DC-BE04-CD6C-E3AFF8F34754}"/>
               </a:ext>
             </a:extLst>
           </p:cNvPr>
@@ -1556,7 +1556,7 @@
           <p:cNvPr id="4" name="Date Placeholder 3">
             <a:extLst>
               <a:ext uri="{FF2B5EF4-FFF2-40B4-BE49-F238E27FC236}">
-                <a16:creationId xmlns:a16="http://schemas.microsoft.com/office/drawing/2014/main" id="{337EA09E-4BF7-9138-A9FF-6793AB733103}"/>
+                <a16:creationId xmlns:a16="http://schemas.microsoft.com/office/drawing/2014/main" id="{98CFDF2F-974F-7FA6-A75C-EF0562E9B531}"/>
               </a:ext>
             </a:extLst>
           </p:cNvPr>
@@ -1572,7 +1572,7 @@
           <a:bodyPr/>
           <a:lstStyle/>
           <a:p>
-            <a:fld id="{187C6756-6102-4259-B40B-0718AF07DF35}" type="datetimeFigureOut">
+            <a:fld id="{3E13F701-25CE-4D2B-8B3E-C45F0907FFE9}" type="datetimeFigureOut">
               <a:rPr lang="en-PK" smtClean="0"/>
               <a:t>26/10/2026</a:t>
             </a:fld>
@@ -1585,7 +1585,7 @@
           <p:cNvPr id="5" name="Footer Placeholder 4">
             <a:extLst>
               <a:ext uri="{FF2B5EF4-FFF2-40B4-BE49-F238E27FC236}">
-                <a16:creationId xmlns:a16="http://schemas.microsoft.com/office/drawing/2014/main" id="{288DE42F-F6F4-5B62-76D2-A714224BE366}"/>
+                <a16:creationId xmlns:a16="http://schemas.microsoft.com/office/drawing/2014/main" id="{66DB644D-83E3-AB36-EA38-3DD568E135D5}"/>
               </a:ext>
             </a:extLst>
           </p:cNvPr>
@@ -1610,7 +1610,7 @@
           <p:cNvPr id="6" name="Slide Number Placeholder 5">
             <a:extLst>
               <a:ext uri="{FF2B5EF4-FFF2-40B4-BE49-F238E27FC236}">
-                <a16:creationId xmlns:a16="http://schemas.microsoft.com/office/drawing/2014/main" id="{BDE42766-1D78-5DA5-C461-006502278CCA}"/>
+                <a16:creationId xmlns:a16="http://schemas.microsoft.com/office/drawing/2014/main" id="{0EDACD1D-EA03-DD08-9552-63D6BC992096}"/>
               </a:ext>
             </a:extLst>
           </p:cNvPr>
@@ -1626,7 +1626,7 @@
           <a:bodyPr/>
           <a:lstStyle/>
           <a:p>
-            <a:fld id="{64F069EE-6B3C-43A6-BA10-5D41419D3069}" type="slidenum">
+            <a:fld id="{FB258019-6AB0-4EA7-82CF-AD3D5CBF336E}" type="slidenum">
               <a:rPr lang="en-PK" smtClean="0"/>
               <a:t>‹#›</a:t>
             </a:fld>
@@ -1637,7 +1637,7 @@
     </p:spTree>
     <p:extLst>
       <p:ext uri="{BB962C8B-B14F-4D97-AF65-F5344CB8AC3E}">
-        <p14:creationId xmlns:p14="http://schemas.microsoft.com/office/powerpoint/2010/main" val="900979404"/>
+        <p14:creationId xmlns:p14="http://schemas.microsoft.com/office/powerpoint/2010/main" val="3112609619"/>
       </p:ext>
     </p:extLst>
   </p:cSld>
@@ -1669,7 +1669,7 @@
           <p:cNvPr id="2" name="Title 1">
             <a:extLst>
               <a:ext uri="{FF2B5EF4-FFF2-40B4-BE49-F238E27FC236}">
-                <a16:creationId xmlns:a16="http://schemas.microsoft.com/office/drawing/2014/main" id="{869F54E2-F7B6-005C-FA6A-97C25F5E315D}"/>
+                <a16:creationId xmlns:a16="http://schemas.microsoft.com/office/drawing/2014/main" id="{C540A525-5E13-F6C0-0B1A-2211D9F6B9F5}"/>
               </a:ext>
             </a:extLst>
           </p:cNvPr>
@@ -1707,7 +1707,7 @@
           <p:cNvPr id="3" name="Text Placeholder 2">
             <a:extLst>
               <a:ext uri="{FF2B5EF4-FFF2-40B4-BE49-F238E27FC236}">
-                <a16:creationId xmlns:a16="http://schemas.microsoft.com/office/drawing/2014/main" id="{1242E04D-68FA-D5C0-56CC-803560AC2957}"/>
+                <a16:creationId xmlns:a16="http://schemas.microsoft.com/office/drawing/2014/main" id="{7B3146EF-7B93-8328-3DE5-32213E72DD86}"/>
               </a:ext>
             </a:extLst>
           </p:cNvPr>
@@ -1832,7 +1832,7 @@
           <p:cNvPr id="4" name="Date Placeholder 3">
             <a:extLst>
               <a:ext uri="{FF2B5EF4-FFF2-40B4-BE49-F238E27FC236}">
-                <a16:creationId xmlns:a16="http://schemas.microsoft.com/office/drawing/2014/main" id="{576FE50A-B86D-575A-DE19-7863FBEBF0D1}"/>
+                <a16:creationId xmlns:a16="http://schemas.microsoft.com/office/drawing/2014/main" id="{A9433486-0746-C555-6D7E-D03A29A3D6FB}"/>
               </a:ext>
             </a:extLst>
           </p:cNvPr>
@@ -1848,7 +1848,7 @@
           <a:bodyPr/>
           <a:lstStyle/>
           <a:p>
-            <a:fld id="{187C6756-6102-4259-B40B-0718AF07DF35}" type="datetimeFigureOut">
+            <a:fld id="{3E13F701-25CE-4D2B-8B3E-C45F0907FFE9}" type="datetimeFigureOut">
               <a:rPr lang="en-PK" smtClean="0"/>
               <a:t>26/10/2026</a:t>
             </a:fld>
@@ -1861,7 +1861,7 @@
           <p:cNvPr id="5" name="Footer Placeholder 4">
             <a:extLst>
               <a:ext uri="{FF2B5EF4-FFF2-40B4-BE49-F238E27FC236}">
-                <a16:creationId xmlns:a16="http://schemas.microsoft.com/office/drawing/2014/main" id="{0AA2670E-D1FD-E09D-A5F4-95CE1E1C91AF}"/>
+                <a16:creationId xmlns:a16="http://schemas.microsoft.com/office/drawing/2014/main" id="{802AA8A0-8594-EF05-63B4-17755CAD8196}"/>
               </a:ext>
             </a:extLst>
           </p:cNvPr>
@@ -1886,7 +1886,7 @@
           <p:cNvPr id="6" name="Slide Number Placeholder 5">
             <a:extLst>
               <a:ext uri="{FF2B5EF4-FFF2-40B4-BE49-F238E27FC236}">
-                <a16:creationId xmlns:a16="http://schemas.microsoft.com/office/drawing/2014/main" id="{2112146A-53E6-DEBE-4E9A-F52402CE3234}"/>
+                <a16:creationId xmlns:a16="http://schemas.microsoft.com/office/drawing/2014/main" id="{C95E2D6B-F668-B9CE-2CF1-475F27E62AE7}"/>
               </a:ext>
             </a:extLst>
           </p:cNvPr>
@@ -1902,7 +1902,7 @@
           <a:bodyPr/>
           <a:lstStyle/>
           <a:p>
-            <a:fld id="{64F069EE-6B3C-43A6-BA10-5D41419D3069}" type="slidenum">
+            <a:fld id="{FB258019-6AB0-4EA7-82CF-AD3D5CBF336E}" type="slidenum">
               <a:rPr lang="en-PK" smtClean="0"/>
               <a:t>‹#›</a:t>
             </a:fld>
@@ -1913,7 +1913,7 @@
     </p:spTree>
     <p:extLst>
       <p:ext uri="{BB962C8B-B14F-4D97-AF65-F5344CB8AC3E}">
-        <p14:creationId xmlns:p14="http://schemas.microsoft.com/office/powerpoint/2010/main" val="311571372"/>
+        <p14:creationId xmlns:p14="http://schemas.microsoft.com/office/powerpoint/2010/main" val="3992832941"/>
       </p:ext>
     </p:extLst>
   </p:cSld>
@@ -1945,7 +1945,7 @@
           <p:cNvPr id="2" name="Title 1">
             <a:extLst>
               <a:ext uri="{FF2B5EF4-FFF2-40B4-BE49-F238E27FC236}">
-                <a16:creationId xmlns:a16="http://schemas.microsoft.com/office/drawing/2014/main" id="{A70D58D9-65B2-51F2-A4C8-47ADC6FF34B7}"/>
+                <a16:creationId xmlns:a16="http://schemas.microsoft.com/office/drawing/2014/main" id="{7D257C25-E223-6321-6C8A-131724D481B7}"/>
               </a:ext>
             </a:extLst>
           </p:cNvPr>
@@ -1974,7 +1974,7 @@
           <p:cNvPr id="3" name="Content Placeholder 2">
             <a:extLst>
               <a:ext uri="{FF2B5EF4-FFF2-40B4-BE49-F238E27FC236}">
-                <a16:creationId xmlns:a16="http://schemas.microsoft.com/office/drawing/2014/main" id="{2AE24E67-560A-A8B9-ECA5-EB089A2E3AB9}"/>
+                <a16:creationId xmlns:a16="http://schemas.microsoft.com/office/drawing/2014/main" id="{5342A964-11FC-A0C0-68D8-F0A0D2476C3A}"/>
               </a:ext>
             </a:extLst>
           </p:cNvPr>
@@ -2037,7 +2037,7 @@
           <p:cNvPr id="4" name="Content Placeholder 3">
             <a:extLst>
               <a:ext uri="{FF2B5EF4-FFF2-40B4-BE49-F238E27FC236}">
-                <a16:creationId xmlns:a16="http://schemas.microsoft.com/office/drawing/2014/main" id="{15077557-2EB0-0AEB-55B0-11FC1CF0CE6B}"/>
+                <a16:creationId xmlns:a16="http://schemas.microsoft.com/office/drawing/2014/main" id="{457B8F9B-9D1C-D22B-2511-C887A2420FB5}"/>
               </a:ext>
             </a:extLst>
           </p:cNvPr>
@@ -2100,7 +2100,7 @@
           <p:cNvPr id="5" name="Date Placeholder 4">
             <a:extLst>
               <a:ext uri="{FF2B5EF4-FFF2-40B4-BE49-F238E27FC236}">
-                <a16:creationId xmlns:a16="http://schemas.microsoft.com/office/drawing/2014/main" id="{DA2F1DA9-B99A-A1AA-DE36-B95B9C5AA9B7}"/>
+                <a16:creationId xmlns:a16="http://schemas.microsoft.com/office/drawing/2014/main" id="{C59AF602-F547-1E0A-EFE0-6C32CD54D84E}"/>
               </a:ext>
             </a:extLst>
           </p:cNvPr>
@@ -2116,7 +2116,7 @@
           <a:bodyPr/>
           <a:lstStyle/>
           <a:p>
-            <a:fld id="{187C6756-6102-4259-B40B-0718AF07DF35}" type="datetimeFigureOut">
+            <a:fld id="{3E13F701-25CE-4D2B-8B3E-C45F0907FFE9}" type="datetimeFigureOut">
               <a:rPr lang="en-PK" smtClean="0"/>
               <a:t>26/10/2026</a:t>
             </a:fld>
@@ -2129,7 +2129,7 @@
           <p:cNvPr id="6" name="Footer Placeholder 5">
             <a:extLst>
               <a:ext uri="{FF2B5EF4-FFF2-40B4-BE49-F238E27FC236}">
-                <a16:creationId xmlns:a16="http://schemas.microsoft.com/office/drawing/2014/main" id="{6D12DDD4-22E9-A086-FB8B-713ACD877320}"/>
+                <a16:creationId xmlns:a16="http://schemas.microsoft.com/office/drawing/2014/main" id="{A8D4E529-33E8-76CB-06B6-39F80FF5C654}"/>
               </a:ext>
             </a:extLst>
           </p:cNvPr>
@@ -2154,7 +2154,7 @@
           <p:cNvPr id="7" name="Slide Number Placeholder 6">
             <a:extLst>
               <a:ext uri="{FF2B5EF4-FFF2-40B4-BE49-F238E27FC236}">
-                <a16:creationId xmlns:a16="http://schemas.microsoft.com/office/drawing/2014/main" id="{BF1DD6FE-A843-FE04-6F41-208D727C8D3D}"/>
+                <a16:creationId xmlns:a16="http://schemas.microsoft.com/office/drawing/2014/main" id="{842B43AA-4F0D-4477-8859-D75155000AF7}"/>
               </a:ext>
             </a:extLst>
           </p:cNvPr>
@@ -2170,7 +2170,7 @@
           <a:bodyPr/>
           <a:lstStyle/>
           <a:p>
-            <a:fld id="{64F069EE-6B3C-43A6-BA10-5D41419D3069}" type="slidenum">
+            <a:fld id="{FB258019-6AB0-4EA7-82CF-AD3D5CBF336E}" type="slidenum">
               <a:rPr lang="en-PK" smtClean="0"/>
               <a:t>‹#›</a:t>
             </a:fld>
@@ -2181,7 +2181,7 @@
     </p:spTree>
     <p:extLst>
       <p:ext uri="{BB962C8B-B14F-4D97-AF65-F5344CB8AC3E}">
-        <p14:creationId xmlns:p14="http://schemas.microsoft.com/office/powerpoint/2010/main" val="846223103"/>
+        <p14:creationId xmlns:p14="http://schemas.microsoft.com/office/powerpoint/2010/main" val="4257219944"/>
       </p:ext>
     </p:extLst>
   </p:cSld>
@@ -2213,7 +2213,7 @@
           <p:cNvPr id="2" name="Title 1">
             <a:extLst>
               <a:ext uri="{FF2B5EF4-FFF2-40B4-BE49-F238E27FC236}">
-                <a16:creationId xmlns:a16="http://schemas.microsoft.com/office/drawing/2014/main" id="{6502574D-9A8B-3528-BA02-B1F0D830E832}"/>
+                <a16:creationId xmlns:a16="http://schemas.microsoft.com/office/drawing/2014/main" id="{A4A87EFD-387F-BC22-238D-837BC6786E16}"/>
               </a:ext>
             </a:extLst>
           </p:cNvPr>
@@ -2247,7 +2247,7 @@
           <p:cNvPr id="3" name="Text Placeholder 2">
             <a:extLst>
               <a:ext uri="{FF2B5EF4-FFF2-40B4-BE49-F238E27FC236}">
-                <a16:creationId xmlns:a16="http://schemas.microsoft.com/office/drawing/2014/main" id="{5D328A40-7BFD-FB69-372F-A8AB39C9800B}"/>
+                <a16:creationId xmlns:a16="http://schemas.microsoft.com/office/drawing/2014/main" id="{F30A3C03-EA86-1445-A7C4-73A2C729A557}"/>
               </a:ext>
             </a:extLst>
           </p:cNvPr>
@@ -2318,7 +2318,7 @@
           <p:cNvPr id="4" name="Content Placeholder 3">
             <a:extLst>
               <a:ext uri="{FF2B5EF4-FFF2-40B4-BE49-F238E27FC236}">
-                <a16:creationId xmlns:a16="http://schemas.microsoft.com/office/drawing/2014/main" id="{3D0983DA-2616-EA03-1770-B164E0382814}"/>
+                <a16:creationId xmlns:a16="http://schemas.microsoft.com/office/drawing/2014/main" id="{B69A0BB6-C555-A90F-C48F-378D2F7E39B9}"/>
               </a:ext>
             </a:extLst>
           </p:cNvPr>
@@ -2381,7 +2381,7 @@
           <p:cNvPr id="5" name="Text Placeholder 4">
             <a:extLst>
               <a:ext uri="{FF2B5EF4-FFF2-40B4-BE49-F238E27FC236}">
-                <a16:creationId xmlns:a16="http://schemas.microsoft.com/office/drawing/2014/main" id="{2E218483-74AC-3806-60D3-E18F15261868}"/>
+                <a16:creationId xmlns:a16="http://schemas.microsoft.com/office/drawing/2014/main" id="{F52B51D9-FCE8-5DB6-52CF-54C0CE8FE685}"/>
               </a:ext>
             </a:extLst>
           </p:cNvPr>
@@ -2452,7 +2452,7 @@
           <p:cNvPr id="6" name="Content Placeholder 5">
             <a:extLst>
               <a:ext uri="{FF2B5EF4-FFF2-40B4-BE49-F238E27FC236}">
-                <a16:creationId xmlns:a16="http://schemas.microsoft.com/office/drawing/2014/main" id="{E33BB180-9CF5-8DFC-06C1-01E98DC5D39B}"/>
+                <a16:creationId xmlns:a16="http://schemas.microsoft.com/office/drawing/2014/main" id="{941AB54E-1458-802E-D5FA-EA7B623282B7}"/>
               </a:ext>
             </a:extLst>
           </p:cNvPr>
@@ -2515,7 +2515,7 @@
           <p:cNvPr id="7" name="Date Placeholder 6">
             <a:extLst>
               <a:ext uri="{FF2B5EF4-FFF2-40B4-BE49-F238E27FC236}">
-                <a16:creationId xmlns:a16="http://schemas.microsoft.com/office/drawing/2014/main" id="{2CEC0C2F-431B-C2B2-5C8D-3BA0674839E4}"/>
+                <a16:creationId xmlns:a16="http://schemas.microsoft.com/office/drawing/2014/main" id="{7E0D72AC-127F-C283-61FC-043334CBDBE9}"/>
               </a:ext>
             </a:extLst>
           </p:cNvPr>
@@ -2531,7 +2531,7 @@
           <a:bodyPr/>
           <a:lstStyle/>
           <a:p>
-            <a:fld id="{187C6756-6102-4259-B40B-0718AF07DF35}" type="datetimeFigureOut">
+            <a:fld id="{3E13F701-25CE-4D2B-8B3E-C45F0907FFE9}" type="datetimeFigureOut">
               <a:rPr lang="en-PK" smtClean="0"/>
               <a:t>26/10/2026</a:t>
             </a:fld>
@@ -2544,7 +2544,7 @@
           <p:cNvPr id="8" name="Footer Placeholder 7">
             <a:extLst>
               <a:ext uri="{FF2B5EF4-FFF2-40B4-BE49-F238E27FC236}">
-                <a16:creationId xmlns:a16="http://schemas.microsoft.com/office/drawing/2014/main" id="{1DADDB03-5491-9E0D-87BB-FC750BC2384B}"/>
+                <a16:creationId xmlns:a16="http://schemas.microsoft.com/office/drawing/2014/main" id="{8BC6C477-BF15-693C-299F-EB1B4455EF0B}"/>
               </a:ext>
             </a:extLst>
           </p:cNvPr>
@@ -2569,7 +2569,7 @@
           <p:cNvPr id="9" name="Slide Number Placeholder 8">
             <a:extLst>
               <a:ext uri="{FF2B5EF4-FFF2-40B4-BE49-F238E27FC236}">
-                <a16:creationId xmlns:a16="http://schemas.microsoft.com/office/drawing/2014/main" id="{28C2EAB3-46AC-8676-B45E-CC8EFE848C17}"/>
+                <a16:creationId xmlns:a16="http://schemas.microsoft.com/office/drawing/2014/main" id="{ED7D80B6-F9CF-68D1-5742-39B07DA06DC9}"/>
               </a:ext>
             </a:extLst>
           </p:cNvPr>
@@ -2585,7 +2585,7 @@
           <a:bodyPr/>
           <a:lstStyle/>
           <a:p>
-            <a:fld id="{64F069EE-6B3C-43A6-BA10-5D41419D3069}" type="slidenum">
+            <a:fld id="{FB258019-6AB0-4EA7-82CF-AD3D5CBF336E}" type="slidenum">
               <a:rPr lang="en-PK" smtClean="0"/>
               <a:t>‹#›</a:t>
             </a:fld>
@@ -2596,7 +2596,7 @@
     </p:spTree>
     <p:extLst>
       <p:ext uri="{BB962C8B-B14F-4D97-AF65-F5344CB8AC3E}">
-        <p14:creationId xmlns:p14="http://schemas.microsoft.com/office/powerpoint/2010/main" val="1895751438"/>
+        <p14:creationId xmlns:p14="http://schemas.microsoft.com/office/powerpoint/2010/main" val="3120983064"/>
       </p:ext>
     </p:extLst>
   </p:cSld>
@@ -2628,7 +2628,7 @@
           <p:cNvPr id="2" name="Title 1">
             <a:extLst>
               <a:ext uri="{FF2B5EF4-FFF2-40B4-BE49-F238E27FC236}">
-                <a16:creationId xmlns:a16="http://schemas.microsoft.com/office/drawing/2014/main" id="{AE2CCDAC-6B23-FE18-4405-0A5B424A6CFA}"/>
+                <a16:creationId xmlns:a16="http://schemas.microsoft.com/office/drawing/2014/main" id="{BBA2B3C8-2D77-18E4-0FDD-4CABADAC8E80}"/>
               </a:ext>
             </a:extLst>
           </p:cNvPr>
@@ -2657,7 +2657,7 @@
           <p:cNvPr id="3" name="Date Placeholder 2">
             <a:extLst>
               <a:ext uri="{FF2B5EF4-FFF2-40B4-BE49-F238E27FC236}">
-                <a16:creationId xmlns:a16="http://schemas.microsoft.com/office/drawing/2014/main" id="{6B1B4541-FCB5-B062-E8C8-8365EC976465}"/>
+                <a16:creationId xmlns:a16="http://schemas.microsoft.com/office/drawing/2014/main" id="{C7A899A3-2D57-E122-2B9B-9D2769713A9E}"/>
               </a:ext>
             </a:extLst>
           </p:cNvPr>
@@ -2673,7 +2673,7 @@
           <a:bodyPr/>
           <a:lstStyle/>
           <a:p>
-            <a:fld id="{187C6756-6102-4259-B40B-0718AF07DF35}" type="datetimeFigureOut">
+            <a:fld id="{3E13F701-25CE-4D2B-8B3E-C45F0907FFE9}" type="datetimeFigureOut">
               <a:rPr lang="en-PK" smtClean="0"/>
               <a:t>26/10/2026</a:t>
             </a:fld>
@@ -2686,7 +2686,7 @@
           <p:cNvPr id="4" name="Footer Placeholder 3">
             <a:extLst>
               <a:ext uri="{FF2B5EF4-FFF2-40B4-BE49-F238E27FC236}">
-                <a16:creationId xmlns:a16="http://schemas.microsoft.com/office/drawing/2014/main" id="{B8F74ECD-769E-B9FC-9D8B-FF8DC3A61FEC}"/>
+                <a16:creationId xmlns:a16="http://schemas.microsoft.com/office/drawing/2014/main" id="{A9883B1F-90F2-405E-9119-C13B28F602F8}"/>
               </a:ext>
             </a:extLst>
           </p:cNvPr>
@@ -2711,7 +2711,7 @@
           <p:cNvPr id="5" name="Slide Number Placeholder 4">
             <a:extLst>
               <a:ext uri="{FF2B5EF4-FFF2-40B4-BE49-F238E27FC236}">
-                <a16:creationId xmlns:a16="http://schemas.microsoft.com/office/drawing/2014/main" id="{2F82BAE1-C0FD-BC6B-8DD3-9E962070CD7F}"/>
+                <a16:creationId xmlns:a16="http://schemas.microsoft.com/office/drawing/2014/main" id="{740F3DC8-CBF0-B343-CF38-5DA3C355F1F5}"/>
               </a:ext>
             </a:extLst>
           </p:cNvPr>
@@ -2727,7 +2727,7 @@
           <a:bodyPr/>
           <a:lstStyle/>
           <a:p>
-            <a:fld id="{64F069EE-6B3C-43A6-BA10-5D41419D3069}" type="slidenum">
+            <a:fld id="{FB258019-6AB0-4EA7-82CF-AD3D5CBF336E}" type="slidenum">
               <a:rPr lang="en-PK" smtClean="0"/>
               <a:t>‹#›</a:t>
             </a:fld>
@@ -2738,7 +2738,7 @@
     </p:spTree>
     <p:extLst>
       <p:ext uri="{BB962C8B-B14F-4D97-AF65-F5344CB8AC3E}">
-        <p14:creationId xmlns:p14="http://schemas.microsoft.com/office/powerpoint/2010/main" val="2655407442"/>
+        <p14:creationId xmlns:p14="http://schemas.microsoft.com/office/powerpoint/2010/main" val="4210717798"/>
       </p:ext>
     </p:extLst>
   </p:cSld>
@@ -2770,7 +2770,7 @@
           <p:cNvPr id="2" name="Date Placeholder 1">
             <a:extLst>
               <a:ext uri="{FF2B5EF4-FFF2-40B4-BE49-F238E27FC236}">
-                <a16:creationId xmlns:a16="http://schemas.microsoft.com/office/drawing/2014/main" id="{88DBA29D-AE53-2467-EB82-DC4212B168F2}"/>
+                <a16:creationId xmlns:a16="http://schemas.microsoft.com/office/drawing/2014/main" id="{5B3EA4E3-8F3B-4E2B-5FFC-F45CF320FBC7}"/>
               </a:ext>
             </a:extLst>
           </p:cNvPr>
@@ -2786,7 +2786,7 @@
           <a:bodyPr/>
           <a:lstStyle/>
           <a:p>
-            <a:fld id="{187C6756-6102-4259-B40B-0718AF07DF35}" type="datetimeFigureOut">
+            <a:fld id="{3E13F701-25CE-4D2B-8B3E-C45F0907FFE9}" type="datetimeFigureOut">
               <a:rPr lang="en-PK" smtClean="0"/>
               <a:t>26/10/2026</a:t>
             </a:fld>
@@ -2799,7 +2799,7 @@
           <p:cNvPr id="3" name="Footer Placeholder 2">
             <a:extLst>
               <a:ext uri="{FF2B5EF4-FFF2-40B4-BE49-F238E27FC236}">
-                <a16:creationId xmlns:a16="http://schemas.microsoft.com/office/drawing/2014/main" id="{FB9872CC-910B-150A-1431-B0E9F3EDAE17}"/>
+                <a16:creationId xmlns:a16="http://schemas.microsoft.com/office/drawing/2014/main" id="{DE155841-B704-4A32-DFCC-4594848D65A6}"/>
               </a:ext>
             </a:extLst>
           </p:cNvPr>
@@ -2824,7 +2824,7 @@
           <p:cNvPr id="4" name="Slide Number Placeholder 3">
             <a:extLst>
               <a:ext uri="{FF2B5EF4-FFF2-40B4-BE49-F238E27FC236}">
-                <a16:creationId xmlns:a16="http://schemas.microsoft.com/office/drawing/2014/main" id="{BD47DC09-410A-52B6-DDDB-36AD849733F9}"/>
+                <a16:creationId xmlns:a16="http://schemas.microsoft.com/office/drawing/2014/main" id="{A2A35DE5-E7D3-685E-40C6-0829D58B8F8F}"/>
               </a:ext>
             </a:extLst>
           </p:cNvPr>
@@ -2840,7 +2840,7 @@
           <a:bodyPr/>
           <a:lstStyle/>
           <a:p>
-            <a:fld id="{64F069EE-6B3C-43A6-BA10-5D41419D3069}" type="slidenum">
+            <a:fld id="{FB258019-6AB0-4EA7-82CF-AD3D5CBF336E}" type="slidenum">
               <a:rPr lang="en-PK" smtClean="0"/>
               <a:t>‹#›</a:t>
             </a:fld>
@@ -2851,7 +2851,7 @@
     </p:spTree>
     <p:extLst>
       <p:ext uri="{BB962C8B-B14F-4D97-AF65-F5344CB8AC3E}">
-        <p14:creationId xmlns:p14="http://schemas.microsoft.com/office/powerpoint/2010/main" val="3633138965"/>
+        <p14:creationId xmlns:p14="http://schemas.microsoft.com/office/powerpoint/2010/main" val="3189011624"/>
       </p:ext>
     </p:extLst>
   </p:cSld>
@@ -2883,7 +2883,7 @@
           <p:cNvPr id="2" name="Title 1">
             <a:extLst>
               <a:ext uri="{FF2B5EF4-FFF2-40B4-BE49-F238E27FC236}">
-                <a16:creationId xmlns:a16="http://schemas.microsoft.com/office/drawing/2014/main" id="{2493D002-5F3F-8D55-1B57-7D593A2567EB}"/>
+                <a16:creationId xmlns:a16="http://schemas.microsoft.com/office/drawing/2014/main" id="{9F584956-605E-EDEA-708B-3DF8B9A8F558}"/>
               </a:ext>
             </a:extLst>
           </p:cNvPr>
@@ -2921,7 +2921,7 @@
           <p:cNvPr id="3" name="Content Placeholder 2">
             <a:extLst>
               <a:ext uri="{FF2B5EF4-FFF2-40B4-BE49-F238E27FC236}">
-                <a16:creationId xmlns:a16="http://schemas.microsoft.com/office/drawing/2014/main" id="{9C1C1BB2-63D6-5400-0487-042DF0E6386B}"/>
+                <a16:creationId xmlns:a16="http://schemas.microsoft.com/office/drawing/2014/main" id="{ACDC7149-A4DA-F27C-F67E-BCCB50FFCD47}"/>
               </a:ext>
             </a:extLst>
           </p:cNvPr>
@@ -3012,7 +3012,7 @@
           <p:cNvPr id="4" name="Text Placeholder 3">
             <a:extLst>
               <a:ext uri="{FF2B5EF4-FFF2-40B4-BE49-F238E27FC236}">
-                <a16:creationId xmlns:a16="http://schemas.microsoft.com/office/drawing/2014/main" id="{CCB437F4-C0E8-79A0-6FAE-53B5A6364446}"/>
+                <a16:creationId xmlns:a16="http://schemas.microsoft.com/office/drawing/2014/main" id="{81344F8D-54E9-CA08-389E-6B362BF53391}"/>
               </a:ext>
             </a:extLst>
           </p:cNvPr>
@@ -3083,7 +3083,7 @@
           <p:cNvPr id="5" name="Date Placeholder 4">
             <a:extLst>
               <a:ext uri="{FF2B5EF4-FFF2-40B4-BE49-F238E27FC236}">
-                <a16:creationId xmlns:a16="http://schemas.microsoft.com/office/drawing/2014/main" id="{FF2D700B-8B3F-78ED-1055-06CEB8D43899}"/>
+                <a16:creationId xmlns:a16="http://schemas.microsoft.com/office/drawing/2014/main" id="{01A0F9A1-09E0-1241-F04E-12045260544D}"/>
               </a:ext>
             </a:extLst>
           </p:cNvPr>
@@ -3099,7 +3099,7 @@
           <a:bodyPr/>
           <a:lstStyle/>
           <a:p>
-            <a:fld id="{187C6756-6102-4259-B40B-0718AF07DF35}" type="datetimeFigureOut">
+            <a:fld id="{3E13F701-25CE-4D2B-8B3E-C45F0907FFE9}" type="datetimeFigureOut">
               <a:rPr lang="en-PK" smtClean="0"/>
               <a:t>26/10/2026</a:t>
             </a:fld>
@@ -3112,7 +3112,7 @@
           <p:cNvPr id="6" name="Footer Placeholder 5">
             <a:extLst>
               <a:ext uri="{FF2B5EF4-FFF2-40B4-BE49-F238E27FC236}">
-                <a16:creationId xmlns:a16="http://schemas.microsoft.com/office/drawing/2014/main" id="{53AE768C-6181-44F9-88B4-DE71D002E678}"/>
+                <a16:creationId xmlns:a16="http://schemas.microsoft.com/office/drawing/2014/main" id="{BE1A7494-C994-2935-3EB5-971B2FFE3AAC}"/>
               </a:ext>
             </a:extLst>
           </p:cNvPr>
@@ -3137,7 +3137,7 @@
           <p:cNvPr id="7" name="Slide Number Placeholder 6">
             <a:extLst>
               <a:ext uri="{FF2B5EF4-FFF2-40B4-BE49-F238E27FC236}">
-                <a16:creationId xmlns:a16="http://schemas.microsoft.com/office/drawing/2014/main" id="{7F3E4306-8DD9-D577-1D8C-1B5445940E05}"/>
+                <a16:creationId xmlns:a16="http://schemas.microsoft.com/office/drawing/2014/main" id="{97C2305E-0955-8E5C-BCE4-425AE235D958}"/>
               </a:ext>
             </a:extLst>
           </p:cNvPr>
@@ -3153,7 +3153,7 @@
           <a:bodyPr/>
           <a:lstStyle/>
           <a:p>
-            <a:fld id="{64F069EE-6B3C-43A6-BA10-5D41419D3069}" type="slidenum">
+            <a:fld id="{FB258019-6AB0-4EA7-82CF-AD3D5CBF336E}" type="slidenum">
               <a:rPr lang="en-PK" smtClean="0"/>
               <a:t>‹#›</a:t>
             </a:fld>
@@ -3164,7 +3164,7 @@
     </p:spTree>
     <p:extLst>
       <p:ext uri="{BB962C8B-B14F-4D97-AF65-F5344CB8AC3E}">
-        <p14:creationId xmlns:p14="http://schemas.microsoft.com/office/powerpoint/2010/main" val="1403830558"/>
+        <p14:creationId xmlns:p14="http://schemas.microsoft.com/office/powerpoint/2010/main" val="4123899104"/>
       </p:ext>
     </p:extLst>
   </p:cSld>
@@ -3196,7 +3196,7 @@
           <p:cNvPr id="2" name="Title 1">
             <a:extLst>
               <a:ext uri="{FF2B5EF4-FFF2-40B4-BE49-F238E27FC236}">
-                <a16:creationId xmlns:a16="http://schemas.microsoft.com/office/drawing/2014/main" id="{5420947D-4031-F893-8413-ADDC1AB1241B}"/>
+                <a16:creationId xmlns:a16="http://schemas.microsoft.com/office/drawing/2014/main" id="{AD4BD280-C794-CC3B-2122-B9B19C3783E3}"/>
               </a:ext>
             </a:extLst>
           </p:cNvPr>
@@ -3234,7 +3234,7 @@
           <p:cNvPr id="3" name="Picture Placeholder 2">
             <a:extLst>
               <a:ext uri="{FF2B5EF4-FFF2-40B4-BE49-F238E27FC236}">
-                <a16:creationId xmlns:a16="http://schemas.microsoft.com/office/drawing/2014/main" id="{9E9B936C-8B91-9C71-765F-D232E70D6E74}"/>
+                <a16:creationId xmlns:a16="http://schemas.microsoft.com/office/drawing/2014/main" id="{35307EFE-D6EE-E034-0E12-076BDA1C9280}"/>
               </a:ext>
             </a:extLst>
           </p:cNvPr>
@@ -3301,7 +3301,7 @@
           <p:cNvPr id="4" name="Text Placeholder 3">
             <a:extLst>
               <a:ext uri="{FF2B5EF4-FFF2-40B4-BE49-F238E27FC236}">
-                <a16:creationId xmlns:a16="http://schemas.microsoft.com/office/drawing/2014/main" id="{4A3487B3-CB62-14F9-4317-9DB4295A12AE}"/>
+                <a16:creationId xmlns:a16="http://schemas.microsoft.com/office/drawing/2014/main" id="{7265B74E-A4F6-E0F7-4B74-F81F3DBB1A32}"/>
               </a:ext>
             </a:extLst>
           </p:cNvPr>
@@ -3372,7 +3372,7 @@
           <p:cNvPr id="5" name="Date Placeholder 4">
             <a:extLst>
               <a:ext uri="{FF2B5EF4-FFF2-40B4-BE49-F238E27FC236}">
-                <a16:creationId xmlns:a16="http://schemas.microsoft.com/office/drawing/2014/main" id="{21599EF9-4975-7E41-98B8-17B3373571AF}"/>
+                <a16:creationId xmlns:a16="http://schemas.microsoft.com/office/drawing/2014/main" id="{FC237972-56BD-26F9-7670-5002555F6BA4}"/>
               </a:ext>
             </a:extLst>
           </p:cNvPr>
@@ -3388,7 +3388,7 @@
           <a:bodyPr/>
           <a:lstStyle/>
           <a:p>
-            <a:fld id="{187C6756-6102-4259-B40B-0718AF07DF35}" type="datetimeFigureOut">
+            <a:fld id="{3E13F701-25CE-4D2B-8B3E-C45F0907FFE9}" type="datetimeFigureOut">
               <a:rPr lang="en-PK" smtClean="0"/>
               <a:t>26/10/2026</a:t>
             </a:fld>
@@ -3401,7 +3401,7 @@
           <p:cNvPr id="6" name="Footer Placeholder 5">
             <a:extLst>
               <a:ext uri="{FF2B5EF4-FFF2-40B4-BE49-F238E27FC236}">
-                <a16:creationId xmlns:a16="http://schemas.microsoft.com/office/drawing/2014/main" id="{6B8ADB9D-2276-DFF1-B742-504362F0F08F}"/>
+                <a16:creationId xmlns:a16="http://schemas.microsoft.com/office/drawing/2014/main" id="{F278DA9A-80CD-7092-69DE-EA09EE5D2FB5}"/>
               </a:ext>
             </a:extLst>
           </p:cNvPr>
@@ -3426,7 +3426,7 @@
           <p:cNvPr id="7" name="Slide Number Placeholder 6">
             <a:extLst>
               <a:ext uri="{FF2B5EF4-FFF2-40B4-BE49-F238E27FC236}">
-                <a16:creationId xmlns:a16="http://schemas.microsoft.com/office/drawing/2014/main" id="{B306629A-A1E7-5393-8E31-BB9857B2A747}"/>
+                <a16:creationId xmlns:a16="http://schemas.microsoft.com/office/drawing/2014/main" id="{00C947CC-6CA1-AC88-5BA3-38BFA76ADC32}"/>
               </a:ext>
             </a:extLst>
           </p:cNvPr>
@@ -3442,7 +3442,7 @@
           <a:bodyPr/>
           <a:lstStyle/>
           <a:p>
-            <a:fld id="{64F069EE-6B3C-43A6-BA10-5D41419D3069}" type="slidenum">
+            <a:fld id="{FB258019-6AB0-4EA7-82CF-AD3D5CBF336E}" type="slidenum">
               <a:rPr lang="en-PK" smtClean="0"/>
               <a:t>‹#›</a:t>
             </a:fld>
@@ -3453,7 +3453,7 @@
     </p:spTree>
     <p:extLst>
       <p:ext uri="{BB962C8B-B14F-4D97-AF65-F5344CB8AC3E}">
-        <p14:creationId xmlns:p14="http://schemas.microsoft.com/office/powerpoint/2010/main" val="565682324"/>
+        <p14:creationId xmlns:p14="http://schemas.microsoft.com/office/powerpoint/2010/main" val="1184693111"/>
       </p:ext>
     </p:extLst>
   </p:cSld>
@@ -3490,7 +3490,7 @@
           <p:cNvPr id="2" name="Title Placeholder 1">
             <a:extLst>
               <a:ext uri="{FF2B5EF4-FFF2-40B4-BE49-F238E27FC236}">
-                <a16:creationId xmlns:a16="http://schemas.microsoft.com/office/drawing/2014/main" id="{43772B63-647A-3646-D6B6-79B94CC1ED9F}"/>
+                <a16:creationId xmlns:a16="http://schemas.microsoft.com/office/drawing/2014/main" id="{E7F8BCA4-21A6-7F56-4945-CD8594ABB62E}"/>
               </a:ext>
             </a:extLst>
           </p:cNvPr>
@@ -3529,7 +3529,7 @@
           <p:cNvPr id="3" name="Text Placeholder 2">
             <a:extLst>
               <a:ext uri="{FF2B5EF4-FFF2-40B4-BE49-F238E27FC236}">
-                <a16:creationId xmlns:a16="http://schemas.microsoft.com/office/drawing/2014/main" id="{5E6F27DA-B05C-F72C-0920-2AF1F71D6502}"/>
+                <a16:creationId xmlns:a16="http://schemas.microsoft.com/office/drawing/2014/main" id="{9ABBAAB0-1113-2104-46E6-7CEBE5A0B8B4}"/>
               </a:ext>
             </a:extLst>
           </p:cNvPr>
@@ -3597,7 +3597,7 @@
           <p:cNvPr id="4" name="Date Placeholder 3">
             <a:extLst>
               <a:ext uri="{FF2B5EF4-FFF2-40B4-BE49-F238E27FC236}">
-                <a16:creationId xmlns:a16="http://schemas.microsoft.com/office/drawing/2014/main" id="{5B42407A-C0B4-5E7F-4EFA-814256772DD3}"/>
+                <a16:creationId xmlns:a16="http://schemas.microsoft.com/office/drawing/2014/main" id="{F021AA7B-981B-C01E-C42C-EFBC4D540AC1}"/>
               </a:ext>
             </a:extLst>
           </p:cNvPr>
@@ -3631,7 +3631,7 @@
             </a:lvl1pPr>
           </a:lstStyle>
           <a:p>
-            <a:fld id="{187C6756-6102-4259-B40B-0718AF07DF35}" type="datetimeFigureOut">
+            <a:fld id="{3E13F701-25CE-4D2B-8B3E-C45F0907FFE9}" type="datetimeFigureOut">
               <a:rPr lang="en-PK" smtClean="0"/>
               <a:t>26/10/2026</a:t>
             </a:fld>
@@ -3644,7 +3644,7 @@
           <p:cNvPr id="5" name="Footer Placeholder 4">
             <a:extLst>
               <a:ext uri="{FF2B5EF4-FFF2-40B4-BE49-F238E27FC236}">
-                <a16:creationId xmlns:a16="http://schemas.microsoft.com/office/drawing/2014/main" id="{04B9DD2C-5017-A929-71DD-61D50B0FD433}"/>
+                <a16:creationId xmlns:a16="http://schemas.microsoft.com/office/drawing/2014/main" id="{BA49AC6B-3483-F269-AC99-E885D5B90F38}"/>
               </a:ext>
             </a:extLst>
           </p:cNvPr>
@@ -3687,7 +3687,7 @@
           <p:cNvPr id="6" name="Slide Number Placeholder 5">
             <a:extLst>
               <a:ext uri="{FF2B5EF4-FFF2-40B4-BE49-F238E27FC236}">
-                <a16:creationId xmlns:a16="http://schemas.microsoft.com/office/drawing/2014/main" id="{7C8A2362-916A-4B26-8FB2-C22BF32A82FE}"/>
+                <a16:creationId xmlns:a16="http://schemas.microsoft.com/office/drawing/2014/main" id="{3715F41E-7957-1B18-0460-AD6D2F461140}"/>
               </a:ext>
             </a:extLst>
           </p:cNvPr>
@@ -3721,7 +3721,7 @@
             </a:lvl1pPr>
           </a:lstStyle>
           <a:p>
-            <a:fld id="{64F069EE-6B3C-43A6-BA10-5D41419D3069}" type="slidenum">
+            <a:fld id="{FB258019-6AB0-4EA7-82CF-AD3D5CBF336E}" type="slidenum">
               <a:rPr lang="en-PK" smtClean="0"/>
               <a:t>‹#›</a:t>
             </a:fld>
@@ -3732,7 +3732,7 @@
     </p:spTree>
     <p:extLst>
       <p:ext uri="{BB962C8B-B14F-4D97-AF65-F5344CB8AC3E}">
-        <p14:creationId xmlns:p14="http://schemas.microsoft.com/office/powerpoint/2010/main" val="4030157828"/>
+        <p14:creationId xmlns:p14="http://schemas.microsoft.com/office/powerpoint/2010/main" val="53792196"/>
       </p:ext>
     </p:extLst>
   </p:cSld>
@@ -4055,7 +4055,7 @@
           <p:cNvPr id="2" name="Rectangle 1">
             <a:extLst>
               <a:ext uri="{FF2B5EF4-FFF2-40B4-BE49-F238E27FC236}">
-                <a16:creationId xmlns:a16="http://schemas.microsoft.com/office/drawing/2014/main" id="{DD7A9A1B-EEB7-51F3-1E02-9EC924CF647B}"/>
+                <a16:creationId xmlns:a16="http://schemas.microsoft.com/office/drawing/2014/main" id="{E4C53EB8-960E-E027-67C7-1994ED87EDC0}"/>
               </a:ext>
             </a:extLst>
           </p:cNvPr>
@@ -4123,7 +4123,7 @@
           <p:cNvPr id="3" name="Rectangle 2">
             <a:extLst>
               <a:ext uri="{FF2B5EF4-FFF2-40B4-BE49-F238E27FC236}">
-                <a16:creationId xmlns:a16="http://schemas.microsoft.com/office/drawing/2014/main" id="{A768D4A2-FC05-7BD5-C53B-A768BAEA5C00}"/>
+                <a16:creationId xmlns:a16="http://schemas.microsoft.com/office/drawing/2014/main" id="{67833C3B-A820-CC4B-0528-209E1F1B12E2}"/>
               </a:ext>
             </a:extLst>
           </p:cNvPr>
@@ -4191,7 +4191,7 @@
           <p:cNvPr id="4" name="TextBox 3">
             <a:extLst>
               <a:ext uri="{FF2B5EF4-FFF2-40B4-BE49-F238E27FC236}">
-                <a16:creationId xmlns:a16="http://schemas.microsoft.com/office/drawing/2014/main" id="{81E6394D-1C33-B545-94AA-67431AC7071C}"/>
+                <a16:creationId xmlns:a16="http://schemas.microsoft.com/office/drawing/2014/main" id="{F65664FF-8C88-3B79-38C8-BCA684C2596B}"/>
               </a:ext>
             </a:extLst>
           </p:cNvPr>
@@ -4237,7 +4237,7 @@
           <p:cNvPr id="5" name="TextBox 4">
             <a:extLst>
               <a:ext uri="{FF2B5EF4-FFF2-40B4-BE49-F238E27FC236}">
-                <a16:creationId xmlns:a16="http://schemas.microsoft.com/office/drawing/2014/main" id="{F94DB5EF-D71E-2E8A-B163-ADBC0FE0025A}"/>
+                <a16:creationId xmlns:a16="http://schemas.microsoft.com/office/drawing/2014/main" id="{7C5F7AD9-1AF3-12BC-1415-1874D9A67C97}"/>
               </a:ext>
             </a:extLst>
           </p:cNvPr>
@@ -4283,7 +4283,7 @@
           <p:cNvPr id="6" name="TextBox 5">
             <a:extLst>
               <a:ext uri="{FF2B5EF4-FFF2-40B4-BE49-F238E27FC236}">
-                <a16:creationId xmlns:a16="http://schemas.microsoft.com/office/drawing/2014/main" id="{58529EBF-3CBE-2E1A-4D6C-6A67DE8FA80C}"/>
+                <a16:creationId xmlns:a16="http://schemas.microsoft.com/office/drawing/2014/main" id="{D39FBE64-BB90-5985-BFCB-27AE69E8956B}"/>
               </a:ext>
             </a:extLst>
           </p:cNvPr>
@@ -4329,7 +4329,7 @@
           <p:cNvPr id="7" name="Rectangle 6">
             <a:extLst>
               <a:ext uri="{FF2B5EF4-FFF2-40B4-BE49-F238E27FC236}">
-                <a16:creationId xmlns:a16="http://schemas.microsoft.com/office/drawing/2014/main" id="{DCE550B5-E52A-86B5-5B36-4AA09DE4AF35}"/>
+                <a16:creationId xmlns:a16="http://schemas.microsoft.com/office/drawing/2014/main" id="{927B8170-9CBF-CE89-9F1B-33F906E70D50}"/>
               </a:ext>
             </a:extLst>
           </p:cNvPr>
@@ -4397,7 +4397,7 @@
           <p:cNvPr id="8" name="TextBox 7">
             <a:extLst>
               <a:ext uri="{FF2B5EF4-FFF2-40B4-BE49-F238E27FC236}">
-                <a16:creationId xmlns:a16="http://schemas.microsoft.com/office/drawing/2014/main" id="{F29348E8-698D-350D-EFD5-997ACBD4F56F}"/>
+                <a16:creationId xmlns:a16="http://schemas.microsoft.com/office/drawing/2014/main" id="{D5FA1B99-D098-A5CD-D45F-674447FB2CEF}"/>
               </a:ext>
             </a:extLst>
           </p:cNvPr>
@@ -4443,7 +4443,7 @@
           <p:cNvPr id="9" name="TextBox 8">
             <a:extLst>
               <a:ext uri="{FF2B5EF4-FFF2-40B4-BE49-F238E27FC236}">
-                <a16:creationId xmlns:a16="http://schemas.microsoft.com/office/drawing/2014/main" id="{81D56092-D330-A9AE-4839-7C92FA57BD86}"/>
+                <a16:creationId xmlns:a16="http://schemas.microsoft.com/office/drawing/2014/main" id="{868FD67B-FAD9-1359-BDEF-87684A6D1E58}"/>
               </a:ext>
             </a:extLst>
           </p:cNvPr>
@@ -4489,7 +4489,7 @@
           <p:cNvPr id="10" name="TextBox 9">
             <a:extLst>
               <a:ext uri="{FF2B5EF4-FFF2-40B4-BE49-F238E27FC236}">
-                <a16:creationId xmlns:a16="http://schemas.microsoft.com/office/drawing/2014/main" id="{A0E4A7FE-7F06-AB83-3C76-9FCC08EC9DB9}"/>
+                <a16:creationId xmlns:a16="http://schemas.microsoft.com/office/drawing/2014/main" id="{46F599E6-4497-485D-FFDE-0F8668CC5C5B}"/>
               </a:ext>
             </a:extLst>
           </p:cNvPr>
@@ -4535,7 +4535,7 @@
           <p:cNvPr id="11" name="TextBox 10">
             <a:extLst>
               <a:ext uri="{FF2B5EF4-FFF2-40B4-BE49-F238E27FC236}">
-                <a16:creationId xmlns:a16="http://schemas.microsoft.com/office/drawing/2014/main" id="{35EFEEA2-70C0-DEB6-8369-45C37327177E}"/>
+                <a16:creationId xmlns:a16="http://schemas.microsoft.com/office/drawing/2014/main" id="{04DF993C-D74B-5946-2016-DD2AC4BD0050}"/>
               </a:ext>
             </a:extLst>
           </p:cNvPr>
@@ -4581,7 +4581,7 @@
           <p:cNvPr id="12" name="TextBox 11">
             <a:extLst>
               <a:ext uri="{FF2B5EF4-FFF2-40B4-BE49-F238E27FC236}">
-                <a16:creationId xmlns:a16="http://schemas.microsoft.com/office/drawing/2014/main" id="{8DE53876-E121-F2F8-016F-762B80F3E4C9}"/>
+                <a16:creationId xmlns:a16="http://schemas.microsoft.com/office/drawing/2014/main" id="{76892162-57F4-EE49-A410-9CCF72FE4221}"/>
               </a:ext>
             </a:extLst>
           </p:cNvPr>
@@ -4628,7 +4628,7 @@
           <p:cNvPr id="13" name="TextBox 12">
             <a:extLst>
               <a:ext uri="{FF2B5EF4-FFF2-40B4-BE49-F238E27FC236}">
-                <a16:creationId xmlns:a16="http://schemas.microsoft.com/office/drawing/2014/main" id="{ABA8A252-1C60-F653-BA25-C3BAACA9B092}"/>
+                <a16:creationId xmlns:a16="http://schemas.microsoft.com/office/drawing/2014/main" id="{D8C0E1B7-E10D-5408-730E-C1DB851CBB03}"/>
               </a:ext>
             </a:extLst>
           </p:cNvPr>
@@ -4672,7 +4672,7 @@
     </p:spTree>
     <p:extLst>
       <p:ext uri="{BB962C8B-B14F-4D97-AF65-F5344CB8AC3E}">
-        <p14:creationId xmlns:p14="http://schemas.microsoft.com/office/powerpoint/2010/main" val="3381361864"/>
+        <p14:creationId xmlns:p14="http://schemas.microsoft.com/office/powerpoint/2010/main" val="1380577199"/>
       </p:ext>
     </p:extLst>
   </p:cSld>
@@ -4704,7 +4704,7 @@
           <p:cNvPr id="12" name="Rectangle 11">
             <a:extLst>
               <a:ext uri="{FF2B5EF4-FFF2-40B4-BE49-F238E27FC236}">
-                <a16:creationId xmlns:a16="http://schemas.microsoft.com/office/drawing/2014/main" id="{67976025-CEED-EC83-91FB-C01FEB170D18}"/>
+                <a16:creationId xmlns:a16="http://schemas.microsoft.com/office/drawing/2014/main" id="{BE6DECFB-BEE7-45DB-2AD7-6A2B74858E2C}"/>
               </a:ext>
             </a:extLst>
           </p:cNvPr>
@@ -4758,7 +4758,7 @@
           <p:cNvPr id="9" name="Rectangle 8">
             <a:extLst>
               <a:ext uri="{FF2B5EF4-FFF2-40B4-BE49-F238E27FC236}">
-                <a16:creationId xmlns:a16="http://schemas.microsoft.com/office/drawing/2014/main" id="{B3C0F8A1-96AC-9E63-AB9D-0888052D49FC}"/>
+                <a16:creationId xmlns:a16="http://schemas.microsoft.com/office/drawing/2014/main" id="{CCBF0C7A-E3F6-FCE1-FFB5-158E1C9AE81E}"/>
               </a:ext>
             </a:extLst>
           </p:cNvPr>
@@ -4812,7 +4812,7 @@
           <p:cNvPr id="2" name="Rectangle 1">
             <a:extLst>
               <a:ext uri="{FF2B5EF4-FFF2-40B4-BE49-F238E27FC236}">
-                <a16:creationId xmlns:a16="http://schemas.microsoft.com/office/drawing/2014/main" id="{E459D89A-2693-C128-2240-92F416A31C25}"/>
+                <a16:creationId xmlns:a16="http://schemas.microsoft.com/office/drawing/2014/main" id="{103FD0BF-06DE-59B3-50F7-85E6829C079C}"/>
               </a:ext>
             </a:extLst>
           </p:cNvPr>
@@ -4880,7 +4880,7 @@
           <p:cNvPr id="3" name="TextBox 2">
             <a:extLst>
               <a:ext uri="{FF2B5EF4-FFF2-40B4-BE49-F238E27FC236}">
-                <a16:creationId xmlns:a16="http://schemas.microsoft.com/office/drawing/2014/main" id="{DAC356B6-F3CF-BF5F-93FA-4138E358321B}"/>
+                <a16:creationId xmlns:a16="http://schemas.microsoft.com/office/drawing/2014/main" id="{B00D6081-CFD6-44BE-A1D5-74F947A8804D}"/>
               </a:ext>
             </a:extLst>
           </p:cNvPr>
@@ -4926,7 +4926,7 @@
           <p:cNvPr id="4" name="TextBox 3">
             <a:extLst>
               <a:ext uri="{FF2B5EF4-FFF2-40B4-BE49-F238E27FC236}">
-                <a16:creationId xmlns:a16="http://schemas.microsoft.com/office/drawing/2014/main" id="{B3D722FE-EAB3-874A-D109-E300A0DBC125}"/>
+                <a16:creationId xmlns:a16="http://schemas.microsoft.com/office/drawing/2014/main" id="{56F0C05D-5C64-CADC-8782-42911856003F}"/>
               </a:ext>
             </a:extLst>
           </p:cNvPr>
@@ -4972,7 +4972,7 @@
           <p:cNvPr id="5" name="TextBox 4">
             <a:extLst>
               <a:ext uri="{FF2B5EF4-FFF2-40B4-BE49-F238E27FC236}">
-                <a16:creationId xmlns:a16="http://schemas.microsoft.com/office/drawing/2014/main" id="{9A2F8AE8-0EA3-4534-095C-7735A6D3CA81}"/>
+                <a16:creationId xmlns:a16="http://schemas.microsoft.com/office/drawing/2014/main" id="{FFD74E85-AE3E-88C0-CF3B-B61AFDC1C3D1}"/>
               </a:ext>
             </a:extLst>
           </p:cNvPr>
@@ -5018,7 +5018,7 @@
           <p:cNvPr id="6" name="TextBox 5">
             <a:extLst>
               <a:ext uri="{FF2B5EF4-FFF2-40B4-BE49-F238E27FC236}">
-                <a16:creationId xmlns:a16="http://schemas.microsoft.com/office/drawing/2014/main" id="{AD94264A-F866-E703-5611-08593A464110}"/>
+                <a16:creationId xmlns:a16="http://schemas.microsoft.com/office/drawing/2014/main" id="{B412B829-8DA3-C1EA-4CD3-83023BF234EE}"/>
               </a:ext>
             </a:extLst>
           </p:cNvPr>
@@ -5064,7 +5064,7 @@
           <p:cNvPr id="8" name="Graphic 7">
             <a:extLst>
               <a:ext uri="{FF2B5EF4-FFF2-40B4-BE49-F238E27FC236}">
-                <a16:creationId xmlns:a16="http://schemas.microsoft.com/office/drawing/2014/main" id="{434BD162-19B5-C080-ACD8-E11552A9613B}"/>
+                <a16:creationId xmlns:a16="http://schemas.microsoft.com/office/drawing/2014/main" id="{80CBC7E9-B994-1F73-2D64-FBC3F6BC8988}"/>
               </a:ext>
             </a:extLst>
           </p:cNvPr>
@@ -5100,7 +5100,7 @@
           <p:cNvPr id="11" name="Graphic 10">
             <a:extLst>
               <a:ext uri="{FF2B5EF4-FFF2-40B4-BE49-F238E27FC236}">
-                <a16:creationId xmlns:a16="http://schemas.microsoft.com/office/drawing/2014/main" id="{29C9E9C5-8CEC-3CA4-6714-A5271C9516D6}"/>
+                <a16:creationId xmlns:a16="http://schemas.microsoft.com/office/drawing/2014/main" id="{585E17C9-5314-DD5F-B3B5-AD819A8F4EC5}"/>
               </a:ext>
             </a:extLst>
           </p:cNvPr>
@@ -5136,7 +5136,7 @@
           <p:cNvPr id="13" name="TextBox 12">
             <a:extLst>
               <a:ext uri="{FF2B5EF4-FFF2-40B4-BE49-F238E27FC236}">
-                <a16:creationId xmlns:a16="http://schemas.microsoft.com/office/drawing/2014/main" id="{555E0752-176D-AA3B-D2B6-FC26B3F43069}"/>
+                <a16:creationId xmlns:a16="http://schemas.microsoft.com/office/drawing/2014/main" id="{FA947F2E-4F86-EAC5-2644-1C6994A3927A}"/>
               </a:ext>
             </a:extLst>
           </p:cNvPr>
@@ -5182,7 +5182,7 @@
           <p:cNvPr id="14" name="TextBox 13">
             <a:extLst>
               <a:ext uri="{FF2B5EF4-FFF2-40B4-BE49-F238E27FC236}">
-                <a16:creationId xmlns:a16="http://schemas.microsoft.com/office/drawing/2014/main" id="{8DF99D11-76B1-4A8B-0FC6-E9F17C2E0309}"/>
+                <a16:creationId xmlns:a16="http://schemas.microsoft.com/office/drawing/2014/main" id="{C8F031FE-08B3-F71C-2FC4-4130B07A961B}"/>
               </a:ext>
             </a:extLst>
           </p:cNvPr>
@@ -5228,7 +5228,7 @@
           <p:cNvPr id="15" name="TextBox 14">
             <a:extLst>
               <a:ext uri="{FF2B5EF4-FFF2-40B4-BE49-F238E27FC236}">
-                <a16:creationId xmlns:a16="http://schemas.microsoft.com/office/drawing/2014/main" id="{F9A55C29-8DA0-4EA1-2867-BF74DE92ED2F}"/>
+                <a16:creationId xmlns:a16="http://schemas.microsoft.com/office/drawing/2014/main" id="{474D1056-2D1D-3EDA-D133-AD2026266B28}"/>
               </a:ext>
             </a:extLst>
           </p:cNvPr>
@@ -5274,7 +5274,7 @@
           <p:cNvPr id="16" name="TextBox 15">
             <a:extLst>
               <a:ext uri="{FF2B5EF4-FFF2-40B4-BE49-F238E27FC236}">
-                <a16:creationId xmlns:a16="http://schemas.microsoft.com/office/drawing/2014/main" id="{16E9BAA2-CEEA-1F6C-EABA-792A9522AF19}"/>
+                <a16:creationId xmlns:a16="http://schemas.microsoft.com/office/drawing/2014/main" id="{801A7106-E203-BA11-4F5D-62A24829A2BF}"/>
               </a:ext>
             </a:extLst>
           </p:cNvPr>
@@ -5320,7 +5320,7 @@
           <p:cNvPr id="17" name="TextBox 16">
             <a:extLst>
               <a:ext uri="{FF2B5EF4-FFF2-40B4-BE49-F238E27FC236}">
-                <a16:creationId xmlns:a16="http://schemas.microsoft.com/office/drawing/2014/main" id="{DBC18145-28DA-950C-7943-D74010F5D401}"/>
+                <a16:creationId xmlns:a16="http://schemas.microsoft.com/office/drawing/2014/main" id="{EEB32339-3693-5210-BEB8-8E9A3172B95E}"/>
               </a:ext>
             </a:extLst>
           </p:cNvPr>
@@ -5359,7 +5359,7 @@
     </p:spTree>
     <p:extLst>
       <p:ext uri="{BB962C8B-B14F-4D97-AF65-F5344CB8AC3E}">
-        <p14:creationId xmlns:p14="http://schemas.microsoft.com/office/powerpoint/2010/main" val="3276020778"/>
+        <p14:creationId xmlns:p14="http://schemas.microsoft.com/office/powerpoint/2010/main" val="3118992068"/>
       </p:ext>
     </p:extLst>
   </p:cSld>
@@ -5391,7 +5391,7 @@
           <p:cNvPr id="13" name="Rectangle 12">
             <a:extLst>
               <a:ext uri="{FF2B5EF4-FFF2-40B4-BE49-F238E27FC236}">
-                <a16:creationId xmlns:a16="http://schemas.microsoft.com/office/drawing/2014/main" id="{AA5BFFF3-91D8-211C-2CA8-C2E6EB6957E4}"/>
+                <a16:creationId xmlns:a16="http://schemas.microsoft.com/office/drawing/2014/main" id="{14B4D7ED-E197-C51B-04E8-FC4BBD893302}"/>
               </a:ext>
             </a:extLst>
           </p:cNvPr>
@@ -5445,7 +5445,7 @@
           <p:cNvPr id="2" name="Rectangle 1">
             <a:extLst>
               <a:ext uri="{FF2B5EF4-FFF2-40B4-BE49-F238E27FC236}">
-                <a16:creationId xmlns:a16="http://schemas.microsoft.com/office/drawing/2014/main" id="{285338D0-5D3E-AD12-5C07-E9B8F5339FEF}"/>
+                <a16:creationId xmlns:a16="http://schemas.microsoft.com/office/drawing/2014/main" id="{ED17CCFB-8526-1B51-4AC5-665DD45950B0}"/>
               </a:ext>
             </a:extLst>
           </p:cNvPr>
@@ -5513,7 +5513,7 @@
           <p:cNvPr id="3" name="TextBox 2">
             <a:extLst>
               <a:ext uri="{FF2B5EF4-FFF2-40B4-BE49-F238E27FC236}">
-                <a16:creationId xmlns:a16="http://schemas.microsoft.com/office/drawing/2014/main" id="{50475EC4-92B3-E108-1464-854D4EF22A6A}"/>
+                <a16:creationId xmlns:a16="http://schemas.microsoft.com/office/drawing/2014/main" id="{1AE75B34-B8D4-7F81-2CB8-9F2D7ECD7445}"/>
               </a:ext>
             </a:extLst>
           </p:cNvPr>
@@ -5559,7 +5559,7 @@
           <p:cNvPr id="4" name="TextBox 3">
             <a:extLst>
               <a:ext uri="{FF2B5EF4-FFF2-40B4-BE49-F238E27FC236}">
-                <a16:creationId xmlns:a16="http://schemas.microsoft.com/office/drawing/2014/main" id="{53FE02DC-5B05-C07A-60BE-8D344DB76D5E}"/>
+                <a16:creationId xmlns:a16="http://schemas.microsoft.com/office/drawing/2014/main" id="{EA1C7EBF-66D5-534C-377F-DFDF5028D0DE}"/>
               </a:ext>
             </a:extLst>
           </p:cNvPr>
@@ -5605,7 +5605,7 @@
           <p:cNvPr id="5" name="TextBox 4">
             <a:extLst>
               <a:ext uri="{FF2B5EF4-FFF2-40B4-BE49-F238E27FC236}">
-                <a16:creationId xmlns:a16="http://schemas.microsoft.com/office/drawing/2014/main" id="{2BE61D69-3B60-65CD-9614-7AEE96FB1AFF}"/>
+                <a16:creationId xmlns:a16="http://schemas.microsoft.com/office/drawing/2014/main" id="{03E197B9-E367-9AA5-B5CD-B94CEDF42229}"/>
               </a:ext>
             </a:extLst>
           </p:cNvPr>
@@ -5645,7 +5645,7 @@
           <p:cNvPr id="6" name="TextBox 5">
             <a:extLst>
               <a:ext uri="{FF2B5EF4-FFF2-40B4-BE49-F238E27FC236}">
-                <a16:creationId xmlns:a16="http://schemas.microsoft.com/office/drawing/2014/main" id="{497AFEB7-96A3-87C4-87E3-AA82CB5992FF}"/>
+                <a16:creationId xmlns:a16="http://schemas.microsoft.com/office/drawing/2014/main" id="{B54C0FE8-F12E-FA7A-77C1-10BF9CD61921}"/>
               </a:ext>
             </a:extLst>
           </p:cNvPr>
@@ -5691,7 +5691,7 @@
           <p:cNvPr id="7" name="TextBox 6">
             <a:extLst>
               <a:ext uri="{FF2B5EF4-FFF2-40B4-BE49-F238E27FC236}">
-                <a16:creationId xmlns:a16="http://schemas.microsoft.com/office/drawing/2014/main" id="{B662DAA1-15DB-163C-0187-FE655BB59F33}"/>
+                <a16:creationId xmlns:a16="http://schemas.microsoft.com/office/drawing/2014/main" id="{476F2421-9CC2-89D3-1E99-C6918CEE342E}"/>
               </a:ext>
             </a:extLst>
           </p:cNvPr>
@@ -5737,7 +5737,7 @@
           <p:cNvPr id="8" name="Rectangle 7">
             <a:extLst>
               <a:ext uri="{FF2B5EF4-FFF2-40B4-BE49-F238E27FC236}">
-                <a16:creationId xmlns:a16="http://schemas.microsoft.com/office/drawing/2014/main" id="{B35E1C3F-3009-7B21-DDBD-CBBC2D14CA8D}"/>
+                <a16:creationId xmlns:a16="http://schemas.microsoft.com/office/drawing/2014/main" id="{27045FDA-767A-CF24-4F2A-9B9759F7FAF2}"/>
               </a:ext>
             </a:extLst>
           </p:cNvPr>
@@ -5805,7 +5805,7 @@
           <p:cNvPr id="9" name="TextBox 8">
             <a:extLst>
               <a:ext uri="{FF2B5EF4-FFF2-40B4-BE49-F238E27FC236}">
-                <a16:creationId xmlns:a16="http://schemas.microsoft.com/office/drawing/2014/main" id="{04512DD9-96AD-6451-CE2E-30D963A28D42}"/>
+                <a16:creationId xmlns:a16="http://schemas.microsoft.com/office/drawing/2014/main" id="{70EC2235-3E88-8432-0C8D-721845B29C2C}"/>
               </a:ext>
             </a:extLst>
           </p:cNvPr>
@@ -5883,7 +5883,7 @@
           <p:cNvPr id="10" name="TextBox 9">
             <a:extLst>
               <a:ext uri="{FF2B5EF4-FFF2-40B4-BE49-F238E27FC236}">
-                <a16:creationId xmlns:a16="http://schemas.microsoft.com/office/drawing/2014/main" id="{B3373285-B050-4681-E4FB-186BACFB4429}"/>
+                <a16:creationId xmlns:a16="http://schemas.microsoft.com/office/drawing/2014/main" id="{2C6823E4-C284-6324-BC4B-B68907A8A87B}"/>
               </a:ext>
             </a:extLst>
           </p:cNvPr>
@@ -5929,7 +5929,7 @@
           <p:cNvPr id="12" name="Graphic 11">
             <a:extLst>
               <a:ext uri="{FF2B5EF4-FFF2-40B4-BE49-F238E27FC236}">
-                <a16:creationId xmlns:a16="http://schemas.microsoft.com/office/drawing/2014/main" id="{89BA7991-A706-C918-5F9F-2DA68D6E1CC9}"/>
+                <a16:creationId xmlns:a16="http://schemas.microsoft.com/office/drawing/2014/main" id="{5B688A4D-657D-BA23-0351-30DC2E9B8537}"/>
               </a:ext>
             </a:extLst>
           </p:cNvPr>
@@ -5965,7 +5965,7 @@
           <p:cNvPr id="14" name="TextBox 13">
             <a:extLst>
               <a:ext uri="{FF2B5EF4-FFF2-40B4-BE49-F238E27FC236}">
-                <a16:creationId xmlns:a16="http://schemas.microsoft.com/office/drawing/2014/main" id="{16036C71-A5F5-9C02-A7EB-1B4180DA2F4A}"/>
+                <a16:creationId xmlns:a16="http://schemas.microsoft.com/office/drawing/2014/main" id="{47311842-7847-1E41-9091-6095DE42183C}"/>
               </a:ext>
             </a:extLst>
           </p:cNvPr>
@@ -6011,7 +6011,7 @@
           <p:cNvPr id="15" name="TextBox 14">
             <a:extLst>
               <a:ext uri="{FF2B5EF4-FFF2-40B4-BE49-F238E27FC236}">
-                <a16:creationId xmlns:a16="http://schemas.microsoft.com/office/drawing/2014/main" id="{BF39CADC-4A1B-FF54-17F1-BE301FC37B8D}"/>
+                <a16:creationId xmlns:a16="http://schemas.microsoft.com/office/drawing/2014/main" id="{8304AEAC-EC07-E7D0-AE9B-D48D1700C85E}"/>
               </a:ext>
             </a:extLst>
           </p:cNvPr>
@@ -6050,7 +6050,7 @@
     </p:spTree>
     <p:extLst>
       <p:ext uri="{BB962C8B-B14F-4D97-AF65-F5344CB8AC3E}">
-        <p14:creationId xmlns:p14="http://schemas.microsoft.com/office/powerpoint/2010/main" val="3542139465"/>
+        <p14:creationId xmlns:p14="http://schemas.microsoft.com/office/powerpoint/2010/main" val="1648883200"/>
       </p:ext>
     </p:extLst>
   </p:cSld>
@@ -6082,7 +6082,7 @@
           <p:cNvPr id="7" name="Rectangle 6">
             <a:extLst>
               <a:ext uri="{FF2B5EF4-FFF2-40B4-BE49-F238E27FC236}">
-                <a16:creationId xmlns:a16="http://schemas.microsoft.com/office/drawing/2014/main" id="{CDF5B806-76B1-BA3E-DDA8-005D2A7B3799}"/>
+                <a16:creationId xmlns:a16="http://schemas.microsoft.com/office/drawing/2014/main" id="{D43A632E-EF4B-2FCD-B5EC-3CC5C04EF296}"/>
               </a:ext>
             </a:extLst>
           </p:cNvPr>
@@ -6136,7 +6136,7 @@
           <p:cNvPr id="2" name="Rectangle 1">
             <a:extLst>
               <a:ext uri="{FF2B5EF4-FFF2-40B4-BE49-F238E27FC236}">
-                <a16:creationId xmlns:a16="http://schemas.microsoft.com/office/drawing/2014/main" id="{C24B8312-F3E5-DB55-5F68-BAF2DFBEC58B}"/>
+                <a16:creationId xmlns:a16="http://schemas.microsoft.com/office/drawing/2014/main" id="{994E594B-3351-C47B-D84F-6BF7B2511F4D}"/>
               </a:ext>
             </a:extLst>
           </p:cNvPr>
@@ -6204,7 +6204,7 @@
           <p:cNvPr id="3" name="TextBox 2">
             <a:extLst>
               <a:ext uri="{FF2B5EF4-FFF2-40B4-BE49-F238E27FC236}">
-                <a16:creationId xmlns:a16="http://schemas.microsoft.com/office/drawing/2014/main" id="{E8A7FEE7-47B2-8A1F-B6A0-3BEA245176E5}"/>
+                <a16:creationId xmlns:a16="http://schemas.microsoft.com/office/drawing/2014/main" id="{1CB417B3-76EC-BD7E-440E-9DB000C7E471}"/>
               </a:ext>
             </a:extLst>
           </p:cNvPr>
@@ -6250,7 +6250,7 @@
           <p:cNvPr id="4" name="TextBox 3">
             <a:extLst>
               <a:ext uri="{FF2B5EF4-FFF2-40B4-BE49-F238E27FC236}">
-                <a16:creationId xmlns:a16="http://schemas.microsoft.com/office/drawing/2014/main" id="{28D95F0E-9CF1-C0DD-B24A-2CD776AF93D3}"/>
+                <a16:creationId xmlns:a16="http://schemas.microsoft.com/office/drawing/2014/main" id="{9019CEA2-65A7-C5D9-EC06-E280263654D2}"/>
               </a:ext>
             </a:extLst>
           </p:cNvPr>
@@ -6296,7 +6296,7 @@
           <p:cNvPr id="6" name="Graphic 5">
             <a:extLst>
               <a:ext uri="{FF2B5EF4-FFF2-40B4-BE49-F238E27FC236}">
-                <a16:creationId xmlns:a16="http://schemas.microsoft.com/office/drawing/2014/main" id="{88A877E6-E60C-1991-4706-44CCCB1C0DCA}"/>
+                <a16:creationId xmlns:a16="http://schemas.microsoft.com/office/drawing/2014/main" id="{92E667E9-D9BF-4970-3E09-B3225BBB6F3F}"/>
               </a:ext>
             </a:extLst>
           </p:cNvPr>
@@ -6332,7 +6332,7 @@
           <p:cNvPr id="8" name="TextBox 7">
             <a:extLst>
               <a:ext uri="{FF2B5EF4-FFF2-40B4-BE49-F238E27FC236}">
-                <a16:creationId xmlns:a16="http://schemas.microsoft.com/office/drawing/2014/main" id="{6FDDB1E0-04B4-2674-9E24-58811351500A}"/>
+                <a16:creationId xmlns:a16="http://schemas.microsoft.com/office/drawing/2014/main" id="{BF6DE186-1FB4-5452-46A6-83B28FC4EA29}"/>
               </a:ext>
             </a:extLst>
           </p:cNvPr>
@@ -6378,7 +6378,7 @@
           <p:cNvPr id="9" name="TextBox 8">
             <a:extLst>
               <a:ext uri="{FF2B5EF4-FFF2-40B4-BE49-F238E27FC236}">
-                <a16:creationId xmlns:a16="http://schemas.microsoft.com/office/drawing/2014/main" id="{5F80F15B-F15A-3D2C-F09C-EF3F8085DFE7}"/>
+                <a16:creationId xmlns:a16="http://schemas.microsoft.com/office/drawing/2014/main" id="{E7B6F26D-A40F-5EFD-26FD-41AEE2158D59}"/>
               </a:ext>
             </a:extLst>
           </p:cNvPr>
@@ -6424,7 +6424,7 @@
           <p:cNvPr id="10" name="TextBox 9">
             <a:extLst>
               <a:ext uri="{FF2B5EF4-FFF2-40B4-BE49-F238E27FC236}">
-                <a16:creationId xmlns:a16="http://schemas.microsoft.com/office/drawing/2014/main" id="{CB2E48E0-611E-35A2-E4EF-8CE3CB42D676}"/>
+                <a16:creationId xmlns:a16="http://schemas.microsoft.com/office/drawing/2014/main" id="{D789C5C4-7BF5-78F3-8F2A-CC304ABBCB05}"/>
               </a:ext>
             </a:extLst>
           </p:cNvPr>
@@ -6464,7 +6464,7 @@
           <p:cNvPr id="11" name="TextBox 10">
             <a:extLst>
               <a:ext uri="{FF2B5EF4-FFF2-40B4-BE49-F238E27FC236}">
-                <a16:creationId xmlns:a16="http://schemas.microsoft.com/office/drawing/2014/main" id="{B8C5BB1F-5B07-50CB-0328-DFDFD1BA8A4C}"/>
+                <a16:creationId xmlns:a16="http://schemas.microsoft.com/office/drawing/2014/main" id="{8303D4EA-DF00-2563-A26F-0926BC023B22}"/>
               </a:ext>
             </a:extLst>
           </p:cNvPr>
@@ -6510,7 +6510,7 @@
           <p:cNvPr id="12" name="TextBox 11">
             <a:extLst>
               <a:ext uri="{FF2B5EF4-FFF2-40B4-BE49-F238E27FC236}">
-                <a16:creationId xmlns:a16="http://schemas.microsoft.com/office/drawing/2014/main" id="{0748E9FE-D3C2-B1F0-2574-6222953F42C0}"/>
+                <a16:creationId xmlns:a16="http://schemas.microsoft.com/office/drawing/2014/main" id="{DBE8E336-FC85-78CC-EE62-27A1A8D258D6}"/>
               </a:ext>
             </a:extLst>
           </p:cNvPr>
@@ -6556,7 +6556,7 @@
           <p:cNvPr id="13" name="Rectangle 12">
             <a:extLst>
               <a:ext uri="{FF2B5EF4-FFF2-40B4-BE49-F238E27FC236}">
-                <a16:creationId xmlns:a16="http://schemas.microsoft.com/office/drawing/2014/main" id="{1AB0EE42-99AC-1B48-AF49-E2DBD97A1006}"/>
+                <a16:creationId xmlns:a16="http://schemas.microsoft.com/office/drawing/2014/main" id="{CB0FF9C7-55BD-71C3-B7F5-D601A4EC32D7}"/>
               </a:ext>
             </a:extLst>
           </p:cNvPr>
@@ -6624,7 +6624,7 @@
           <p:cNvPr id="14" name="TextBox 13">
             <a:extLst>
               <a:ext uri="{FF2B5EF4-FFF2-40B4-BE49-F238E27FC236}">
-                <a16:creationId xmlns:a16="http://schemas.microsoft.com/office/drawing/2014/main" id="{8D14BFA3-67DB-584F-7370-2E1E04BA619F}"/>
+                <a16:creationId xmlns:a16="http://schemas.microsoft.com/office/drawing/2014/main" id="{12429D2F-1580-F7F0-D728-20F743C988CB}"/>
               </a:ext>
             </a:extLst>
           </p:cNvPr>
@@ -6670,7 +6670,7 @@
           <p:cNvPr id="15" name="TextBox 14">
             <a:extLst>
               <a:ext uri="{FF2B5EF4-FFF2-40B4-BE49-F238E27FC236}">
-                <a16:creationId xmlns:a16="http://schemas.microsoft.com/office/drawing/2014/main" id="{5C4D4ADC-73B9-C892-868E-C761514F0F70}"/>
+                <a16:creationId xmlns:a16="http://schemas.microsoft.com/office/drawing/2014/main" id="{8E80539B-95BA-60A3-3016-D502AFBB96F7}"/>
               </a:ext>
             </a:extLst>
           </p:cNvPr>
@@ -6716,7 +6716,7 @@
           <p:cNvPr id="16" name="TextBox 15">
             <a:extLst>
               <a:ext uri="{FF2B5EF4-FFF2-40B4-BE49-F238E27FC236}">
-                <a16:creationId xmlns:a16="http://schemas.microsoft.com/office/drawing/2014/main" id="{CB7C9051-2DAB-0B87-264F-EEC476338184}"/>
+                <a16:creationId xmlns:a16="http://schemas.microsoft.com/office/drawing/2014/main" id="{FD99391C-D5E5-CF93-9375-F452BCC8A7F1}"/>
               </a:ext>
             </a:extLst>
           </p:cNvPr>
@@ -6762,7 +6762,7 @@
           <p:cNvPr id="17" name="TextBox 16">
             <a:extLst>
               <a:ext uri="{FF2B5EF4-FFF2-40B4-BE49-F238E27FC236}">
-                <a16:creationId xmlns:a16="http://schemas.microsoft.com/office/drawing/2014/main" id="{2AB56694-479B-2744-C634-849787BFB19B}"/>
+                <a16:creationId xmlns:a16="http://schemas.microsoft.com/office/drawing/2014/main" id="{186B9F21-B851-64BC-DF86-7AE721597DCC}"/>
               </a:ext>
             </a:extLst>
           </p:cNvPr>
@@ -6808,7 +6808,7 @@
           <p:cNvPr id="18" name="TextBox 17">
             <a:extLst>
               <a:ext uri="{FF2B5EF4-FFF2-40B4-BE49-F238E27FC236}">
-                <a16:creationId xmlns:a16="http://schemas.microsoft.com/office/drawing/2014/main" id="{52AEE2E3-48AC-120E-95B0-9E6DAE3E6547}"/>
+                <a16:creationId xmlns:a16="http://schemas.microsoft.com/office/drawing/2014/main" id="{CFE99B41-8E11-1591-F161-708B547B3EAB}"/>
               </a:ext>
             </a:extLst>
           </p:cNvPr>
@@ -6854,7 +6854,7 @@
           <p:cNvPr id="19" name="TextBox 18">
             <a:extLst>
               <a:ext uri="{FF2B5EF4-FFF2-40B4-BE49-F238E27FC236}">
-                <a16:creationId xmlns:a16="http://schemas.microsoft.com/office/drawing/2014/main" id="{06F2DB36-FE68-D488-186B-DC0756F05DF3}"/>
+                <a16:creationId xmlns:a16="http://schemas.microsoft.com/office/drawing/2014/main" id="{CF848C7B-EF66-4F6D-A77A-210A965DC228}"/>
               </a:ext>
             </a:extLst>
           </p:cNvPr>
@@ -6900,7 +6900,7 @@
           <p:cNvPr id="20" name="TextBox 19">
             <a:extLst>
               <a:ext uri="{FF2B5EF4-FFF2-40B4-BE49-F238E27FC236}">
-                <a16:creationId xmlns:a16="http://schemas.microsoft.com/office/drawing/2014/main" id="{440FB0B1-488D-790B-E51F-2DDBA1432F2B}"/>
+                <a16:creationId xmlns:a16="http://schemas.microsoft.com/office/drawing/2014/main" id="{66E596A7-57B6-DB49-5B6D-3A8B64E394FD}"/>
               </a:ext>
             </a:extLst>
           </p:cNvPr>
@@ -6946,7 +6946,7 @@
           <p:cNvPr id="21" name="TextBox 20">
             <a:extLst>
               <a:ext uri="{FF2B5EF4-FFF2-40B4-BE49-F238E27FC236}">
-                <a16:creationId xmlns:a16="http://schemas.microsoft.com/office/drawing/2014/main" id="{F0308EEC-A508-DE6F-0B1E-2EF831C31C17}"/>
+                <a16:creationId xmlns:a16="http://schemas.microsoft.com/office/drawing/2014/main" id="{5FF2A486-46A4-87D4-0394-BD9CC5F5CE5A}"/>
               </a:ext>
             </a:extLst>
           </p:cNvPr>
@@ -6985,7 +6985,7 @@
     </p:spTree>
     <p:extLst>
       <p:ext uri="{BB962C8B-B14F-4D97-AF65-F5344CB8AC3E}">
-        <p14:creationId xmlns:p14="http://schemas.microsoft.com/office/powerpoint/2010/main" val="3347263254"/>
+        <p14:creationId xmlns:p14="http://schemas.microsoft.com/office/powerpoint/2010/main" val="133880189"/>
       </p:ext>
     </p:extLst>
   </p:cSld>

</xml_diff>